<commit_message>
feat: add minimalist DEMO transition slide and refine conclusion slide (15 slides total)
</commit_message>
<xml_diff>
--- a/Bao_Cao_Giua_Ky_DT05_Final.pptx
+++ b/Bao_Cao_Giua_Ky_DT05_Final.pptx
@@ -19,6 +19,7 @@
     <p:sldId id="267" r:id="rId18"/>
     <p:sldId id="268" r:id="rId19"/>
     <p:sldId id="269" r:id="rId20"/>
+    <p:sldId id="270" r:id="rId21"/>
   </p:sldIdLst>
   <p:sldSz cx="12191695" cy="6858000" type="screen4x3"/>
   <p:notesSz cx="6858000" cy="9144000"/>
@@ -5642,7 +5643,7 @@
             <a:avLst/>
           </a:prstGeom>
           <a:solidFill>
-            <a:srgbClr val="FFFFFF"/>
+            <a:srgbClr val="0F172A"/>
           </a:solidFill>
           <a:ln>
             <a:noFill/>
@@ -5672,183 +5673,14 @@
       </p:sp>
       <p:sp>
         <p:nvSpPr>
-          <p:cNvPr id="3" name="Rounded Rectangle 2"/>
-          <p:cNvSpPr/>
-          <p:nvPr/>
-        </p:nvSpPr>
-        <p:spPr>
-          <a:xfrm>
-            <a:off x="731520" y="365760"/>
-            <a:ext cx="4114800" cy="320040"/>
-          </a:xfrm>
-          <a:prstGeom prst="roundRect">
-            <a:avLst/>
-          </a:prstGeom>
-          <a:solidFill>
-            <a:srgbClr val="EFF6FF"/>
-          </a:solidFill>
-          <a:ln w="12700">
-            <a:solidFill>
-              <a:srgbClr val="BFDBFE"/>
-            </a:solidFill>
-          </a:ln>
-        </p:spPr>
-        <p:style>
-          <a:lnRef idx="1">
-            <a:schemeClr val="accent1"/>
-          </a:lnRef>
-          <a:fillRef idx="3">
-            <a:schemeClr val="accent1"/>
-          </a:fillRef>
-          <a:effectRef idx="2">
-            <a:schemeClr val="accent1"/>
-          </a:effectRef>
-          <a:fontRef idx="minor">
-            <a:schemeClr val="lt1"/>
-          </a:fontRef>
-        </p:style>
-        <p:txBody>
-          <a:bodyPr rtlCol="0" anchor="ctr" wrap="square"/>
-          <a:lstStyle/>
-          <a:p>
-            <a:pPr algn="ctr">
-              <a:defRPr sz="1000" b="1">
-                <a:solidFill>
-                  <a:srgbClr val="1D4ED8"/>
-                </a:solidFill>
-              </a:defRPr>
-            </a:pPr>
-            <a:r>
-              <a:t>THÍ NGHIỆM MINH HỌA ĐỘC LẬP DO SINH VIÊN THIẾT KẾ</a:t>
-            </a:r>
-          </a:p>
-        </p:txBody>
-      </p:sp>
-      <p:sp>
-        <p:nvSpPr>
-          <p:cNvPr id="4" name="TextBox 3"/>
+          <p:cNvPr id="3" name="TextBox 2"/>
           <p:cNvSpPr txBox="1"/>
           <p:nvPr/>
         </p:nvSpPr>
         <p:spPr>
           <a:xfrm>
-            <a:off x="731520" y="749808"/>
-            <a:ext cx="10698480" cy="502920"/>
-          </a:xfrm>
-          <a:prstGeom prst="rect">
-            <a:avLst/>
-          </a:prstGeom>
-          <a:noFill/>
-        </p:spPr>
-        <p:txBody>
-          <a:bodyPr wrap="square" lIns="0" rIns="0" tIns="0" bIns="0">
-            <a:spAutoFit/>
-          </a:bodyPr>
-          <a:lstStyle/>
-          <a:p>
-            <a:pPr>
-              <a:defRPr sz="2100" b="1">
-                <a:solidFill>
-                  <a:srgbClr val="0F172A"/>
-                </a:solidFill>
-              </a:defRPr>
-            </a:pPr>
-            <a:r>
-              <a:t>DEMO THỰC NGHIỆM ĐỐI KHÁNG: RED TEAM VS BLUE TEAM</a:t>
-            </a:r>
-          </a:p>
-        </p:txBody>
-      </p:sp>
-      <p:sp>
-        <p:nvSpPr>
-          <p:cNvPr id="5" name="TextBox 4"/>
-          <p:cNvSpPr txBox="1"/>
-          <p:nvPr/>
-        </p:nvSpPr>
-        <p:spPr>
-          <a:xfrm>
-            <a:off x="731520" y="1261872"/>
-            <a:ext cx="10698480" cy="320040"/>
-          </a:xfrm>
-          <a:prstGeom prst="rect">
-            <a:avLst/>
-          </a:prstGeom>
-          <a:noFill/>
-        </p:spPr>
-        <p:txBody>
-          <a:bodyPr wrap="square" lIns="0" rIns="0" tIns="0" bIns="0">
-            <a:spAutoFit/>
-          </a:bodyPr>
-          <a:lstStyle/>
-          <a:p>
-            <a:pPr>
-              <a:defRPr sz="1200">
-                <a:solidFill>
-                  <a:srgbClr val="475569"/>
-                </a:solidFill>
-              </a:defRPr>
-            </a:pPr>
-            <a:r>
-              <a:t>Diễn tập an ninh mạng trực quan minh họa các luận điểm đối thủ trên tập dữ liệu thực tế</a:t>
-            </a:r>
-          </a:p>
-        </p:txBody>
-      </p:sp>
-      <p:sp>
-        <p:nvSpPr>
-          <p:cNvPr id="6" name="Rounded Rectangle 5"/>
-          <p:cNvSpPr/>
-          <p:nvPr/>
-        </p:nvSpPr>
-        <p:spPr>
-          <a:xfrm>
-            <a:off x="731520" y="1691640"/>
-            <a:ext cx="5212080" cy="4389120"/>
-          </a:xfrm>
-          <a:prstGeom prst="roundRect">
-            <a:avLst/>
-          </a:prstGeom>
-          <a:solidFill>
-            <a:srgbClr val="F8FAFC"/>
-          </a:solidFill>
-          <a:ln w="12700">
-            <a:solidFill>
-              <a:srgbClr val="BFDBFE"/>
-            </a:solidFill>
-          </a:ln>
-        </p:spPr>
-        <p:style>
-          <a:lnRef idx="1">
-            <a:schemeClr val="accent1"/>
-          </a:lnRef>
-          <a:fillRef idx="3">
-            <a:schemeClr val="accent1"/>
-          </a:fillRef>
-          <a:effectRef idx="2">
-            <a:schemeClr val="accent1"/>
-          </a:effectRef>
-          <a:fontRef idx="minor">
-            <a:schemeClr val="lt1"/>
-          </a:fontRef>
-        </p:style>
-        <p:txBody>
-          <a:bodyPr rtlCol="0" anchor="ctr"/>
-          <a:lstStyle/>
-          <a:p>
-            <a:pPr algn="ctr"/>
-          </a:p>
-        </p:txBody>
-      </p:sp>
-      <p:sp>
-        <p:nvSpPr>
-          <p:cNvPr id="7" name="TextBox 6"/>
-          <p:cNvSpPr txBox="1"/>
-          <p:nvPr/>
-        </p:nvSpPr>
-        <p:spPr>
-          <a:xfrm>
-            <a:off x="914400" y="1828800"/>
-            <a:ext cx="4846320" cy="4114800"/>
+            <a:off x="1371600" y="2011680"/>
+            <a:ext cx="9448495" cy="2743200"/>
           </a:xfrm>
           <a:prstGeom prst="rect">
             <a:avLst/>
@@ -5861,359 +5693,60 @@
           </a:bodyPr>
           <a:lstStyle/>
           <a:p>
-            <a:pPr>
+            <a:pPr algn="ctr">
               <a:defRPr sz="1300" b="1">
                 <a:solidFill>
-                  <a:srgbClr val="1E40AF"/>
-                </a:solidFill>
-              </a:defRPr>
-            </a:pPr>
-            <a:r>
-              <a:t>1. Kiến Trúc Diễn Tập Đối Kháng Trực Quan</a:t>
-            </a:r>
-          </a:p>
-          <a:p>
-            <a:pPr>
+                  <a:srgbClr val="38BDF8"/>
+                </a:solidFill>
+              </a:defRPr>
+            </a:pPr>
+            <a:r>
+              <a:t>DIỄN TẬP AN NINH MẠNG TRỰC TIẾP</a:t>
+            </a:r>
+          </a:p>
+          <a:p>
+            <a:pPr algn="ctr">
               <a:spcBef>
-                <a:spcPts val="600"/>
+                <a:spcPts val="1600"/>
               </a:spcBef>
-              <a:defRPr sz="950">
-                <a:solidFill>
-                  <a:srgbClr val="1E293B"/>
-                </a:solidFill>
-                <a:latin typeface="Consolas"/>
-              </a:defRPr>
-            </a:pPr>
-            <a:r>
-              <a:t>[BLUE TEAM - Cổng 8080]        [RED TEAM - Cổng 8081]</a:t>
-            </a:r>
-            <a:br/>
-            <a:r>
-              <a:t>- Giám sát kaggle_dataset (2.483 tệp)  - 6 Vector tấn công đối kháng</a:t>
-            </a:r>
-            <a:br/>
-            <a:r>
-              <a:t>- Quét mốc tin cậy ban đầu H_0         - Sửa tệp, CRC32, Dolev-Yao</a:t>
-            </a:r>
-            <a:br/>
-            <a:r>
-              <a:t>- Phát hiện sai lệch &amp; Dirty Path     - Phục hồi an toàn (Rollback)</a:t>
-            </a:r>
-          </a:p>
-          <a:p>
-            <a:pPr>
+              <a:defRPr sz="6400" b="1">
+                <a:solidFill>
+                  <a:srgbClr val="FFFFFF"/>
+                </a:solidFill>
+              </a:defRPr>
+            </a:pPr>
+            <a:r>
+              <a:t>DEMO</a:t>
+            </a:r>
+          </a:p>
+          <a:p>
+            <a:pPr algn="ctr">
               <a:spcBef>
-                <a:spcPts val="500"/>
+                <a:spcPts val="1600"/>
               </a:spcBef>
-            </a:pPr>
-            <a:r>
-              <a:rPr b="1" sz="1050">
-                <a:solidFill>
-                  <a:srgbClr val="1E293B"/>
-                </a:solidFill>
-              </a:rPr>
-              <a:t>• Kịch bản 1 (CRC32 Forge): </a:t>
-            </a:r>
-            <a:r>
-              <a:rPr sz="1000">
-                <a:solidFill>
-                  <a:srgbClr val="475569"/>
-                </a:solidFill>
-              </a:rPr>
-              <a:t>Red Team sửa giao dịch, bù 4 byte GF(2) qua mặt CRC32; Blue Team dùng SHA-256 bắt quả tang tức thì.</a:t>
-            </a:r>
-          </a:p>
-          <a:p>
-            <a:pPr>
+              <a:defRPr sz="1500" b="1">
+                <a:solidFill>
+                  <a:srgbClr val="E2E8F0"/>
+                </a:solidFill>
+              </a:defRPr>
+            </a:pPr>
+            <a:r>
+              <a:t>HỆ THỐNG GIÁM SÁT TOÀN VẸN TỆP &amp; MÔ HÌNH ĐỐI KHÁNG RED TEAM VS BLUE TEAM</a:t>
+            </a:r>
+          </a:p>
+          <a:p>
+            <a:pPr algn="ctr">
               <a:spcBef>
-                <a:spcPts val="500"/>
+                <a:spcPts val="800"/>
               </a:spcBef>
-            </a:pPr>
-            <a:r>
-              <a:rPr b="1" sz="1050">
-                <a:solidFill>
-                  <a:srgbClr val="1E293B"/>
-                </a:solidFill>
-              </a:rPr>
-              <a:t>• Kịch bản 2 (In-place Tamper): </a:t>
-            </a:r>
-            <a:r>
-              <a:rPr sz="1000">
-                <a:solidFill>
-                  <a:srgbClr val="475569"/>
-                </a:solidFill>
-              </a:rPr>
-              <a:t>Sửa nội dung tệp; Blue Team phát hiện FILE_MODIFIED và định vị chính xác qua Dirty Path O(log N).</a:t>
-            </a:r>
-          </a:p>
-          <a:p>
-            <a:pPr>
-              <a:spcBef>
-                <a:spcPts val="500"/>
-              </a:spcBef>
-            </a:pPr>
-            <a:r>
-              <a:rPr b="1" sz="1050">
-                <a:solidFill>
-                  <a:srgbClr val="1E293B"/>
-                </a:solidFill>
-              </a:rPr>
-              <a:t>• Kịch bản 3 (Dolev-Yao MitM): </a:t>
-            </a:r>
-            <a:r>
-              <a:rPr sz="1000">
-                <a:solidFill>
-                  <a:srgbClr val="475569"/>
-                </a:solidFill>
-              </a:rPr>
-              <a:t>Đánh tráo Merkle Proof trên đường truyền mạng; bộ xác thực từ chối 100% chữ ký bằng chứng.</a:t>
-            </a:r>
-          </a:p>
-          <a:p>
-            <a:pPr>
-              <a:spcBef>
-                <a:spcPts val="500"/>
-              </a:spcBef>
-            </a:pPr>
-            <a:r>
-              <a:rPr b="1" sz="1050">
-                <a:solidFill>
-                  <a:srgbClr val="1E293B"/>
-                </a:solidFill>
-              </a:rPr>
-              <a:t>• Khôi phục an toàn (Rollback): </a:t>
-            </a:r>
-            <a:r>
-              <a:rPr sz="1000">
-                <a:solidFill>
-                  <a:srgbClr val="475569"/>
-                </a:solidFill>
-              </a:rPr>
-              <a:t>Nút 'ROLLBACK ALL' phục hồi 100% nguyên trạng từ thư mục an toàn .adversary_backups/.</a:t>
-            </a:r>
-          </a:p>
-        </p:txBody>
-      </p:sp>
-      <p:sp>
-        <p:nvSpPr>
-          <p:cNvPr id="8" name="Rounded Rectangle 7"/>
-          <p:cNvSpPr/>
-          <p:nvPr/>
-        </p:nvSpPr>
-        <p:spPr>
-          <a:xfrm>
-            <a:off x="6217920" y="1691640"/>
-            <a:ext cx="5212080" cy="4389120"/>
-          </a:xfrm>
-          <a:prstGeom prst="roundRect">
-            <a:avLst/>
-          </a:prstGeom>
-          <a:solidFill>
-            <a:srgbClr val="ECFDF5"/>
-          </a:solidFill>
-          <a:ln w="12700">
-            <a:solidFill>
-              <a:srgbClr val="A7F3D0"/>
-            </a:solidFill>
-          </a:ln>
-        </p:spPr>
-        <p:style>
-          <a:lnRef idx="1">
-            <a:schemeClr val="accent1"/>
-          </a:lnRef>
-          <a:fillRef idx="3">
-            <a:schemeClr val="accent1"/>
-          </a:fillRef>
-          <a:effectRef idx="2">
-            <a:schemeClr val="accent1"/>
-          </a:effectRef>
-          <a:fontRef idx="minor">
-            <a:schemeClr val="lt1"/>
-          </a:fontRef>
-        </p:style>
-        <p:txBody>
-          <a:bodyPr rtlCol="0" anchor="ctr"/>
-          <a:lstStyle/>
-          <a:p>
-            <a:pPr algn="ctr"/>
-          </a:p>
-        </p:txBody>
-      </p:sp>
-      <p:sp>
-        <p:nvSpPr>
-          <p:cNvPr id="9" name="TextBox 8"/>
-          <p:cNvSpPr txBox="1"/>
-          <p:nvPr/>
-        </p:nvSpPr>
-        <p:spPr>
-          <a:xfrm>
-            <a:off x="6400800" y="1828800"/>
-            <a:ext cx="4846320" cy="4114800"/>
-          </a:xfrm>
-          <a:prstGeom prst="rect">
-            <a:avLst/>
-          </a:prstGeom>
-          <a:noFill/>
-        </p:spPr>
-        <p:txBody>
-          <a:bodyPr wrap="square">
-            <a:spAutoFit/>
-          </a:bodyPr>
-          <a:lstStyle/>
-          <a:p>
-            <a:pPr>
-              <a:defRPr sz="1300" b="1">
-                <a:solidFill>
-                  <a:srgbClr val="059669"/>
-                </a:solidFill>
-              </a:defRPr>
-            </a:pPr>
-            <a:r>
-              <a:t>2. Bằng Chứng Chạy Thật &amp; Giới Hạn Thực Nghiệm</a:t>
-            </a:r>
-          </a:p>
-          <a:p>
-            <a:pPr>
-              <a:spcBef>
-                <a:spcPts val="600"/>
-              </a:spcBef>
-              <a:defRPr sz="900">
-                <a:solidFill>
-                  <a:srgbClr val="0F172A"/>
-                </a:solidFill>
-                <a:latin typeface="Consolas"/>
-              </a:defRPr>
-            </a:pPr>
-            <a:r>
-              <a:t>[LOG THỰC TẾ: python -m src.proposed_model.security_games]</a:t>
-            </a:r>
-            <a:br/>
-            <a:r>
-              <a:t>[*] Thư mục kiểm định : kaggle_dataset (2,483 tệp tin)</a:t>
-            </a:r>
-            <a:br/>
-            <a:r>
-              <a:t>[*] PPT Integrity Game: Phát hiện 100/100 phép thử (Tỷ lệ = 0.0)</a:t>
-            </a:r>
-            <a:br/>
-            <a:r>
-              <a:t>[*] Dolev-Yao Network : Chặn đứng 3/3 kịch bản (Swap, Tamper, Replay)</a:t>
-            </a:r>
-            <a:br/>
-            <a:r>
-              <a:t>[*] Consistency Proof : Xác thực nhất quán chỉ-thêm RFC 6962</a:t>
-            </a:r>
-            <a:br/>
-            <a:r>
-              <a:t>[*] Tuyết lở SAC Monte Carlo: 127.28/256 bit biến đổi (~49.72%)</a:t>
-            </a:r>
-            <a:br/>
-            <a:r>
-              <a:t>[*] Thời gian tổng cộng: 2,885.53 ms (Đạt chuẩn 7/7 thí nghiệm)</a:t>
-            </a:r>
-          </a:p>
-          <a:p>
-            <a:pPr>
-              <a:spcBef>
-                <a:spcPts val="500"/>
-              </a:spcBef>
-            </a:pPr>
-            <a:r>
-              <a:rPr b="1" sz="1050">
-                <a:solidFill>
-                  <a:srgbClr val="1E293B"/>
-                </a:solidFill>
-              </a:rPr>
-              <a:t>• Bản chất minh họa: </a:t>
-            </a:r>
-            <a:r>
-              <a:rPr sz="1000">
-                <a:solidFill>
-                  <a:srgbClr val="475569"/>
-                </a:solidFill>
-              </a:rPr>
-              <a:t>Thực nghiệm được thiết kế độc lập nhằm kiểm chứng tính đúng đắn logic của các khái niệm; không phải là việc chạy lại số liệu của tác giả.</a:t>
-            </a:r>
-          </a:p>
-          <a:p>
-            <a:pPr>
-              <a:spcBef>
-                <a:spcPts val="500"/>
-              </a:spcBef>
-            </a:pPr>
-            <a:r>
-              <a:rPr b="1" sz="1050">
-                <a:solidFill>
-                  <a:srgbClr val="1E293B"/>
-                </a:solidFill>
-              </a:rPr>
-              <a:t>• Môi trường kiểm thử: </a:t>
-            </a:r>
-            <a:r>
-              <a:rPr sz="1000">
-                <a:solidFill>
-                  <a:srgbClr val="475569"/>
-                </a:solidFill>
-              </a:rPr>
-              <a:t>Đo đạc trên máy tính cá nhân (Intel Core i7, Windows 11). Các phép đo thời gian vi mô chịu ảnh hưởng của jitter hệ điều hành.</a:t>
-            </a:r>
-          </a:p>
-          <a:p>
-            <a:pPr>
-              <a:spcBef>
-                <a:spcPts val="500"/>
-              </a:spcBef>
-            </a:pPr>
-            <a:r>
-              <a:rPr b="1" sz="1050">
-                <a:solidFill>
-                  <a:srgbClr val="1E293B"/>
-                </a:solidFill>
-              </a:rPr>
-              <a:t>• Hướng dẫn chạy: </a:t>
-            </a:r>
-            <a:r>
-              <a:rPr sz="1000">
-                <a:solidFill>
-                  <a:srgbClr val="475569"/>
-                </a:solidFill>
-              </a:rPr>
-              <a:t>Chi tiết lệnh chạy và các bước thao tác màn hình kép được hướng dẫn trong file MIDTERM_DEMO.md.</a:t>
-            </a:r>
-          </a:p>
-        </p:txBody>
-      </p:sp>
-      <p:sp>
-        <p:nvSpPr>
-          <p:cNvPr id="10" name="TextBox 9"/>
-          <p:cNvSpPr txBox="1"/>
-          <p:nvPr/>
-        </p:nvSpPr>
-        <p:spPr>
-          <a:xfrm>
-            <a:off x="731520" y="6217920"/>
-            <a:ext cx="10698480" cy="365760"/>
-          </a:xfrm>
-          <a:prstGeom prst="rect">
-            <a:avLst/>
-          </a:prstGeom>
-          <a:noFill/>
-        </p:spPr>
-        <p:txBody>
-          <a:bodyPr wrap="none">
-            <a:spAutoFit/>
-          </a:bodyPr>
-          <a:lstStyle/>
-          <a:p>
-            <a:pPr>
-              <a:defRPr sz="1000" i="1">
-                <a:solidFill>
-                  <a:srgbClr val="64748B"/>
-                </a:solidFill>
-              </a:defRPr>
-            </a:pPr>
-            <a:r>
-              <a:t>Số liệu thực tế đo đạc trực tiếp từ mã nguồn đề tài DT005; xem hướng dẫn chạy tại MIDTERM_DEMO.md.</a:t>
+              <a:defRPr sz="1100" i="1">
+                <a:solidFill>
+                  <a:srgbClr val="94A3B8"/>
+                </a:solidFill>
+              </a:defRPr>
+            </a:pPr>
+            <a:r>
+              <a:t>Minh họa thực nghiệm các luận điểm lý thuyết: Can thiệp dữ liệu, Nhập nhằng nút lá RFC 6962, và So sánh chuỗi thời gian hằng số</a:t>
             </a:r>
           </a:p>
         </p:txBody>
@@ -6328,7 +5861,7 @@
               </a:defRPr>
             </a:pPr>
             <a:r>
-              <a:t>SECTION 7 — KẾT LUẬN &amp; NGUỒN THAM CHIẾU HỌC THUẬT</a:t>
+              <a:t>THÍ NGHIỆM MINH HỌA ĐỘC LẬP DO SINH VIÊN THIẾT KẾ</a:t>
             </a:r>
           </a:p>
         </p:txBody>
@@ -6363,7 +5896,7 @@
               </a:defRPr>
             </a:pPr>
             <a:r>
-              <a:t>TỔNG KẾT BÁO CÁO GIỮA KỲ &amp; TÀI LIỆU THAM KHẢO</a:t>
+              <a:t>KẾT QUẢ THỰC NGHIỆM MINH HỌA ĐỘC LẬP: RED TEAM VS BLUE TEAM</a:t>
             </a:r>
           </a:p>
         </p:txBody>
@@ -6398,7 +5931,7 @@
               </a:defRPr>
             </a:pPr>
             <a:r>
-              <a:t>Tổng kết các luận điểm chính của Halpin, bài học thiết kế an ninh và danh mục tài liệu</a:t>
+              <a:t>Diễn tập an ninh mạng trực quan minh họa các luận điểm đối thủ trên tập dữ liệu thực tế</a:t>
             </a:r>
           </a:p>
         </p:txBody>
@@ -6478,76 +6011,127 @@
               </a:defRPr>
             </a:pPr>
             <a:r>
-              <a:t>1. Tổng Kết Thông Điệp Học Thuật Của Bài Báo</a:t>
+              <a:t>1. Kiến Trúc Diễn Tập Đối Kháng Trực Quan</a:t>
             </a:r>
           </a:p>
           <a:p>
             <a:pPr>
               <a:spcBef>
-                <a:spcPts val="800"/>
+                <a:spcPts val="600"/>
               </a:spcBef>
-            </a:pPr>
-            <a:r>
-              <a:rPr b="1" sz="1100">
+              <a:defRPr sz="950">
                 <a:solidFill>
                   <a:srgbClr val="1E293B"/>
                 </a:solidFill>
-              </a:rPr>
-              <a:t>• Bài học từ Halpin: </a:t>
-            </a:r>
-            <a:r>
-              <a:rPr sz="1050">
+                <a:latin typeface="Consolas"/>
+              </a:defRPr>
+            </a:pPr>
+            <a:r>
+              <a:t>[BLUE TEAM - Cổng 8080]        [RED TEAM - Cổng 8081]</a:t>
+            </a:r>
+            <a:br/>
+            <a:r>
+              <a:t>- Giám sát kaggle_dataset (2.483 tệp)  - 6 Vector tấn công đối kháng</a:t>
+            </a:r>
+            <a:br/>
+            <a:r>
+              <a:t>- Quét mốc tin cậy ban đầu H_0         - Sửa tệp, CRC32, Dolev-Yao</a:t>
+            </a:r>
+            <a:br/>
+            <a:r>
+              <a:t>- Phát hiện sai lệch &amp; Dirty Path     - Phục hồi an toàn (Rollback)</a:t>
+            </a:r>
+          </a:p>
+          <a:p>
+            <a:pPr>
+              <a:spcBef>
+                <a:spcPts val="500"/>
+              </a:spcBef>
+            </a:pPr>
+            <a:r>
+              <a:rPr b="1" sz="1050">
+                <a:solidFill>
+                  <a:srgbClr val="1E293B"/>
+                </a:solidFill>
+              </a:rPr>
+              <a:t>• Kịch bản 1 (CRC32 Forge): </a:t>
+            </a:r>
+            <a:r>
+              <a:rPr sz="1000">
                 <a:solidFill>
                   <a:srgbClr val="475569"/>
                 </a:solidFill>
               </a:rPr>
-              <a:t>Mật mã học không chỉ là toán học thuần túy trên giấy tờ. Các hệ thống an toàn trong thế giới thực phải nhận thức rõ khoảng cách giữa mô hình trừu tượng và thực tế triển khai (kênh kề, siêu dữ liệu, chuỗi cung ứng, thể chế).</a:t>
+              <a:t>Red Team sửa giao dịch, bù 4 byte GF(2) qua mặt CRC32; Blue Team dùng SHA-256 bắt quả tang tức thì.</a:t>
             </a:r>
           </a:p>
           <a:p>
             <a:pPr>
               <a:spcBef>
-                <a:spcPts val="800"/>
+                <a:spcPts val="500"/>
               </a:spcBef>
             </a:pPr>
             <a:r>
-              <a:rPr b="1" sz="1100">
+              <a:rPr b="1" sz="1050">
                 <a:solidFill>
                   <a:srgbClr val="1E293B"/>
                 </a:solidFill>
               </a:rPr>
-              <a:t>• Đóng góp của Halpin: </a:t>
-            </a:r>
-            <a:r>
-              <a:rPr sz="1050">
+              <a:t>• Kịch bản 2 (In-place Tamper): </a:t>
+            </a:r>
+            <a:r>
+              <a:rPr sz="1000">
                 <a:solidFill>
                   <a:srgbClr val="475569"/>
                 </a:solidFill>
               </a:rPr>
-              <a:t>Đặt nền móng triết học cho mật mã học, phân tích nhận thức luận về kẻ thù và vạch ra 4 hướng nghiên cứu mở nhằm mở rộng mật mã thành một khoa học an ninh hoàn chỉnh.</a:t>
+              <a:t>Sửa nội dung tệp; Blue Team phát hiện FILE_MODIFIED và định vị chính xác qua Dirty Path O(log N).</a:t>
             </a:r>
           </a:p>
           <a:p>
             <a:pPr>
               <a:spcBef>
-                <a:spcPts val="800"/>
+                <a:spcPts val="500"/>
               </a:spcBef>
             </a:pPr>
             <a:r>
-              <a:rPr b="1" sz="1100">
+              <a:rPr b="1" sz="1050">
                 <a:solidFill>
                   <a:srgbClr val="1E293B"/>
                 </a:solidFill>
               </a:rPr>
-              <a:t>• Hoàn thành mục tiêu giữa kỳ: </a:t>
-            </a:r>
-            <a:r>
-              <a:rPr sz="1050">
+              <a:t>• Kịch bản 3 (Dolev-Yao MitM): </a:t>
+            </a:r>
+            <a:r>
+              <a:rPr sz="1000">
                 <a:solidFill>
                   <a:srgbClr val="475569"/>
                 </a:solidFill>
               </a:rPr>
-              <a:t>Nhóm sinh viên DT005 đã thẩm định học thuật sâu sắc toàn văn bài báo gốc (17 trang PDF) và xây dựng thành công bộ thí nghiệm minh họa thực nghiệm sống động phục vụ báo cáo hội đồng.</a:t>
+              <a:t>Đánh tráo Merkle Proof trên đường truyền mạng; bộ xác thực từ chối 100% chữ ký bằng chứng.</a:t>
+            </a:r>
+          </a:p>
+          <a:p>
+            <a:pPr>
+              <a:spcBef>
+                <a:spcPts val="500"/>
+              </a:spcBef>
+            </a:pPr>
+            <a:r>
+              <a:rPr b="1" sz="1050">
+                <a:solidFill>
+                  <a:srgbClr val="1E293B"/>
+                </a:solidFill>
+              </a:rPr>
+              <a:t>• Khôi phục an toàn (Rollback): </a:t>
+            </a:r>
+            <a:r>
+              <a:rPr sz="1000">
+                <a:solidFill>
+                  <a:srgbClr val="475569"/>
+                </a:solidFill>
+              </a:rPr>
+              <a:t>Nút 'ROLLBACK ALL' phục hồi 100% nguyên trạng từ thư mục an toàn .adversary_backups/.</a:t>
             </a:r>
           </a:p>
         </p:txBody>
@@ -6562,6 +6146,415 @@
           <a:xfrm>
             <a:off x="6217920" y="1691640"/>
             <a:ext cx="5212080" cy="4389120"/>
+          </a:xfrm>
+          <a:prstGeom prst="roundRect">
+            <a:avLst/>
+          </a:prstGeom>
+          <a:solidFill>
+            <a:srgbClr val="ECFDF5"/>
+          </a:solidFill>
+          <a:ln w="12700">
+            <a:solidFill>
+              <a:srgbClr val="A7F3D0"/>
+            </a:solidFill>
+          </a:ln>
+        </p:spPr>
+        <p:style>
+          <a:lnRef idx="1">
+            <a:schemeClr val="accent1"/>
+          </a:lnRef>
+          <a:fillRef idx="3">
+            <a:schemeClr val="accent1"/>
+          </a:fillRef>
+          <a:effectRef idx="2">
+            <a:schemeClr val="accent1"/>
+          </a:effectRef>
+          <a:fontRef idx="minor">
+            <a:schemeClr val="lt1"/>
+          </a:fontRef>
+        </p:style>
+        <p:txBody>
+          <a:bodyPr rtlCol="0" anchor="ctr"/>
+          <a:lstStyle/>
+          <a:p>
+            <a:pPr algn="ctr"/>
+          </a:p>
+        </p:txBody>
+      </p:sp>
+      <p:sp>
+        <p:nvSpPr>
+          <p:cNvPr id="9" name="TextBox 8"/>
+          <p:cNvSpPr txBox="1"/>
+          <p:nvPr/>
+        </p:nvSpPr>
+        <p:spPr>
+          <a:xfrm>
+            <a:off x="6400800" y="1828800"/>
+            <a:ext cx="4846320" cy="4114800"/>
+          </a:xfrm>
+          <a:prstGeom prst="rect">
+            <a:avLst/>
+          </a:prstGeom>
+          <a:noFill/>
+        </p:spPr>
+        <p:txBody>
+          <a:bodyPr wrap="square">
+            <a:spAutoFit/>
+          </a:bodyPr>
+          <a:lstStyle/>
+          <a:p>
+            <a:pPr>
+              <a:defRPr sz="1300" b="1">
+                <a:solidFill>
+                  <a:srgbClr val="059669"/>
+                </a:solidFill>
+              </a:defRPr>
+            </a:pPr>
+            <a:r>
+              <a:t>2. Bằng Chứng Chạy Thật &amp; Giới Hạn Thực Nghiệm</a:t>
+            </a:r>
+          </a:p>
+          <a:p>
+            <a:pPr>
+              <a:spcBef>
+                <a:spcPts val="600"/>
+              </a:spcBef>
+              <a:defRPr sz="900">
+                <a:solidFill>
+                  <a:srgbClr val="0F172A"/>
+                </a:solidFill>
+                <a:latin typeface="Consolas"/>
+              </a:defRPr>
+            </a:pPr>
+            <a:r>
+              <a:t>[LOG THỰC TẾ: python -m src.proposed_model.security_games]</a:t>
+            </a:r>
+            <a:br/>
+            <a:r>
+              <a:t>[*] Thư mục kiểm định : kaggle_dataset (2,483 tệp tin)</a:t>
+            </a:r>
+            <a:br/>
+            <a:r>
+              <a:t>[*] PPT Integrity Game: Phát hiện 100/100 phép thử (Tỷ lệ = 0.0)</a:t>
+            </a:r>
+            <a:br/>
+            <a:r>
+              <a:t>[*] Dolev-Yao Network : Chặn đứng 3/3 kịch bản (Swap, Tamper, Replay)</a:t>
+            </a:r>
+            <a:br/>
+            <a:r>
+              <a:t>[*] Consistency Proof : Xác thực nhất quán chỉ-thêm RFC 6962</a:t>
+            </a:r>
+            <a:br/>
+            <a:r>
+              <a:t>[*] Tuyết lở SAC Monte Carlo: 128.00/256 bit biến đổi (~50.00%)</a:t>
+            </a:r>
+            <a:br/>
+            <a:r>
+              <a:t>[*] Thời gian tổng cộng: 2,885.05 ms (Đạt chuẩn 7/7 thí nghiệm)</a:t>
+            </a:r>
+          </a:p>
+          <a:p>
+            <a:pPr>
+              <a:spcBef>
+                <a:spcPts val="500"/>
+              </a:spcBef>
+            </a:pPr>
+            <a:r>
+              <a:rPr b="1" sz="1050">
+                <a:solidFill>
+                  <a:srgbClr val="1E293B"/>
+                </a:solidFill>
+              </a:rPr>
+              <a:t>• Bản chất minh họa: </a:t>
+            </a:r>
+            <a:r>
+              <a:rPr sz="1000">
+                <a:solidFill>
+                  <a:srgbClr val="475569"/>
+                </a:solidFill>
+              </a:rPr>
+              <a:t>Thực nghiệm được thiết kế độc lập nhằm kiểm chứng tính đúng đắn logic của các khái niệm; không phải là việc chạy lại số liệu của tác giả.</a:t>
+            </a:r>
+          </a:p>
+          <a:p>
+            <a:pPr>
+              <a:spcBef>
+                <a:spcPts val="500"/>
+              </a:spcBef>
+            </a:pPr>
+            <a:r>
+              <a:rPr b="1" sz="1050">
+                <a:solidFill>
+                  <a:srgbClr val="1E293B"/>
+                </a:solidFill>
+              </a:rPr>
+              <a:t>• Môi trường kiểm thử: </a:t>
+            </a:r>
+            <a:r>
+              <a:rPr sz="1000">
+                <a:solidFill>
+                  <a:srgbClr val="475569"/>
+                </a:solidFill>
+              </a:rPr>
+              <a:t>Đo đạc trên máy tính cá nhân (Intel Core i7, Windows 11). Các phép đo thời gian vi mô chịu ảnh hưởng của jitter hệ điều hành.</a:t>
+            </a:r>
+          </a:p>
+          <a:p>
+            <a:pPr>
+              <a:spcBef>
+                <a:spcPts val="500"/>
+              </a:spcBef>
+            </a:pPr>
+            <a:r>
+              <a:rPr b="1" sz="1050">
+                <a:solidFill>
+                  <a:srgbClr val="1E293B"/>
+                </a:solidFill>
+              </a:rPr>
+              <a:t>• Hướng dẫn chạy: </a:t>
+            </a:r>
+            <a:r>
+              <a:rPr sz="1000">
+                <a:solidFill>
+                  <a:srgbClr val="475569"/>
+                </a:solidFill>
+              </a:rPr>
+              <a:t>Chi tiết lệnh chạy và các bước thao tác màn hình kép được hướng dẫn trong file MIDTERM_DEMO.md.</a:t>
+            </a:r>
+          </a:p>
+        </p:txBody>
+      </p:sp>
+      <p:sp>
+        <p:nvSpPr>
+          <p:cNvPr id="10" name="TextBox 9"/>
+          <p:cNvSpPr txBox="1"/>
+          <p:nvPr/>
+        </p:nvSpPr>
+        <p:spPr>
+          <a:xfrm>
+            <a:off x="731520" y="6217920"/>
+            <a:ext cx="10698480" cy="365760"/>
+          </a:xfrm>
+          <a:prstGeom prst="rect">
+            <a:avLst/>
+          </a:prstGeom>
+          <a:noFill/>
+        </p:spPr>
+        <p:txBody>
+          <a:bodyPr wrap="none">
+            <a:spAutoFit/>
+          </a:bodyPr>
+          <a:lstStyle/>
+          <a:p>
+            <a:pPr>
+              <a:defRPr sz="1000" i="1">
+                <a:solidFill>
+                  <a:srgbClr val="64748B"/>
+                </a:solidFill>
+              </a:defRPr>
+            </a:pPr>
+            <a:r>
+              <a:t>Số liệu thực tế đo đạc trực tiếp từ mã nguồn đề tài DT005; xem hướng dẫn chạy tại MIDTERM_DEMO.md.</a:t>
+            </a:r>
+          </a:p>
+        </p:txBody>
+      </p:sp>
+    </p:spTree>
+  </p:cSld>
+  <p:clrMapOvr>
+    <a:masterClrMapping/>
+  </p:clrMapOvr>
+</p:sld>
+</file>
+
+<file path=ppt/slides/slide15.xml><?xml version="1.0" encoding="utf-8"?>
+<p:sld xmlns:a="http://schemas.openxmlformats.org/drawingml/2006/main" xmlns:p="http://schemas.openxmlformats.org/presentationml/2006/main" xmlns:r="http://schemas.openxmlformats.org/officeDocument/2006/relationships">
+  <p:cSld>
+    <p:spTree>
+      <p:nvGrpSpPr>
+        <p:cNvPr id="1" name=""/>
+        <p:cNvGrpSpPr/>
+        <p:nvPr/>
+      </p:nvGrpSpPr>
+      <p:grpSpPr/>
+      <p:sp>
+        <p:nvSpPr>
+          <p:cNvPr id="2" name="Rectangle 1"/>
+          <p:cNvSpPr/>
+          <p:nvPr/>
+        </p:nvSpPr>
+        <p:spPr>
+          <a:xfrm>
+            <a:off x="0" y="0"/>
+            <a:ext cx="12191695" cy="6858000"/>
+          </a:xfrm>
+          <a:prstGeom prst="rect">
+            <a:avLst/>
+          </a:prstGeom>
+          <a:solidFill>
+            <a:srgbClr val="FFFFFF"/>
+          </a:solidFill>
+          <a:ln>
+            <a:noFill/>
+          </a:ln>
+        </p:spPr>
+        <p:style>
+          <a:lnRef idx="1">
+            <a:schemeClr val="accent1"/>
+          </a:lnRef>
+          <a:fillRef idx="3">
+            <a:schemeClr val="accent1"/>
+          </a:fillRef>
+          <a:effectRef idx="2">
+            <a:schemeClr val="accent1"/>
+          </a:effectRef>
+          <a:fontRef idx="minor">
+            <a:schemeClr val="lt1"/>
+          </a:fontRef>
+        </p:style>
+        <p:txBody>
+          <a:bodyPr rtlCol="0" anchor="ctr"/>
+          <a:lstStyle/>
+          <a:p>
+            <a:pPr algn="ctr"/>
+          </a:p>
+        </p:txBody>
+      </p:sp>
+      <p:sp>
+        <p:nvSpPr>
+          <p:cNvPr id="3" name="Rounded Rectangle 2"/>
+          <p:cNvSpPr/>
+          <p:nvPr/>
+        </p:nvSpPr>
+        <p:spPr>
+          <a:xfrm>
+            <a:off x="731520" y="365760"/>
+            <a:ext cx="4114800" cy="320040"/>
+          </a:xfrm>
+          <a:prstGeom prst="roundRect">
+            <a:avLst/>
+          </a:prstGeom>
+          <a:solidFill>
+            <a:srgbClr val="EFF6FF"/>
+          </a:solidFill>
+          <a:ln w="12700">
+            <a:solidFill>
+              <a:srgbClr val="BFDBFE"/>
+            </a:solidFill>
+          </a:ln>
+        </p:spPr>
+        <p:style>
+          <a:lnRef idx="1">
+            <a:schemeClr val="accent1"/>
+          </a:lnRef>
+          <a:fillRef idx="3">
+            <a:schemeClr val="accent1"/>
+          </a:fillRef>
+          <a:effectRef idx="2">
+            <a:schemeClr val="accent1"/>
+          </a:effectRef>
+          <a:fontRef idx="minor">
+            <a:schemeClr val="lt1"/>
+          </a:fontRef>
+        </p:style>
+        <p:txBody>
+          <a:bodyPr rtlCol="0" anchor="ctr" wrap="square"/>
+          <a:lstStyle/>
+          <a:p>
+            <a:pPr algn="ctr">
+              <a:defRPr sz="1000" b="1">
+                <a:solidFill>
+                  <a:srgbClr val="1D4ED8"/>
+                </a:solidFill>
+              </a:defRPr>
+            </a:pPr>
+            <a:r>
+              <a:t>SECTION 7 — KẾT LUẬN &amp; THÔNG ĐIỆP HỌC THUẬT</a:t>
+            </a:r>
+          </a:p>
+        </p:txBody>
+      </p:sp>
+      <p:sp>
+        <p:nvSpPr>
+          <p:cNvPr id="4" name="TextBox 3"/>
+          <p:cNvSpPr txBox="1"/>
+          <p:nvPr/>
+        </p:nvSpPr>
+        <p:spPr>
+          <a:xfrm>
+            <a:off x="731520" y="749808"/>
+            <a:ext cx="10698480" cy="502920"/>
+          </a:xfrm>
+          <a:prstGeom prst="rect">
+            <a:avLst/>
+          </a:prstGeom>
+          <a:noFill/>
+        </p:spPr>
+        <p:txBody>
+          <a:bodyPr wrap="square" lIns="0" rIns="0" tIns="0" bIns="0">
+            <a:spAutoFit/>
+          </a:bodyPr>
+          <a:lstStyle/>
+          <a:p>
+            <a:pPr>
+              <a:defRPr sz="2100" b="1">
+                <a:solidFill>
+                  <a:srgbClr val="0F172A"/>
+                </a:solidFill>
+              </a:defRPr>
+            </a:pPr>
+            <a:r>
+              <a:t>TỔNG KẾT BÁO CÁO GIỮA KỲ &amp; ĐỊNH HƯỚNG NGHIÊN CỨU</a:t>
+            </a:r>
+          </a:p>
+        </p:txBody>
+      </p:sp>
+      <p:sp>
+        <p:nvSpPr>
+          <p:cNvPr id="5" name="TextBox 4"/>
+          <p:cNvSpPr txBox="1"/>
+          <p:nvPr/>
+        </p:nvSpPr>
+        <p:spPr>
+          <a:xfrm>
+            <a:off x="731520" y="1261872"/>
+            <a:ext cx="10698480" cy="320040"/>
+          </a:xfrm>
+          <a:prstGeom prst="rect">
+            <a:avLst/>
+          </a:prstGeom>
+          <a:noFill/>
+        </p:spPr>
+        <p:txBody>
+          <a:bodyPr wrap="square" lIns="0" rIns="0" tIns="0" bIns="0">
+            <a:spAutoFit/>
+          </a:bodyPr>
+          <a:lstStyle/>
+          <a:p>
+            <a:pPr>
+              <a:defRPr sz="1200">
+                <a:solidFill>
+                  <a:srgbClr val="475569"/>
+                </a:solidFill>
+              </a:defRPr>
+            </a:pPr>
+            <a:r>
+              <a:t>Tổng kết các đóng góp lý thuyết của Halpin và lộ trình kỹ thuật cho giai đoạn cuối kỳ</a:t>
+            </a:r>
+          </a:p>
+        </p:txBody>
+      </p:sp>
+      <p:sp>
+        <p:nvSpPr>
+          <p:cNvPr id="6" name="Rounded Rectangle 5"/>
+          <p:cNvSpPr/>
+          <p:nvPr/>
+        </p:nvSpPr>
+        <p:spPr>
+          <a:xfrm>
+            <a:off x="731520" y="1691640"/>
+            <a:ext cx="5212080" cy="4206240"/>
           </a:xfrm>
           <a:prstGeom prst="roundRect">
             <a:avLst/>
@@ -6571,7 +6564,7 @@
           </a:solidFill>
           <a:ln w="12700">
             <a:solidFill>
-              <a:srgbClr val="E2E8F0"/>
+              <a:srgbClr val="BFDBFE"/>
             </a:solidFill>
           </a:ln>
         </p:spPr>
@@ -6599,14 +6592,14 @@
       </p:sp>
       <p:sp>
         <p:nvSpPr>
-          <p:cNvPr id="9" name="TextBox 8"/>
+          <p:cNvPr id="7" name="TextBox 6"/>
           <p:cNvSpPr txBox="1"/>
           <p:nvPr/>
         </p:nvSpPr>
         <p:spPr>
           <a:xfrm>
-            <a:off x="6400800" y="1828800"/>
-            <a:ext cx="4846320" cy="4114800"/>
+            <a:off x="914400" y="1828800"/>
+            <a:ext cx="4846320" cy="3931920"/>
           </a:xfrm>
           <a:prstGeom prst="rect">
             <a:avLst/>
@@ -6622,196 +6615,230 @@
             <a:pPr>
               <a:defRPr sz="1300" b="1">
                 <a:solidFill>
-                  <a:srgbClr val="0F172A"/>
-                </a:solidFill>
-              </a:defRPr>
-            </a:pPr>
-            <a:r>
-              <a:t>2. Tài Liệu Tham Khảo Chọn Lọc (Key References)</a:t>
+                  <a:srgbClr val="1E40AF"/>
+                </a:solidFill>
+              </a:defRPr>
+            </a:pPr>
+            <a:r>
+              <a:t>1. Thông Điệp Học Thuật Cốt Lõi (Harry Halpin 2025)</a:t>
             </a:r>
           </a:p>
           <a:p>
             <a:pPr>
               <a:spcBef>
-                <a:spcPts val="400"/>
+                <a:spcPts val="800"/>
               </a:spcBef>
             </a:pPr>
             <a:r>
-              <a:rPr b="1" sz="950">
-                <a:solidFill>
-                  <a:srgbClr val="1E40AF"/>
-                </a:solidFill>
-              </a:rPr>
-              <a:t>[1] H. Halpin, </a:t>
-            </a:r>
-            <a:r>
-              <a:rPr sz="900">
+              <a:rPr b="1" sz="1100">
+                <a:solidFill>
+                  <a:srgbClr val="1E293B"/>
+                </a:solidFill>
+              </a:rPr>
+              <a:t>• Vượt qua sự trừu tượng hóa: </a:t>
+            </a:r>
+            <a:r>
+              <a:rPr sz="1050">
                 <a:solidFill>
                   <a:srgbClr val="475569"/>
                 </a:solidFill>
               </a:rPr>
-              <a:t>The adversary: the philosophy of cryptography, Journal of Cybersecurity, Oxford Academic, Vol. 11, No. 1, tyaf006, 2025.</a:t>
+              <a:t>Mật mã học không chỉ là toán học thuần túy trên giấy tờ. Các hệ thống an toàn trong thế giới thực phải nhận thức rõ khoảng cách giữa mô hình lý tưởng và thực tế vật lý (kênh kề, siêu dữ liệu, chuỗi cung ứng, áp lực thể chế).</a:t>
             </a:r>
           </a:p>
           <a:p>
             <a:pPr>
               <a:spcBef>
-                <a:spcPts val="400"/>
+                <a:spcPts val="800"/>
               </a:spcBef>
             </a:pPr>
             <a:r>
-              <a:rPr b="1" sz="950">
-                <a:solidFill>
-                  <a:srgbClr val="1E40AF"/>
-                </a:solidFill>
-              </a:rPr>
-              <a:t>[2] C. E. Shannon, </a:t>
-            </a:r>
-            <a:r>
-              <a:rPr sz="900">
+              <a:rPr b="1" sz="1100">
+                <a:solidFill>
+                  <a:srgbClr val="1E293B"/>
+                </a:solidFill>
+              </a:rPr>
+              <a:t>• Bản chất của đối thủ: </a:t>
+            </a:r>
+            <a:r>
+              <a:rPr sz="1050">
                 <a:solidFill>
                   <a:srgbClr val="475569"/>
                 </a:solidFill>
               </a:rPr>
-              <a:t>A mathematical theory of communication, Bell Syst. Tech. J., 1948.</a:t>
+              <a:t>Đối thủ không phải là 'nhiễu ngẫu nhiên' mà là tác nhân có chủ đích, liên tục tìm kiếm các kênh rò rỉ bị mô hình toán học bỏ qua.</a:t>
             </a:r>
           </a:p>
           <a:p>
             <a:pPr>
               <a:spcBef>
-                <a:spcPts val="400"/>
+                <a:spcPts val="800"/>
               </a:spcBef>
             </a:pPr>
             <a:r>
-              <a:rPr b="1" sz="950">
-                <a:solidFill>
-                  <a:srgbClr val="1E40AF"/>
-                </a:solidFill>
-              </a:rPr>
-              <a:t>[3] C. E. Shannon, </a:t>
-            </a:r>
-            <a:r>
-              <a:rPr sz="900">
+              <a:rPr b="1" sz="1100">
+                <a:solidFill>
+                  <a:srgbClr val="1E293B"/>
+                </a:solidFill>
+              </a:rPr>
+              <a:t>• Chương trình nghiên cứu mở: </a:t>
+            </a:r>
+            <a:r>
+              <a:rPr sz="1050">
                 <a:solidFill>
                   <a:srgbClr val="475569"/>
                 </a:solidFill>
               </a:rPr>
-              <a:t>Communication theory of secrecy systems, Bell Syst. Tech. J., 1949.</a:t>
+              <a:t>Halpin đặt nền móng triết học và vạch ra 4 câu hỏi nghiên cứu liên ngành nhằm mở rộng mật mã học thành một khoa học an ninh hoàn chỉnh.</a:t>
+            </a:r>
+          </a:p>
+        </p:txBody>
+      </p:sp>
+      <p:sp>
+        <p:nvSpPr>
+          <p:cNvPr id="8" name="Rounded Rectangle 7"/>
+          <p:cNvSpPr/>
+          <p:nvPr/>
+        </p:nvSpPr>
+        <p:spPr>
+          <a:xfrm>
+            <a:off x="6217920" y="1691640"/>
+            <a:ext cx="5212080" cy="4206240"/>
+          </a:xfrm>
+          <a:prstGeom prst="roundRect">
+            <a:avLst/>
+          </a:prstGeom>
+          <a:solidFill>
+            <a:srgbClr val="ECFDF5"/>
+          </a:solidFill>
+          <a:ln w="12700">
+            <a:solidFill>
+              <a:srgbClr val="A7F3D0"/>
+            </a:solidFill>
+          </a:ln>
+        </p:spPr>
+        <p:style>
+          <a:lnRef idx="1">
+            <a:schemeClr val="accent1"/>
+          </a:lnRef>
+          <a:fillRef idx="3">
+            <a:schemeClr val="accent1"/>
+          </a:fillRef>
+          <a:effectRef idx="2">
+            <a:schemeClr val="accent1"/>
+          </a:effectRef>
+          <a:fontRef idx="minor">
+            <a:schemeClr val="lt1"/>
+          </a:fontRef>
+        </p:style>
+        <p:txBody>
+          <a:bodyPr rtlCol="0" anchor="ctr"/>
+          <a:lstStyle/>
+          <a:p>
+            <a:pPr algn="ctr"/>
+          </a:p>
+        </p:txBody>
+      </p:sp>
+      <p:sp>
+        <p:nvSpPr>
+          <p:cNvPr id="9" name="TextBox 8"/>
+          <p:cNvSpPr txBox="1"/>
+          <p:nvPr/>
+        </p:nvSpPr>
+        <p:spPr>
+          <a:xfrm>
+            <a:off x="6400800" y="1828800"/>
+            <a:ext cx="4846320" cy="3931920"/>
+          </a:xfrm>
+          <a:prstGeom prst="rect">
+            <a:avLst/>
+          </a:prstGeom>
+          <a:noFill/>
+        </p:spPr>
+        <p:txBody>
+          <a:bodyPr wrap="square">
+            <a:spAutoFit/>
+          </a:bodyPr>
+          <a:lstStyle/>
+          <a:p>
+            <a:pPr>
+              <a:defRPr sz="1300" b="1">
+                <a:solidFill>
+                  <a:srgbClr val="059669"/>
+                </a:solidFill>
+              </a:defRPr>
+            </a:pPr>
+            <a:r>
+              <a:t>2. Hoàn Thành Giữa Kỳ &amp; Lộ Trình Cuối Kỳ (Nhóm DT005)</a:t>
             </a:r>
           </a:p>
           <a:p>
             <a:pPr>
               <a:spcBef>
-                <a:spcPts val="400"/>
+                <a:spcPts val="800"/>
               </a:spcBef>
             </a:pPr>
             <a:r>
-              <a:rPr b="1" sz="950">
-                <a:solidFill>
-                  <a:srgbClr val="1E40AF"/>
-                </a:solidFill>
-              </a:rPr>
-              <a:t>[4] S. Goldwasser &amp; S. Micali, </a:t>
-            </a:r>
-            <a:r>
-              <a:rPr sz="900">
+              <a:rPr b="1" sz="1100">
+                <a:solidFill>
+                  <a:srgbClr val="1E293B"/>
+                </a:solidFill>
+              </a:rPr>
+              <a:t>• Nghiệm thu tiến độ giữa kỳ: </a:t>
+            </a:r>
+            <a:r>
+              <a:rPr sz="1050">
                 <a:solidFill>
                   <a:srgbClr val="475569"/>
                 </a:solidFill>
               </a:rPr>
-              <a:t>Probabilistic encryption, JCSS, 1984.</a:t>
+              <a:t>Hoàn thành thẩm định học thuật sâu sắc toàn văn bài báo gốc (17 trang PDF), phân tích đầy đủ 7 mục nội dung và xây dựng bộ diễn tập minh họa thực nghiệm sống động phục vụ báo cáo.</a:t>
             </a:r>
           </a:p>
           <a:p>
             <a:pPr>
               <a:spcBef>
-                <a:spcPts val="400"/>
+                <a:spcPts val="800"/>
               </a:spcBef>
             </a:pPr>
             <a:r>
-              <a:rPr b="1" sz="950">
-                <a:solidFill>
-                  <a:srgbClr val="1E40AF"/>
-                </a:solidFill>
-              </a:rPr>
-              <a:t>[5] D. Dolev &amp; A. Yao, </a:t>
-            </a:r>
-            <a:r>
-              <a:rPr sz="900">
+              <a:rPr b="1" sz="1100">
+                <a:solidFill>
+                  <a:srgbClr val="1E293B"/>
+                </a:solidFill>
+              </a:rPr>
+              <a:t>• Minh bạch phương pháp luận: </a:t>
+            </a:r>
+            <a:r>
+              <a:rPr sz="1050">
                 <a:solidFill>
                   <a:srgbClr val="475569"/>
                 </a:solidFill>
               </a:rPr>
-              <a:t>On the security of public key protocols, IEEE TIT, 1983.</a:t>
+              <a:t>Không ngụy tạo số liệu tác giả; phân định rạch ròi giữa công trình triết học của Halpin và các thử nghiệm độc lập của sinh viên.</a:t>
             </a:r>
           </a:p>
           <a:p>
             <a:pPr>
               <a:spcBef>
-                <a:spcPts val="400"/>
+                <a:spcPts val="800"/>
               </a:spcBef>
             </a:pPr>
             <a:r>
-              <a:rPr b="1" sz="950">
-                <a:solidFill>
-                  <a:srgbClr val="1E40AF"/>
-                </a:solidFill>
-              </a:rPr>
-              <a:t>[6] M. Bellare &amp; P. Rogaway, </a:t>
-            </a:r>
-            <a:r>
-              <a:rPr sz="900">
+              <a:rPr b="1" sz="1100">
+                <a:solidFill>
+                  <a:srgbClr val="1E293B"/>
+                </a:solidFill>
+              </a:rPr>
+              <a:t>• Lộ trình nghiên cứu cuối kỳ: </a:t>
+            </a:r>
+            <a:r>
+              <a:rPr sz="1050">
                 <a:solidFill>
                   <a:srgbClr val="475569"/>
                 </a:solidFill>
               </a:rPr>
-              <a:t>Random oracles are practical, ACM CCS, 1993.</a:t>
-            </a:r>
-          </a:p>
-          <a:p>
-            <a:pPr>
-              <a:spcBef>
-                <a:spcPts val="400"/>
-              </a:spcBef>
-            </a:pPr>
-            <a:r>
-              <a:rPr b="1" sz="950">
-                <a:solidFill>
-                  <a:srgbClr val="1E40AF"/>
-                </a:solidFill>
-              </a:rPr>
-              <a:t>[7] P. Kocher, </a:t>
-            </a:r>
-            <a:r>
-              <a:rPr sz="900">
-                <a:solidFill>
-                  <a:srgbClr val="475569"/>
-                </a:solidFill>
-              </a:rPr>
-              <a:t>Timing attacks on implementations of Diffie-Hellman, RSA, DSS, Crypto, 1996.</a:t>
-            </a:r>
-          </a:p>
-          <a:p>
-            <a:pPr>
-              <a:spcBef>
-                <a:spcPts val="400"/>
-              </a:spcBef>
-            </a:pPr>
-            <a:r>
-              <a:rPr b="1" sz="950">
-                <a:solidFill>
-                  <a:srgbClr val="1E40AF"/>
-                </a:solidFill>
-              </a:rPr>
-              <a:t>[8] B. Laurie et al., </a:t>
-            </a:r>
-            <a:r>
-              <a:rPr sz="900">
-                <a:solidFill>
-                  <a:srgbClr val="475569"/>
-                </a:solidFill>
-              </a:rPr>
-              <a:t>Certificate Transparency, IETF RFC 6962, 2013.</a:t>
+              <a:t>Đề xuất phát triển chuyên sâu giải pháp tối ưu hóa cấu trúc cây Merkle phân cấp (HD-Merkle Dirty-Path Caching, nén CompactProof O(1)) làm đóng góp kỹ thuật trọng tâm cho đồ án cuối kỳ.</a:t>
             </a:r>
           </a:p>
         </p:txBody>
@@ -6824,8 +6851,8 @@
         </p:nvSpPr>
         <p:spPr>
           <a:xfrm>
-            <a:off x="731520" y="6217920"/>
-            <a:ext cx="10698480" cy="365760"/>
+            <a:off x="731520" y="6035040"/>
+            <a:ext cx="10698480" cy="502920"/>
           </a:xfrm>
           <a:prstGeom prst="rect">
             <a:avLst/>
@@ -6839,14 +6866,14 @@
           <a:lstStyle/>
           <a:p>
             <a:pPr>
-              <a:defRPr sz="1000" i="1">
+              <a:defRPr sz="950" i="1">
                 <a:solidFill>
                   <a:srgbClr val="64748B"/>
                 </a:solidFill>
               </a:defRPr>
             </a:pPr>
             <a:r>
-              <a:t>Đề tài DT005 — An Toàn và Bảo Mật Hệ Thống Thông Tin — Báo cáo Tiến độ Giữa kỳ.</a:t>
+              <a:t>Tài liệu tham khảo chính: [1] H. Halpin, Oxford J. Cybersec., 2025 (DOI: 10.1093/cybsec/tyaf006); [2] Shannon (1949); [3] Goldwasser-Micali (1984); [4] Dolev-Yao (1983); [5] Kocher (1996); [6] RFC 6962 (2013).</a:t>
             </a:r>
           </a:p>
         </p:txBody>

</xml_diff>

<commit_message>
refactor: streamline and minimize text in diagrams and slides 5 & 13
</commit_message>
<xml_diff>
--- a/Bao_Cao_Giua_Ky_DT05_Final.pptx
+++ b/Bao_Cao_Giua_Ky_DT05_Final.pptx
@@ -5236,7 +5236,7 @@
                   <a:srgbClr val="1E293B"/>
                 </a:solidFill>
               </a:rPr>
-              <a:t>• Kịch bản 1 (CRC32 Forge): </a:t>
+              <a:t>• Kịch bản 1 (CRC32): </a:t>
             </a:r>
             <a:r>
               <a:rPr sz="950">
@@ -5244,7 +5244,7 @@
                   <a:srgbClr val="475569"/>
                 </a:solidFill>
               </a:rPr>
-              <a:t>Red Team bù 4 byte GF(2) qua mặt CRC32; Blue Team dùng SHA-256 bắt quả tang tức thì.</a:t>
+              <a:t>Red Team bù 4 byte GF(2); Blue Team dùng SHA-256 bắt quả tang tức thì.</a:t>
             </a:r>
           </a:p>
           <a:p>
@@ -5267,7 +5267,7 @@
                   <a:srgbClr val="475569"/>
                 </a:solidFill>
               </a:rPr>
-              <a:t>Sửa nội dung tệp; Blue Team phát hiện FILE_MODIFIED và vẽ Dirty Path O(log N).</a:t>
+              <a:t>Sửa nội dung tệp; Blue Team phát hiện và vẽ Dirty Path O(log N).</a:t>
             </a:r>
           </a:p>
           <a:p>
@@ -5290,7 +5290,7 @@
                   <a:srgbClr val="475569"/>
                 </a:solidFill>
               </a:rPr>
-              <a:t>Đánh tráo Merkle Proof trên đường truyền mạng; bộ xác thực từ chối 100% chữ ký bằng chứng.</a:t>
+              <a:t>Đánh tráo Merkle Proof trên mạng; bộ xác thực từ chối 100% chữ ký.</a:t>
             </a:r>
           </a:p>
         </p:txBody>
@@ -5607,7 +5607,7 @@
                   <a:srgbClr val="1E293B"/>
                 </a:solidFill>
               </a:rPr>
-              <a:t>• Mục đích minh họa: </a:t>
+              <a:t>• Bản chất minh họa: </a:t>
             </a:r>
             <a:r>
               <a:rPr sz="950">
@@ -5615,7 +5615,7 @@
                   <a:srgbClr val="475569"/>
                 </a:solidFill>
               </a:rPr>
-              <a:t>Thực nghiệm được thiết kế độc lập nhằm kiểm chứng tính đúng đắn logic của các khái niệm; không phải là chạy lại số liệu của tác giả.</a:t>
+              <a:t>Thực nghiệm độc lập kiểm chứng logic các khái niệm; không phải chạy lại số liệu bài báo.</a:t>
             </a:r>
           </a:p>
           <a:p>
@@ -5630,7 +5630,7 @@
                   <a:srgbClr val="1E293B"/>
                 </a:solidFill>
               </a:rPr>
-              <a:t>• Môi trường kiểm thử: </a:t>
+              <a:t>• Môi trường đo đạc: </a:t>
             </a:r>
             <a:r>
               <a:rPr sz="950">
@@ -5638,7 +5638,7 @@
                   <a:srgbClr val="475569"/>
                 </a:solidFill>
               </a:rPr>
-              <a:t>Đo đạc trên máy tính cá nhân (Intel Core i7, Windows 11). Các phép đo thời gian vi mô chịu ảnh hưởng của jitter hệ điều hành.</a:t>
+              <a:t>CPU Intel i7, Windows 11; tốc độ duyệt đạt 2.325 tệp/giây trên kaggle_dataset.</a:t>
             </a:r>
           </a:p>
           <a:p>
@@ -5653,7 +5653,7 @@
                   <a:srgbClr val="1E293B"/>
                 </a:solidFill>
               </a:rPr>
-              <a:t>• Kịch bản tương tác: </a:t>
+              <a:t>• Kịch bản thao tác: </a:t>
             </a:r>
             <a:r>
               <a:rPr sz="950">
@@ -5661,7 +5661,7 @@
                   <a:srgbClr val="475569"/>
                 </a:solidFill>
               </a:rPr>
-              <a:t>Toàn bộ mã nguồn và kịch bản demo 2 màn hình được hướng dẫn chi tiết tại file MIDTERM_DEMO.md.</a:t>
+              <a:t>Hướng dẫn lệnh chạy và quy trình demo 2 màn hình xem tại MIDTERM_DEMO.md.</a:t>
             </a:r>
           </a:p>
         </p:txBody>
@@ -9002,7 +9002,7 @@
                   <a:srgbClr val="1E293B"/>
                 </a:solidFill>
               </a:rPr>
-              <a:t>• Nguồn gốc tối mật: </a:t>
+              <a:t>• Bí mật hoàn hảo: </a:t>
             </a:r>
             <a:r>
               <a:rPr sz="950">
@@ -9010,7 +9010,7 @@
                   <a:srgbClr val="475569"/>
                 </a:solidFill>
               </a:rPr>
-              <a:t>Lý thuyết thông tin Shannon (1948) bắt nguồn từ báo cáo mật mã tối mật năm 1945 ('A Mathematical Theory of Cryptography').</a:t>
+              <a:t>OTP an toàn tuyệt đối khi H(K) &gt;= H(M), nhưng bất khả thi khi triển khai diện rộng.</a:t>
             </a:r>
           </a:p>
           <a:p>
@@ -9025,7 +9025,7 @@
                   <a:srgbClr val="1E293B"/>
                 </a:solidFill>
               </a:rPr>
-              <a:t>• Bí mật hoàn hảo: </a:t>
+              <a:t>• Giả định Shannon: </a:t>
             </a:r>
             <a:r>
               <a:rPr sz="950">
@@ -9033,7 +9033,7 @@
                   <a:srgbClr val="475569"/>
                 </a:solidFill>
               </a:rPr>
-              <a:t>Shannon chứng minh OTP là hệ mật hoàn hảo duy nhất, nhưng đòi hỏi khóa ngẫu nhiên dài bằng thông điệp ($H(K) &gt;= H(M)$).</a:t>
+              <a:t>Xem sai lệch dữ liệu là 'nhiễu ngẫu nhiên'. Đối thủ thực tế là tác nhân có chủ đích!</a:t>
             </a:r>
           </a:p>
           <a:p>
@@ -9048,7 +9048,7 @@
                   <a:srgbClr val="1E293B"/>
                 </a:solidFill>
               </a:rPr>
-              <a:t>• Giả định giới hạn: </a:t>
+              <a:t>• Hạn chế: </a:t>
             </a:r>
             <a:r>
               <a:rPr sz="950">
@@ -9056,7 +9056,7 @@
                   <a:srgbClr val="475569"/>
                 </a:solidFill>
               </a:rPr>
-              <a:t>Shannon xem sự sai lệch là 'nhiễu ngẫu nhiên' (noise). Tuy nhiên, kẻ thù là tác nhân có chủ đích (intentional agent), không phải nhiễu!</a:t>
+              <a:t>Bỏ qua chi phí lưu trữ/phân phối khóa, rò rỉ kênh kề và ranh giới hệ thống vật lý.</a:t>
             </a:r>
           </a:p>
         </p:txBody>
@@ -9347,7 +9347,7 @@
         </p:nvSpPr>
         <p:spPr>
           <a:xfrm>
-            <a:off x="6400800" y="3657600"/>
+            <a:off x="6400800" y="3611880"/>
             <a:ext cx="4846320" cy="2194560"/>
           </a:xfrm>
           <a:prstGeom prst="rect">
@@ -9373,7 +9373,7 @@
                   <a:srgbClr val="1E293B"/>
                 </a:solidFill>
               </a:rPr>
-              <a:t>• Vượt qua kênh đơn: </a:t>
+              <a:t>• Mạng phức hợp: </a:t>
             </a:r>
             <a:r>
               <a:rPr sz="950">
@@ -9381,7 +9381,7 @@
                   <a:srgbClr val="475569"/>
                 </a:solidFill>
               </a:rPr>
-              <a:t>Thông tin chảy qua mạng lưới phức tạp gồm người dùng, thiết bị, hệ điều hành và hạ tầng cáp quang toàn cầu.</a:t>
+              <a:t>Thông tin chảy qua nhiều thực thể: người dùng, ISP, cáp quang biển, đám mây.</a:t>
             </a:r>
           </a:p>
           <a:p>
@@ -9396,7 +9396,7 @@
                   <a:srgbClr val="1E293B"/>
                 </a:solidFill>
               </a:rPr>
-              <a:t>• Tổ chức thông tin: </a:t>
+              <a:t>• Đối thủ thể chế: </a:t>
             </a:r>
             <a:r>
               <a:rPr sz="950">
@@ -9404,7 +9404,7 @@
                   <a:srgbClr val="475569"/>
                 </a:solidFill>
               </a:rPr>
-              <a:t>Bảo toàn bí mật là duy trì bất biến chính sách trước các lỗi Byzantine và hành vi làm rò rỉ của người bên trong (insider / Snowden).</a:t>
+              <a:t>NSA/Five Eyes tấn công chuỗi cung ứng, suy yếu chuẩn &amp; giám sát siêu dữ liệu.</a:t>
             </a:r>
           </a:p>
           <a:p>
@@ -9419,7 +9419,7 @@
                   <a:srgbClr val="1E293B"/>
                 </a:solidFill>
               </a:rPr>
-              <a:t>• Điểm mù của Shannon: </a:t>
+              <a:t>• Mục tiêu hiện đại: </a:t>
             </a:r>
             <a:r>
               <a:rPr sz="950">
@@ -9427,7 +9427,7 @@
                   <a:srgbClr val="475569"/>
                 </a:solidFill>
               </a:rPr>
-              <a:t>Bỏ qua hoàn toàn chi phí lưu trữ khóa, phân phối khóa, lỗi phần mềm và sự can thiệp vào hành vi của người giữ bí mật.</a:t>
+              <a:t>Bảo vệ siêu dữ liệu (Mixnet), kháng kênh kề thời gian và kiểm soát lỗi nội bộ.</a:t>
             </a:r>
           </a:p>
         </p:txBody>

</xml_diff>

<commit_message>
feat(slides): integrate user drawio diagrams, brighten slide 12, streamline slide 11 minimal layout
</commit_message>
<xml_diff>
--- a/Bao_Cao_Giua_Ky_DT05_Final.pptx
+++ b/Bao_Cao_Giua_Ky_DT05_Final.pptx
@@ -4146,191 +4146,7 @@
         <p:spPr>
           <a:xfrm>
             <a:off x="731520" y="1691640"/>
-            <a:ext cx="5212080" cy="777240"/>
-          </a:xfrm>
-          <a:prstGeom prst="roundRect">
-            <a:avLst/>
-          </a:prstGeom>
-          <a:solidFill>
-            <a:srgbClr val="F8FAFC"/>
-          </a:solidFill>
-          <a:ln>
-            <a:solidFill>
-              <a:srgbClr val="BFDBFE"/>
-            </a:solidFill>
-          </a:ln>
-        </p:spPr>
-        <p:style>
-          <a:lnRef idx="1">
-            <a:schemeClr val="accent1"/>
-          </a:lnRef>
-          <a:fillRef idx="3">
-            <a:schemeClr val="accent1"/>
-          </a:fillRef>
-          <a:effectRef idx="2">
-            <a:schemeClr val="accent1"/>
-          </a:effectRef>
-          <a:fontRef idx="minor">
-            <a:schemeClr val="lt1"/>
-          </a:fontRef>
-        </p:style>
-        <p:txBody>
-          <a:bodyPr rtlCol="0" anchor="ctr"/>
-          <a:lstStyle/>
-          <a:p>
-            <a:pPr algn="ctr"/>
-          </a:p>
-        </p:txBody>
-      </p:sp>
-      <p:sp>
-        <p:nvSpPr>
-          <p:cNvPr id="7" name="TextBox 6"/>
-          <p:cNvSpPr txBox="1"/>
-          <p:nvPr/>
-        </p:nvSpPr>
-        <p:spPr>
-          <a:xfrm>
-            <a:off x="822960" y="1737360"/>
-            <a:ext cx="5029200" cy="685800"/>
-          </a:xfrm>
-          <a:prstGeom prst="rect">
-            <a:avLst/>
-          </a:prstGeom>
-          <a:noFill/>
-        </p:spPr>
-        <p:txBody>
-          <a:bodyPr wrap="none">
-            <a:spAutoFit/>
-          </a:bodyPr>
-          <a:lstStyle/>
-          <a:p>
-            <a:pPr>
-              <a:defRPr sz="1100" b="1">
-                <a:solidFill>
-                  <a:srgbClr val="1E40AF"/>
-                </a:solidFill>
-              </a:defRPr>
-            </a:pPr>
-            <a:r>
-              <a:t>LUỒNG LÝ THUYẾT BÀI BÁO (HARRY HALPIN 2025)</a:t>
-            </a:r>
-          </a:p>
-          <a:p>
-            <a:pPr>
-              <a:defRPr sz="950">
-                <a:solidFill>
-                  <a:srgbClr val="64748B"/>
-                </a:solidFill>
-              </a:defRPr>
-            </a:pPr>
-            <a:r>
-              <a:t>Khảo sát triết học, phê phán trừu tượng hóa, phân tích Dolev-Yao &amp; NSA</a:t>
-            </a:r>
-          </a:p>
-        </p:txBody>
-      </p:sp>
-      <p:sp>
-        <p:nvSpPr>
-          <p:cNvPr id="8" name="Rounded Rectangle 7"/>
-          <p:cNvSpPr/>
-          <p:nvPr/>
-        </p:nvSpPr>
-        <p:spPr>
-          <a:xfrm>
-            <a:off x="6217920" y="1691640"/>
-            <a:ext cx="5212080" cy="777240"/>
-          </a:xfrm>
-          <a:prstGeom prst="roundRect">
-            <a:avLst/>
-          </a:prstGeom>
-          <a:solidFill>
-            <a:srgbClr val="ECFDF5"/>
-          </a:solidFill>
-          <a:ln>
-            <a:solidFill>
-              <a:srgbClr val="A7F3D0"/>
-            </a:solidFill>
-          </a:ln>
-        </p:spPr>
-        <p:style>
-          <a:lnRef idx="1">
-            <a:schemeClr val="accent1"/>
-          </a:lnRef>
-          <a:fillRef idx="3">
-            <a:schemeClr val="accent1"/>
-          </a:fillRef>
-          <a:effectRef idx="2">
-            <a:schemeClr val="accent1"/>
-          </a:effectRef>
-          <a:fontRef idx="minor">
-            <a:schemeClr val="lt1"/>
-          </a:fontRef>
-        </p:style>
-        <p:txBody>
-          <a:bodyPr rtlCol="0" anchor="ctr"/>
-          <a:lstStyle/>
-          <a:p>
-            <a:pPr algn="ctr"/>
-          </a:p>
-        </p:txBody>
-      </p:sp>
-      <p:sp>
-        <p:nvSpPr>
-          <p:cNvPr id="9" name="TextBox 8"/>
-          <p:cNvSpPr txBox="1"/>
-          <p:nvPr/>
-        </p:nvSpPr>
-        <p:spPr>
-          <a:xfrm>
-            <a:off x="6309360" y="1737360"/>
-            <a:ext cx="5029200" cy="685800"/>
-          </a:xfrm>
-          <a:prstGeom prst="rect">
-            <a:avLst/>
-          </a:prstGeom>
-          <a:noFill/>
-        </p:spPr>
-        <p:txBody>
-          <a:bodyPr wrap="none">
-            <a:spAutoFit/>
-          </a:bodyPr>
-          <a:lstStyle/>
-          <a:p>
-            <a:pPr>
-              <a:defRPr sz="1100" b="1">
-                <a:solidFill>
-                  <a:srgbClr val="059669"/>
-                </a:solidFill>
-              </a:defRPr>
-            </a:pPr>
-            <a:r>
-              <a:t>LUỒNG THỰC NGHIỆM ĐỘC LẬP (SINH VIÊN DT005)</a:t>
-            </a:r>
-          </a:p>
-          <a:p>
-            <a:pPr>
-              <a:defRPr sz="950">
-                <a:solidFill>
-                  <a:srgbClr val="64748B"/>
-                </a:solidFill>
-              </a:defRPr>
-            </a:pPr>
-            <a:r>
-              <a:t>Hệ thống kiểm tra toàn vẹn tệp, 7 thí nghiệm minh họa, đối kháng Red/Blue</a:t>
-            </a:r>
-          </a:p>
-        </p:txBody>
-      </p:sp>
-      <p:sp>
-        <p:nvSpPr>
-          <p:cNvPr id="10" name="Rounded Rectangle 9"/>
-          <p:cNvSpPr/>
-          <p:nvPr/>
-        </p:nvSpPr>
-        <p:spPr>
-          <a:xfrm>
-            <a:off x="731520" y="2606040"/>
-            <a:ext cx="10728655" cy="3520440"/>
+            <a:ext cx="3383280" cy="4389120"/>
           </a:xfrm>
           <a:prstGeom prst="roundRect">
             <a:avLst/>
@@ -4368,14 +4184,14 @@
       </p:sp>
       <p:sp>
         <p:nvSpPr>
-          <p:cNvPr id="11" name="TextBox 10"/>
+          <p:cNvPr id="7" name="TextBox 6"/>
           <p:cNvSpPr txBox="1"/>
           <p:nvPr/>
         </p:nvSpPr>
         <p:spPr>
           <a:xfrm>
-            <a:off x="914400" y="2697480"/>
-            <a:ext cx="10362895" cy="3337560"/>
+            <a:off x="914400" y="1828800"/>
+            <a:ext cx="3017520" cy="4114800"/>
           </a:xfrm>
           <a:prstGeom prst="rect">
             <a:avLst/>
@@ -4389,6 +4205,9 @@
           <a:lstStyle/>
           <a:p>
             <a:pPr>
+              <a:spcAft>
+                <a:spcPts val="1000"/>
+              </a:spcAft>
               <a:defRPr sz="1200" b="1">
                 <a:solidFill>
                   <a:srgbClr val="0F172A"/>
@@ -4396,169 +4215,407 @@
               </a:defRPr>
             </a:pPr>
             <a:r>
-              <a:t>BẢNG ĐỐI CHIẾU BA MINH HỌA THỰC NGHIỆM TIÊU BIỂU VÀ GIỚI HẠN DIỄN GIẢI</a:t>
-            </a:r>
-          </a:p>
-          <a:p>
-            <a:pPr>
-              <a:spcBef>
-                <a:spcPts val="600"/>
-              </a:spcBef>
-            </a:pPr>
-            <a:r>
-              <a:rPr b="1" sz="1050">
-                <a:solidFill>
-                  <a:srgbClr val="1E40AF"/>
-                </a:solidFill>
-              </a:rPr>
-              <a:t>1. Noise vs Adversary (Sec. 1 &amp; 2) — </a:t>
-            </a:r>
-            <a:r>
-              <a:rPr sz="1000">
+              <a:t>1. NHIỄU vs KẺ THÙ CHỦ ĐÍCH</a:t>
+            </a:r>
+          </a:p>
+          <a:p>
+            <a:pPr>
+              <a:defRPr sz="1050" b="1">
                 <a:solidFill>
                   <a:srgbClr val="1E293B"/>
                 </a:solidFill>
-              </a:rPr>
-              <a:t>Luận điểm Halpin: Kẻ thù có chủ đích khác với nhiễu ngẫu nhiên; mã tuyến tính CRC32 bất lực. | </a:t>
-            </a:r>
-            <a:r>
-              <a:rPr sz="1000">
+              </a:defRPr>
+            </a:pPr>
+            <a:r>
+              <a:t>Luận điểm bài báo Halpin:</a:t>
+            </a:r>
+          </a:p>
+          <a:p>
+            <a:pPr>
+              <a:spcAft>
+                <a:spcPts val="800"/>
+              </a:spcAft>
+              <a:defRPr sz="950">
                 <a:solidFill>
                   <a:srgbClr val="475569"/>
                 </a:solidFill>
-              </a:rPr>
-              <a:t>Code DT005: Code giải mã bù đại số trên trường nhị phân GF(2), tìm 4 byte bù qua mặt CRC32 100%; SHA-256 phát hiện tức thì. </a:t>
-            </a:r>
-          </a:p>
-          <a:p>
-            <a:pPr>
-              <a:spcBef>
-                <a:spcPts val="200"/>
-              </a:spcBef>
-            </a:pPr>
-            <a:r>
-              <a:rPr b="1" sz="950">
-                <a:solidFill>
-                  <a:srgbClr val="059669"/>
-                </a:solidFill>
-              </a:rPr>
-              <a:t>   ► Bằng chứng đã chạy: orig_crc == forged_crc (Trùng 100%), SHA-256 lệch hoàn toàn.  |  </a:t>
-            </a:r>
-            <a:r>
-              <a:rPr sz="950">
-                <a:solidFill>
-                  <a:srgbClr val="D97706"/>
-                </a:solidFill>
-              </a:rPr>
-              <a:t>▲ Giới hạn diễn giải: Minh họa tính phi tuyến của hàm băm; không chứng minh an toàn toàn diện cho toàn hệ thống.</a:t>
-            </a:r>
-          </a:p>
-          <a:p>
-            <a:pPr>
-              <a:spcBef>
-                <a:spcPts val="600"/>
-              </a:spcBef>
-            </a:pPr>
-            <a:r>
-              <a:rPr b="1" sz="1050">
-                <a:solidFill>
-                  <a:srgbClr val="1E40AF"/>
-                </a:solidFill>
-              </a:rPr>
-              <a:t>2. Node-Leaf Confusion (Sec. 5) — </a:t>
-            </a:r>
-            <a:r>
-              <a:rPr sz="1000">
+              </a:defRPr>
+            </a:pPr>
+            <a:r>
+              <a:t>Mật mã học khác lý thuyết Shannon: đối thủ có chủ đích, không phải nhiễu ngẫu nhiên. Mã toàn vẹn tuyến tính CRC32 hoàn toàn bất lực.</a:t>
+            </a:r>
+          </a:p>
+          <a:p>
+            <a:pPr>
+              <a:defRPr sz="1050" b="1">
                 <a:solidFill>
                   <a:srgbClr val="1E293B"/>
                 </a:solidFill>
-              </a:rPr>
-              <a:t>Luận điểm Halpin: Ghép chuỗi thô H(L||R) gây va chạm tiền ảnh cấp hai cấu trúc (nút cha bị nhầm với nút lá). | </a:t>
-            </a:r>
-            <a:r>
-              <a:rPr sz="1000">
+              </a:defRPr>
+            </a:pPr>
+            <a:r>
+              <a:t>Minh họa thực nghiệm DT005:</a:t>
+            </a:r>
+          </a:p>
+          <a:p>
+            <a:pPr>
+              <a:spcAft>
+                <a:spcPts val="800"/>
+              </a:spcAft>
+              <a:defRPr sz="950">
                 <a:solidFill>
                   <a:srgbClr val="475569"/>
                 </a:solidFill>
-              </a:rPr>
-              <a:t>Code DT005: Triển khai phân tách miền chuẩn RFC 6962: Tiền tố 0x00 cho lá, 0x01 cho nhánh nội bộ. </a:t>
-            </a:r>
-          </a:p>
-          <a:p>
-            <a:pPr>
-              <a:spcBef>
-                <a:spcPts val="200"/>
-              </a:spcBef>
-            </a:pPr>
-            <a:r>
-              <a:rPr b="1" sz="950">
-                <a:solidFill>
-                  <a:srgbClr val="059669"/>
-                </a:solidFill>
-              </a:rPr>
-              <a:t>   ► Bằng chứng đã chạy: Standard Merkle Tree ghép thô bị va chạm; HD-Merkle phân tách miền chặn đứng hoàn toàn.  |  </a:t>
-            </a:r>
-            <a:r>
-              <a:rPr sz="950">
-                <a:solidFill>
-                  <a:srgbClr val="D97706"/>
-                </a:solidFill>
-              </a:rPr>
-              <a:t>▲ Giới hạn diễn giải: Chỉ giải quyết va chạm cấu trúc tầng cây; không loại trừ va chạm ngẫu nhiên 2^256 của SHA-256.</a:t>
-            </a:r>
-          </a:p>
-          <a:p>
-            <a:pPr>
-              <a:spcBef>
-                <a:spcPts val="600"/>
-              </a:spcBef>
-            </a:pPr>
-            <a:r>
-              <a:rPr b="1" sz="1050">
-                <a:solidFill>
-                  <a:srgbClr val="1E40AF"/>
-                </a:solidFill>
-              </a:rPr>
-              <a:t>3. Timing Side-Channel (Sec. 5) — </a:t>
-            </a:r>
-            <a:r>
-              <a:rPr sz="1000">
+              </a:defRPr>
+            </a:pPr>
+            <a:r>
+              <a:t>Giải hệ phương trình bù đại số GF(2), tìm 4 byte giả mạo qua mặt CRC32 100%. Hàm băm SHA-256 phát hiện thay đổi ngay lập tức.</a:t>
+            </a:r>
+          </a:p>
+          <a:p>
+            <a:pPr>
+              <a:defRPr sz="1050" b="1">
                 <a:solidFill>
                   <a:srgbClr val="1E293B"/>
                 </a:solidFill>
-              </a:rPr>
-              <a:t>Luận điểm Halpin: Rò rỉ thông tin qua thời gian so sánh chuỗi (Early-return comparison leak - Kocher 1996). | </a:t>
-            </a:r>
-            <a:r>
-              <a:rPr sz="1000">
+              </a:defRPr>
+            </a:pPr>
+            <a:r>
+              <a:t>Giới hạn diễn giải:</a:t>
+            </a:r>
+          </a:p>
+          <a:p>
+            <a:pPr>
+              <a:defRPr sz="950">
+                <a:solidFill>
+                  <a:srgbClr val="64748B"/>
+                </a:solidFill>
+              </a:defRPr>
+            </a:pPr>
+            <a:r>
+              <a:t>Chỉ minh họa tính phi tuyến của hàm băm; không chứng minh an toàn toàn diện cho toàn bộ hệ thống.</a:t>
+            </a:r>
+          </a:p>
+        </p:txBody>
+      </p:sp>
+      <p:sp>
+        <p:nvSpPr>
+          <p:cNvPr id="8" name="Rounded Rectangle 7"/>
+          <p:cNvSpPr/>
+          <p:nvPr/>
+        </p:nvSpPr>
+        <p:spPr>
+          <a:xfrm>
+            <a:off x="4389120" y="1691640"/>
+            <a:ext cx="3383280" cy="4389120"/>
+          </a:xfrm>
+          <a:prstGeom prst="roundRect">
+            <a:avLst/>
+          </a:prstGeom>
+          <a:solidFill>
+            <a:srgbClr val="F8FAFC"/>
+          </a:solidFill>
+          <a:ln>
+            <a:solidFill>
+              <a:srgbClr val="E2E8F0"/>
+            </a:solidFill>
+          </a:ln>
+        </p:spPr>
+        <p:style>
+          <a:lnRef idx="1">
+            <a:schemeClr val="accent1"/>
+          </a:lnRef>
+          <a:fillRef idx="3">
+            <a:schemeClr val="accent1"/>
+          </a:fillRef>
+          <a:effectRef idx="2">
+            <a:schemeClr val="accent1"/>
+          </a:effectRef>
+          <a:fontRef idx="minor">
+            <a:schemeClr val="lt1"/>
+          </a:fontRef>
+        </p:style>
+        <p:txBody>
+          <a:bodyPr rtlCol="0" anchor="ctr"/>
+          <a:lstStyle/>
+          <a:p>
+            <a:pPr algn="ctr"/>
+          </a:p>
+        </p:txBody>
+      </p:sp>
+      <p:sp>
+        <p:nvSpPr>
+          <p:cNvPr id="9" name="TextBox 8"/>
+          <p:cNvSpPr txBox="1"/>
+          <p:nvPr/>
+        </p:nvSpPr>
+        <p:spPr>
+          <a:xfrm>
+            <a:off x="4572000" y="1828800"/>
+            <a:ext cx="3017520" cy="4114800"/>
+          </a:xfrm>
+          <a:prstGeom prst="rect">
+            <a:avLst/>
+          </a:prstGeom>
+          <a:noFill/>
+        </p:spPr>
+        <p:txBody>
+          <a:bodyPr wrap="square">
+            <a:spAutoFit/>
+          </a:bodyPr>
+          <a:lstStyle/>
+          <a:p>
+            <a:pPr>
+              <a:spcAft>
+                <a:spcPts val="1000"/>
+              </a:spcAft>
+              <a:defRPr sz="1200" b="1">
+                <a:solidFill>
+                  <a:srgbClr val="0F172A"/>
+                </a:solidFill>
+              </a:defRPr>
+            </a:pPr>
+            <a:r>
+              <a:t>2. NHẬP NHẰNG NÚT LÁ MERKLE</a:t>
+            </a:r>
+          </a:p>
+          <a:p>
+            <a:pPr>
+              <a:defRPr sz="1050" b="1">
+                <a:solidFill>
+                  <a:srgbClr val="1E293B"/>
+                </a:solidFill>
+              </a:defRPr>
+            </a:pPr>
+            <a:r>
+              <a:t>Luận điểm bài báo Halpin:</a:t>
+            </a:r>
+          </a:p>
+          <a:p>
+            <a:pPr>
+              <a:spcAft>
+                <a:spcPts val="800"/>
+              </a:spcAft>
+              <a:defRPr sz="950">
                 <a:solidFill>
                   <a:srgbClr val="475569"/>
                 </a:solidFill>
-              </a:rPr>
-              <a:t>Code DT005: Khảo sát đo lường 5 vòng so sánh chuỗi naive vs hàm thời gian hằng số hmac.compare_digest. </a:t>
-            </a:r>
-          </a:p>
-          <a:p>
-            <a:pPr>
-              <a:spcBef>
-                <a:spcPts val="200"/>
-              </a:spcBef>
-            </a:pPr>
-            <a:r>
-              <a:rPr b="1" sz="950">
-                <a:solidFill>
-                  <a:srgbClr val="059669"/>
-                </a:solidFill>
-              </a:rPr>
-              <a:t>   ► Bằng chứng đã chạy: Naive so sánh tuần tự lộ độ lệch trung vị ~0.08 µs; hmac.compare_digest triệt tiêu độ lệch.  |  </a:t>
-            </a:r>
-            <a:r>
-              <a:rPr sz="950">
-                <a:solidFill>
-                  <a:srgbClr val="D97706"/>
-                </a:solidFill>
-              </a:rPr>
-              <a:t>▲ Giới hạn diễn giải: Phép đo trên Python máy đơn có jitter; chỉ minh họa mức thư viện C, không chứng minh miễn nhiễm kênh kề phần cứng.</a:t>
+              </a:defRPr>
+            </a:pPr>
+            <a:r>
+              <a:t>Ghép chuỗi thô H(L || R) khiến kẻ thù có thể đánh tráo nút nhánh nội bộ thành nút lá, gây va chạm cấu trúc tầng cây.</a:t>
+            </a:r>
+          </a:p>
+          <a:p>
+            <a:pPr>
+              <a:defRPr sz="1050" b="1">
+                <a:solidFill>
+                  <a:srgbClr val="1E293B"/>
+                </a:solidFill>
+              </a:defRPr>
+            </a:pPr>
+            <a:r>
+              <a:t>Minh họa thực nghiệm DT005:</a:t>
+            </a:r>
+          </a:p>
+          <a:p>
+            <a:pPr>
+              <a:spcAft>
+                <a:spcPts val="800"/>
+              </a:spcAft>
+              <a:defRPr sz="950">
+                <a:solidFill>
+                  <a:srgbClr val="475569"/>
+                </a:solidFill>
+              </a:defRPr>
+            </a:pPr>
+            <a:r>
+              <a:t>Cài đặt phân tách miền chuẩn RFC 6962: gắn tiền tố 0x00 cho nút lá và 0x01 cho nút nhánh để triệt tiêu hoàn toàn nhập nhằng.</a:t>
+            </a:r>
+          </a:p>
+          <a:p>
+            <a:pPr>
+              <a:defRPr sz="1050" b="1">
+                <a:solidFill>
+                  <a:srgbClr val="1E293B"/>
+                </a:solidFill>
+              </a:defRPr>
+            </a:pPr>
+            <a:r>
+              <a:t>Giới hạn diễn giải:</a:t>
+            </a:r>
+          </a:p>
+          <a:p>
+            <a:pPr>
+              <a:defRPr sz="950">
+                <a:solidFill>
+                  <a:srgbClr val="64748B"/>
+                </a:solidFill>
+              </a:defRPr>
+            </a:pPr>
+            <a:r>
+              <a:t>Chỉ giải quyết va chạm cấu trúc tầng cây Merkle; không loại trừ va chạm ngẫu nhiên 2^256 của SHA-256.</a:t>
+            </a:r>
+          </a:p>
+        </p:txBody>
+      </p:sp>
+      <p:sp>
+        <p:nvSpPr>
+          <p:cNvPr id="10" name="Rounded Rectangle 9"/>
+          <p:cNvSpPr/>
+          <p:nvPr/>
+        </p:nvSpPr>
+        <p:spPr>
+          <a:xfrm>
+            <a:off x="8046720" y="1691640"/>
+            <a:ext cx="3383280" cy="4389120"/>
+          </a:xfrm>
+          <a:prstGeom prst="roundRect">
+            <a:avLst/>
+          </a:prstGeom>
+          <a:solidFill>
+            <a:srgbClr val="F8FAFC"/>
+          </a:solidFill>
+          <a:ln>
+            <a:solidFill>
+              <a:srgbClr val="E2E8F0"/>
+            </a:solidFill>
+          </a:ln>
+        </p:spPr>
+        <p:style>
+          <a:lnRef idx="1">
+            <a:schemeClr val="accent1"/>
+          </a:lnRef>
+          <a:fillRef idx="3">
+            <a:schemeClr val="accent1"/>
+          </a:fillRef>
+          <a:effectRef idx="2">
+            <a:schemeClr val="accent1"/>
+          </a:effectRef>
+          <a:fontRef idx="minor">
+            <a:schemeClr val="lt1"/>
+          </a:fontRef>
+        </p:style>
+        <p:txBody>
+          <a:bodyPr rtlCol="0" anchor="ctr"/>
+          <a:lstStyle/>
+          <a:p>
+            <a:pPr algn="ctr"/>
+          </a:p>
+        </p:txBody>
+      </p:sp>
+      <p:sp>
+        <p:nvSpPr>
+          <p:cNvPr id="11" name="TextBox 10"/>
+          <p:cNvSpPr txBox="1"/>
+          <p:nvPr/>
+        </p:nvSpPr>
+        <p:spPr>
+          <a:xfrm>
+            <a:off x="8229600" y="1828800"/>
+            <a:ext cx="3017520" cy="4114800"/>
+          </a:xfrm>
+          <a:prstGeom prst="rect">
+            <a:avLst/>
+          </a:prstGeom>
+          <a:noFill/>
+        </p:spPr>
+        <p:txBody>
+          <a:bodyPr wrap="square">
+            <a:spAutoFit/>
+          </a:bodyPr>
+          <a:lstStyle/>
+          <a:p>
+            <a:pPr>
+              <a:spcAft>
+                <a:spcPts val="1000"/>
+              </a:spcAft>
+              <a:defRPr sz="1200" b="1">
+                <a:solidFill>
+                  <a:srgbClr val="0F172A"/>
+                </a:solidFill>
+              </a:defRPr>
+            </a:pPr>
+            <a:r>
+              <a:t>3. KÊNH KỀ THỜI GIAN SO SÁNH</a:t>
+            </a:r>
+          </a:p>
+          <a:p>
+            <a:pPr>
+              <a:defRPr sz="1050" b="1">
+                <a:solidFill>
+                  <a:srgbClr val="1E293B"/>
+                </a:solidFill>
+              </a:defRPr>
+            </a:pPr>
+            <a:r>
+              <a:t>Luận điểm bài báo Halpin:</a:t>
+            </a:r>
+          </a:p>
+          <a:p>
+            <a:pPr>
+              <a:spcAft>
+                <a:spcPts val="800"/>
+              </a:spcAft>
+              <a:defRPr sz="950">
+                <a:solidFill>
+                  <a:srgbClr val="475569"/>
+                </a:solidFill>
+              </a:defRPr>
+            </a:pPr>
+            <a:r>
+              <a:t>Lý thuyết xem mật mã là hàm toán học lý tưởng, nhưng thực tế việc dừng sớm (early-return) làm rò rỉ dữ liệu qua thời gian thực thi.</a:t>
+            </a:r>
+          </a:p>
+          <a:p>
+            <a:pPr>
+              <a:defRPr sz="1050" b="1">
+                <a:solidFill>
+                  <a:srgbClr val="1E293B"/>
+                </a:solidFill>
+              </a:defRPr>
+            </a:pPr>
+            <a:r>
+              <a:t>Minh họa thực nghiệm DT005:</a:t>
+            </a:r>
+          </a:p>
+          <a:p>
+            <a:pPr>
+              <a:spcAft>
+                <a:spcPts val="800"/>
+              </a:spcAft>
+              <a:defRPr sz="950">
+                <a:solidFill>
+                  <a:srgbClr val="475569"/>
+                </a:solidFill>
+              </a:defRPr>
+            </a:pPr>
+            <a:r>
+              <a:t>Đo đạc 5 vòng so sánh chuỗi tuần tự (lộ chênh lệch thời gian) so với hàm thời gian hằng số hmac.compare_digest triệt tiêu độ lệch.</a:t>
+            </a:r>
+          </a:p>
+          <a:p>
+            <a:pPr>
+              <a:defRPr sz="1050" b="1">
+                <a:solidFill>
+                  <a:srgbClr val="1E293B"/>
+                </a:solidFill>
+              </a:defRPr>
+            </a:pPr>
+            <a:r>
+              <a:t>Giới hạn diễn giải:</a:t>
+            </a:r>
+          </a:p>
+          <a:p>
+            <a:pPr>
+              <a:defRPr sz="950">
+                <a:solidFill>
+                  <a:srgbClr val="64748B"/>
+                </a:solidFill>
+              </a:defRPr>
+            </a:pPr>
+            <a:r>
+              <a:t>Đo đạc trên máy tính đơn có nhiễu hệ điều hành; chỉ minh họa ở mức thư viện phần mềm, không phải phần cứng.</a:t>
             </a:r>
           </a:p>
         </p:txBody>
@@ -4593,7 +4650,7 @@
               </a:defRPr>
             </a:pPr>
             <a:r>
-              <a:t>Sơ đồ và bảng đối chiếu do sinh viên tự xây dựng; chi tiết mã nguồn lưu tại MIDTERM_CODE_AUDIT.md.</a:t>
+              <a:t>Bảng đối chiếu minh bạch do sinh viên tự xây dựng; chi tiết mã nguồn lưu tại MIDTERM_CODE_AUDIT.md.</a:t>
             </a:r>
           </a:p>
         </p:txBody>
@@ -4631,7 +4688,7 @@
             <a:avLst/>
           </a:prstGeom>
           <a:solidFill>
-            <a:srgbClr val="0F172A"/>
+            <a:srgbClr val="FFFFFF"/>
           </a:solidFill>
           <a:ln>
             <a:noFill/>
@@ -4661,14 +4718,59 @@
       </p:sp>
       <p:sp>
         <p:nvSpPr>
-          <p:cNvPr id="3" name="TextBox 2"/>
+          <p:cNvPr id="3" name="Rounded Rectangle 2"/>
+          <p:cNvSpPr/>
+          <p:nvPr/>
+        </p:nvSpPr>
+        <p:spPr>
+          <a:xfrm>
+            <a:off x="1371600" y="1371600"/>
+            <a:ext cx="9448495" cy="4114800"/>
+          </a:xfrm>
+          <a:prstGeom prst="roundRect">
+            <a:avLst/>
+          </a:prstGeom>
+          <a:solidFill>
+            <a:srgbClr val="F8FAFC"/>
+          </a:solidFill>
+          <a:ln>
+            <a:solidFill>
+              <a:srgbClr val="BFDBFE"/>
+            </a:solidFill>
+          </a:ln>
+        </p:spPr>
+        <p:style>
+          <a:lnRef idx="1">
+            <a:schemeClr val="accent1"/>
+          </a:lnRef>
+          <a:fillRef idx="3">
+            <a:schemeClr val="accent1"/>
+          </a:fillRef>
+          <a:effectRef idx="2">
+            <a:schemeClr val="accent1"/>
+          </a:effectRef>
+          <a:fontRef idx="minor">
+            <a:schemeClr val="lt1"/>
+          </a:fontRef>
+        </p:style>
+        <p:txBody>
+          <a:bodyPr rtlCol="0" anchor="ctr"/>
+          <a:lstStyle/>
+          <a:p>
+            <a:pPr algn="ctr"/>
+          </a:p>
+        </p:txBody>
+      </p:sp>
+      <p:sp>
+        <p:nvSpPr>
+          <p:cNvPr id="4" name="TextBox 3"/>
           <p:cNvSpPr txBox="1"/>
           <p:nvPr/>
         </p:nvSpPr>
         <p:spPr>
           <a:xfrm>
-            <a:off x="1371600" y="2011680"/>
-            <a:ext cx="9448495" cy="2743200"/>
+            <a:off x="1645920" y="1645920"/>
+            <a:ext cx="8899855" cy="3566160"/>
           </a:xfrm>
           <a:prstGeom prst="rect">
             <a:avLst/>
@@ -4682,9 +4784,9 @@
           <a:lstStyle/>
           <a:p>
             <a:pPr algn="ctr">
-              <a:defRPr sz="1300" b="1">
-                <a:solidFill>
-                  <a:srgbClr val="38BDF8"/>
+              <a:defRPr sz="1200" b="1">
+                <a:solidFill>
+                  <a:srgbClr val="1E40AF"/>
                 </a:solidFill>
               </a:defRPr>
             </a:pPr>
@@ -4695,11 +4797,11 @@
           <a:p>
             <a:pPr algn="ctr">
               <a:spcBef>
-                <a:spcPts val="1600"/>
+                <a:spcPts val="1400"/>
               </a:spcBef>
               <a:defRPr sz="6400" b="1">
                 <a:solidFill>
-                  <a:srgbClr val="FFFFFF"/>
+                  <a:srgbClr val="0F172A"/>
                 </a:solidFill>
               </a:defRPr>
             </a:pPr>
@@ -4710,11 +4812,11 @@
           <a:p>
             <a:pPr algn="ctr">
               <a:spcBef>
-                <a:spcPts val="1600"/>
+                <a:spcPts val="1400"/>
               </a:spcBef>
               <a:defRPr sz="1500" b="1">
                 <a:solidFill>
-                  <a:srgbClr val="E2E8F0"/>
+                  <a:srgbClr val="1E293B"/>
                 </a:solidFill>
               </a:defRPr>
             </a:pPr>
@@ -4725,16 +4827,31 @@
           <a:p>
             <a:pPr algn="ctr">
               <a:spcBef>
-                <a:spcPts val="800"/>
+                <a:spcPts val="1000"/>
               </a:spcBef>
               <a:defRPr sz="1100" i="1">
                 <a:solidFill>
-                  <a:srgbClr val="94A3B8"/>
+                  <a:srgbClr val="475569"/>
                 </a:solidFill>
               </a:defRPr>
             </a:pPr>
             <a:r>
               <a:t>Minh họa thực nghiệm các luận điểm lý thuyết: Can thiệp dữ liệu, Nhập nhằng nút lá RFC 6962, và So sánh chuỗi thời gian hằng số</a:t>
+            </a:r>
+          </a:p>
+          <a:p>
+            <a:pPr algn="ctr">
+              <a:spcBef>
+                <a:spcPts val="1200"/>
+              </a:spcBef>
+              <a:defRPr sz="1050" b="1">
+                <a:solidFill>
+                  <a:srgbClr val="1E40AF"/>
+                </a:solidFill>
+              </a:defRPr>
+            </a:pPr>
+            <a:r>
+              <a:t>Blue Team Dashboard: http://localhost:8080   |   Red Team Adversary Engine: http://localhost:8081</a:t>
             </a:r>
           </a:p>
         </p:txBody>
@@ -4924,51 +5041,30 @@
           </a:p>
         </p:txBody>
       </p:sp>
-      <p:sp>
-        <p:nvSpPr>
-          <p:cNvPr id="6" name="Rounded Rectangle 5"/>
-          <p:cNvSpPr/>
-          <p:nvPr/>
-        </p:nvSpPr>
-        <p:spPr>
-          <a:xfrm>
-            <a:off x="731520" y="1691640"/>
-            <a:ext cx="5212080" cy="4343400"/>
-          </a:xfrm>
-          <a:prstGeom prst="roundRect">
-            <a:avLst/>
-          </a:prstGeom>
-          <a:solidFill>
-            <a:srgbClr val="F8FAFC"/>
-          </a:solidFill>
-          <a:ln>
-            <a:solidFill>
-              <a:srgbClr val="BFDBFE"/>
-            </a:solidFill>
-          </a:ln>
-        </p:spPr>
-        <p:style>
-          <a:lnRef idx="1">
-            <a:schemeClr val="accent1"/>
-          </a:lnRef>
-          <a:fillRef idx="3">
-            <a:schemeClr val="accent1"/>
-          </a:fillRef>
-          <a:effectRef idx="2">
-            <a:schemeClr val="accent1"/>
-          </a:effectRef>
-          <a:fontRef idx="minor">
-            <a:schemeClr val="lt1"/>
-          </a:fontRef>
-        </p:style>
-        <p:txBody>
-          <a:bodyPr rtlCol="0" anchor="ctr"/>
-          <a:lstStyle/>
-          <a:p>
-            <a:pPr algn="ctr"/>
-          </a:p>
-        </p:txBody>
-      </p:sp>
+      <p:pic>
+        <p:nvPicPr>
+          <p:cNvPr id="6" name="Picture 5" descr="Slide14.drawio.png"/>
+          <p:cNvPicPr>
+            <a:picLocks noChangeAspect="1"/>
+          </p:cNvPicPr>
+          <p:nvPr/>
+        </p:nvPicPr>
+        <p:blipFill>
+          <a:blip r:embed="rId2"/>
+          <a:stretch>
+            <a:fillRect/>
+          </a:stretch>
+        </p:blipFill>
+        <p:spPr>
+          <a:xfrm>
+            <a:off x="1386687" y="1664208"/>
+            <a:ext cx="9418320" cy="4425696"/>
+          </a:xfrm>
+          <a:prstGeom prst="rect">
+            <a:avLst/>
+          </a:prstGeom>
+        </p:spPr>
+      </p:pic>
       <p:sp>
         <p:nvSpPr>
           <p:cNvPr id="7" name="TextBox 6"/>
@@ -4977,8 +5073,8 @@
         </p:nvSpPr>
         <p:spPr>
           <a:xfrm>
-            <a:off x="914400" y="1783080"/>
-            <a:ext cx="4846320" cy="365760"/>
+            <a:off x="731520" y="6217920"/>
+            <a:ext cx="10698480" cy="365760"/>
           </a:xfrm>
           <a:prstGeom prst="rect">
             <a:avLst/>
@@ -4992,703 +5088,6 @@
           <a:lstStyle/>
           <a:p>
             <a:pPr>
-              <a:defRPr sz="1200" b="1">
-                <a:solidFill>
-                  <a:srgbClr val="1E40AF"/>
-                </a:solidFill>
-              </a:defRPr>
-            </a:pPr>
-            <a:r>
-              <a:t>BLUE TEAM — HỆ THỐNG PHÒNG THỦ (PORT 8080)</a:t>
-            </a:r>
-          </a:p>
-        </p:txBody>
-      </p:sp>
-      <p:sp>
-        <p:nvSpPr>
-          <p:cNvPr id="8" name="Rounded Rectangle 7"/>
-          <p:cNvSpPr/>
-          <p:nvPr/>
-        </p:nvSpPr>
-        <p:spPr>
-          <a:xfrm>
-            <a:off x="1005840" y="2240280"/>
-            <a:ext cx="2194560" cy="594360"/>
-          </a:xfrm>
-          <a:prstGeom prst="roundRect">
-            <a:avLst/>
-          </a:prstGeom>
-          <a:solidFill>
-            <a:srgbClr val="FFFFFF"/>
-          </a:solidFill>
-          <a:ln>
-            <a:solidFill>
-              <a:srgbClr val="2563EB"/>
-            </a:solidFill>
-          </a:ln>
-        </p:spPr>
-        <p:style>
-          <a:lnRef idx="1">
-            <a:schemeClr val="accent1"/>
-          </a:lnRef>
-          <a:fillRef idx="3">
-            <a:schemeClr val="accent1"/>
-          </a:fillRef>
-          <a:effectRef idx="2">
-            <a:schemeClr val="accent1"/>
-          </a:effectRef>
-          <a:fontRef idx="minor">
-            <a:schemeClr val="lt1"/>
-          </a:fontRef>
-        </p:style>
-        <p:txBody>
-          <a:bodyPr rtlCol="0" anchor="ctr" wrap="square" lIns="36576" rIns="36576" tIns="36576" bIns="36576"/>
-          <a:lstStyle/>
-          <a:p>
-            <a:pPr algn="ctr">
-              <a:defRPr sz="950" b="1">
-                <a:solidFill>
-                  <a:srgbClr val="1E40AF"/>
-                </a:solidFill>
-              </a:defRPr>
-            </a:pPr>
-            <a:r>
-              <a:t>Tập Dữ Liệu Giám Sát</a:t>
-            </a:r>
-          </a:p>
-          <a:p>
-            <a:pPr algn="ctr">
-              <a:defRPr sz="950" b="0">
-                <a:solidFill>
-                  <a:srgbClr val="1E40AF"/>
-                </a:solidFill>
-              </a:defRPr>
-            </a:pPr>
-            <a:r>
-              <a:t>(2.483 tệp / 112.81 MB)</a:t>
-            </a:r>
-          </a:p>
-        </p:txBody>
-      </p:sp>
-      <p:sp>
-        <p:nvSpPr>
-          <p:cNvPr id="9" name="Rounded Rectangle 8"/>
-          <p:cNvSpPr/>
-          <p:nvPr/>
-        </p:nvSpPr>
-        <p:spPr>
-          <a:xfrm>
-            <a:off x="3474720" y="2240280"/>
-            <a:ext cx="2194560" cy="594360"/>
-          </a:xfrm>
-          <a:prstGeom prst="roundRect">
-            <a:avLst/>
-          </a:prstGeom>
-          <a:solidFill>
-            <a:srgbClr val="FFFFFF"/>
-          </a:solidFill>
-          <a:ln>
-            <a:solidFill>
-              <a:srgbClr val="1E40AF"/>
-            </a:solidFill>
-          </a:ln>
-        </p:spPr>
-        <p:style>
-          <a:lnRef idx="1">
-            <a:schemeClr val="accent1"/>
-          </a:lnRef>
-          <a:fillRef idx="3">
-            <a:schemeClr val="accent1"/>
-          </a:fillRef>
-          <a:effectRef idx="2">
-            <a:schemeClr val="accent1"/>
-          </a:effectRef>
-          <a:fontRef idx="minor">
-            <a:schemeClr val="lt1"/>
-          </a:fontRef>
-        </p:style>
-        <p:txBody>
-          <a:bodyPr rtlCol="0" anchor="ctr" wrap="square" lIns="36576" rIns="36576" tIns="36576" bIns="36576"/>
-          <a:lstStyle/>
-          <a:p>
-            <a:pPr algn="ctr">
-              <a:defRPr sz="950" b="1">
-                <a:solidFill>
-                  <a:srgbClr val="1E40AF"/>
-                </a:solidFill>
-              </a:defRPr>
-            </a:pPr>
-            <a:r>
-              <a:t>Động Cơ Xác Thực</a:t>
-            </a:r>
-          </a:p>
-          <a:p>
-            <a:pPr algn="ctr">
-              <a:defRPr sz="950" b="0">
-                <a:solidFill>
-                  <a:srgbClr val="1E40AF"/>
-                </a:solidFill>
-              </a:defRPr>
-            </a:pPr>
-            <a:r>
-              <a:t>(SHA-256 / HMAC / Merkle)</a:t>
-            </a:r>
-          </a:p>
-        </p:txBody>
-      </p:sp>
-      <p:sp>
-        <p:nvSpPr>
-          <p:cNvPr id="10" name="Rounded Rectangle 9"/>
-          <p:cNvSpPr/>
-          <p:nvPr/>
-        </p:nvSpPr>
-        <p:spPr>
-          <a:xfrm>
-            <a:off x="1005840" y="2971800"/>
-            <a:ext cx="4663440" cy="502920"/>
-          </a:xfrm>
-          <a:prstGeom prst="roundRect">
-            <a:avLst/>
-          </a:prstGeom>
-          <a:solidFill>
-            <a:srgbClr val="ECFDF5"/>
-          </a:solidFill>
-          <a:ln>
-            <a:solidFill>
-              <a:srgbClr val="059669"/>
-            </a:solidFill>
-          </a:ln>
-        </p:spPr>
-        <p:style>
-          <a:lnRef idx="1">
-            <a:schemeClr val="accent1"/>
-          </a:lnRef>
-          <a:fillRef idx="3">
-            <a:schemeClr val="accent1"/>
-          </a:fillRef>
-          <a:effectRef idx="2">
-            <a:schemeClr val="accent1"/>
-          </a:effectRef>
-          <a:fontRef idx="minor">
-            <a:schemeClr val="lt1"/>
-          </a:fontRef>
-        </p:style>
-        <p:txBody>
-          <a:bodyPr rtlCol="0" anchor="ctr" wrap="square" lIns="36576" rIns="36576" tIns="36576" bIns="36576"/>
-          <a:lstStyle/>
-          <a:p>
-            <a:pPr algn="ctr">
-              <a:defRPr sz="900" b="1">
-                <a:solidFill>
-                  <a:srgbClr val="047857"/>
-                </a:solidFill>
-              </a:defRPr>
-            </a:pPr>
-            <a:r>
-              <a:t>Mốc Tin Cậy Ban Đầu: Root Hash H_0 (Trạng thái: 100% NGUYÊN VẸN)</a:t>
-            </a:r>
-          </a:p>
-          <a:p>
-            <a:pPr algn="ctr">
-              <a:defRPr sz="900" b="0">
-                <a:solidFill>
-                  <a:srgbClr val="047857"/>
-                </a:solidFill>
-              </a:defRPr>
-            </a:pPr>
-            <a:r>
-              <a:t>Định vị sai lệch O(log N) qua Dirty Path trong ~1.06 ms (2.325 tệp/giây)</a:t>
-            </a:r>
-          </a:p>
-        </p:txBody>
-      </p:sp>
-      <p:sp>
-        <p:nvSpPr>
-          <p:cNvPr id="11" name="TextBox 10"/>
-          <p:cNvSpPr txBox="1"/>
-          <p:nvPr/>
-        </p:nvSpPr>
-        <p:spPr>
-          <a:xfrm>
-            <a:off x="914400" y="3611880"/>
-            <a:ext cx="4846320" cy="2286000"/>
-          </a:xfrm>
-          <a:prstGeom prst="rect">
-            <a:avLst/>
-          </a:prstGeom>
-          <a:noFill/>
-        </p:spPr>
-        <p:txBody>
-          <a:bodyPr wrap="square">
-            <a:spAutoFit/>
-          </a:bodyPr>
-          <a:lstStyle/>
-          <a:p/>
-          <a:p>
-            <a:pPr>
-              <a:spcBef>
-                <a:spcPts val="400"/>
-              </a:spcBef>
-            </a:pPr>
-            <a:r>
-              <a:rPr b="1" sz="1000">
-                <a:solidFill>
-                  <a:srgbClr val="1E293B"/>
-                </a:solidFill>
-              </a:rPr>
-              <a:t>• Kịch bản 1 (CRC32): </a:t>
-            </a:r>
-            <a:r>
-              <a:rPr sz="950">
-                <a:solidFill>
-                  <a:srgbClr val="475569"/>
-                </a:solidFill>
-              </a:rPr>
-              <a:t>Red Team bù 4 byte GF(2); Blue Team dùng SHA-256 bắt quả tang tức thì.</a:t>
-            </a:r>
-          </a:p>
-          <a:p>
-            <a:pPr>
-              <a:spcBef>
-                <a:spcPts val="400"/>
-              </a:spcBef>
-            </a:pPr>
-            <a:r>
-              <a:rPr b="1" sz="1000">
-                <a:solidFill>
-                  <a:srgbClr val="1E293B"/>
-                </a:solidFill>
-              </a:rPr>
-              <a:t>• Kịch bản 2 (In-place Tamper): </a:t>
-            </a:r>
-            <a:r>
-              <a:rPr sz="950">
-                <a:solidFill>
-                  <a:srgbClr val="475569"/>
-                </a:solidFill>
-              </a:rPr>
-              <a:t>Sửa nội dung tệp; Blue Team phát hiện và vẽ Dirty Path O(log N).</a:t>
-            </a:r>
-          </a:p>
-          <a:p>
-            <a:pPr>
-              <a:spcBef>
-                <a:spcPts val="400"/>
-              </a:spcBef>
-            </a:pPr>
-            <a:r>
-              <a:rPr b="1" sz="1000">
-                <a:solidFill>
-                  <a:srgbClr val="1E293B"/>
-                </a:solidFill>
-              </a:rPr>
-              <a:t>• Kịch bản 3 (Dolev-Yao MitM): </a:t>
-            </a:r>
-            <a:r>
-              <a:rPr sz="950">
-                <a:solidFill>
-                  <a:srgbClr val="475569"/>
-                </a:solidFill>
-              </a:rPr>
-              <a:t>Đánh tráo Merkle Proof trên mạng; bộ xác thực từ chối 100% chữ ký.</a:t>
-            </a:r>
-          </a:p>
-        </p:txBody>
-      </p:sp>
-      <p:sp>
-        <p:nvSpPr>
-          <p:cNvPr id="12" name="Rounded Rectangle 11"/>
-          <p:cNvSpPr/>
-          <p:nvPr/>
-        </p:nvSpPr>
-        <p:spPr>
-          <a:xfrm>
-            <a:off x="6217920" y="1691640"/>
-            <a:ext cx="5212080" cy="4343400"/>
-          </a:xfrm>
-          <a:prstGeom prst="roundRect">
-            <a:avLst/>
-          </a:prstGeom>
-          <a:solidFill>
-            <a:srgbClr val="ECFDF5"/>
-          </a:solidFill>
-          <a:ln>
-            <a:solidFill>
-              <a:srgbClr val="A7F3D0"/>
-            </a:solidFill>
-          </a:ln>
-        </p:spPr>
-        <p:style>
-          <a:lnRef idx="1">
-            <a:schemeClr val="accent1"/>
-          </a:lnRef>
-          <a:fillRef idx="3">
-            <a:schemeClr val="accent1"/>
-          </a:fillRef>
-          <a:effectRef idx="2">
-            <a:schemeClr val="accent1"/>
-          </a:effectRef>
-          <a:fontRef idx="minor">
-            <a:schemeClr val="lt1"/>
-          </a:fontRef>
-        </p:style>
-        <p:txBody>
-          <a:bodyPr rtlCol="0" anchor="ctr"/>
-          <a:lstStyle/>
-          <a:p>
-            <a:pPr algn="ctr"/>
-          </a:p>
-        </p:txBody>
-      </p:sp>
-      <p:sp>
-        <p:nvSpPr>
-          <p:cNvPr id="13" name="TextBox 12"/>
-          <p:cNvSpPr txBox="1"/>
-          <p:nvPr/>
-        </p:nvSpPr>
-        <p:spPr>
-          <a:xfrm>
-            <a:off x="6400800" y="1783080"/>
-            <a:ext cx="4846320" cy="365760"/>
-          </a:xfrm>
-          <a:prstGeom prst="rect">
-            <a:avLst/>
-          </a:prstGeom>
-          <a:noFill/>
-        </p:spPr>
-        <p:txBody>
-          <a:bodyPr wrap="none">
-            <a:spAutoFit/>
-          </a:bodyPr>
-          <a:lstStyle/>
-          <a:p>
-            <a:pPr>
-              <a:defRPr sz="1200" b="1">
-                <a:solidFill>
-                  <a:srgbClr val="059669"/>
-                </a:solidFill>
-              </a:defRPr>
-            </a:pPr>
-            <a:r>
-              <a:t>RED TEAM — ĐỘNG CƠ TẤN CÔNG ĐỐI KHÁNG (PORT 8081)</a:t>
-            </a:r>
-          </a:p>
-        </p:txBody>
-      </p:sp>
-      <p:sp>
-        <p:nvSpPr>
-          <p:cNvPr id="14" name="Rounded Rectangle 13"/>
-          <p:cNvSpPr/>
-          <p:nvPr/>
-        </p:nvSpPr>
-        <p:spPr>
-          <a:xfrm>
-            <a:off x="6492240" y="2240280"/>
-            <a:ext cx="2194560" cy="594360"/>
-          </a:xfrm>
-          <a:prstGeom prst="roundRect">
-            <a:avLst/>
-          </a:prstGeom>
-          <a:solidFill>
-            <a:srgbClr val="FEF2F2"/>
-          </a:solidFill>
-          <a:ln>
-            <a:solidFill>
-              <a:srgbClr val="DC2626"/>
-            </a:solidFill>
-          </a:ln>
-        </p:spPr>
-        <p:style>
-          <a:lnRef idx="1">
-            <a:schemeClr val="accent1"/>
-          </a:lnRef>
-          <a:fillRef idx="3">
-            <a:schemeClr val="accent1"/>
-          </a:fillRef>
-          <a:effectRef idx="2">
-            <a:schemeClr val="accent1"/>
-          </a:effectRef>
-          <a:fontRef idx="minor">
-            <a:schemeClr val="lt1"/>
-          </a:fontRef>
-        </p:style>
-        <p:txBody>
-          <a:bodyPr rtlCol="0" anchor="ctr" wrap="square" lIns="36576" rIns="36576" tIns="36576" bIns="36576"/>
-          <a:lstStyle/>
-          <a:p>
-            <a:pPr algn="ctr">
-              <a:defRPr sz="950" b="1">
-                <a:solidFill>
-                  <a:srgbClr val="B91C1C"/>
-                </a:solidFill>
-              </a:defRPr>
-            </a:pPr>
-            <a:r>
-              <a:t>Adversary Engine</a:t>
-            </a:r>
-          </a:p>
-          <a:p>
-            <a:pPr algn="ctr">
-              <a:defRPr sz="950" b="0">
-                <a:solidFill>
-                  <a:srgbClr val="B91C1C"/>
-                </a:solidFill>
-              </a:defRPr>
-            </a:pPr>
-            <a:r>
-              <a:t>(6 Vector tấn công đối kháng)</a:t>
-            </a:r>
-          </a:p>
-        </p:txBody>
-      </p:sp>
-      <p:sp>
-        <p:nvSpPr>
-          <p:cNvPr id="15" name="Rounded Rectangle 14"/>
-          <p:cNvSpPr/>
-          <p:nvPr/>
-        </p:nvSpPr>
-        <p:spPr>
-          <a:xfrm>
-            <a:off x="8961120" y="2240280"/>
-            <a:ext cx="2194560" cy="594360"/>
-          </a:xfrm>
-          <a:prstGeom prst="roundRect">
-            <a:avLst/>
-          </a:prstGeom>
-          <a:solidFill>
-            <a:srgbClr val="ECFDF5"/>
-          </a:solidFill>
-          <a:ln>
-            <a:solidFill>
-              <a:srgbClr val="059669"/>
-            </a:solidFill>
-          </a:ln>
-        </p:spPr>
-        <p:style>
-          <a:lnRef idx="1">
-            <a:schemeClr val="accent1"/>
-          </a:lnRef>
-          <a:fillRef idx="3">
-            <a:schemeClr val="accent1"/>
-          </a:fillRef>
-          <a:effectRef idx="2">
-            <a:schemeClr val="accent1"/>
-          </a:effectRef>
-          <a:fontRef idx="minor">
-            <a:schemeClr val="lt1"/>
-          </a:fontRef>
-        </p:style>
-        <p:txBody>
-          <a:bodyPr rtlCol="0" anchor="ctr" wrap="square" lIns="36576" rIns="36576" tIns="36576" bIns="36576"/>
-          <a:lstStyle/>
-          <a:p>
-            <a:pPr algn="ctr">
-              <a:defRPr sz="950" b="1">
-                <a:solidFill>
-                  <a:srgbClr val="047857"/>
-                </a:solidFill>
-              </a:defRPr>
-            </a:pPr>
-            <a:r>
-              <a:t>Cơ Chế Phục Hồi An Toàn</a:t>
-            </a:r>
-          </a:p>
-          <a:p>
-            <a:pPr algn="ctr">
-              <a:defRPr sz="950" b="0">
-                <a:solidFill>
-                  <a:srgbClr val="047857"/>
-                </a:solidFill>
-              </a:defRPr>
-            </a:pPr>
-            <a:r>
-              <a:t>(Nút ROLLBACK ALL 100%)</a:t>
-            </a:r>
-          </a:p>
-        </p:txBody>
-      </p:sp>
-      <p:sp>
-        <p:nvSpPr>
-          <p:cNvPr id="16" name="Rounded Rectangle 15"/>
-          <p:cNvSpPr/>
-          <p:nvPr/>
-        </p:nvSpPr>
-        <p:spPr>
-          <a:xfrm>
-            <a:off x="6492240" y="2971800"/>
-            <a:ext cx="4663440" cy="502920"/>
-          </a:xfrm>
-          <a:prstGeom prst="roundRect">
-            <a:avLst/>
-          </a:prstGeom>
-          <a:solidFill>
-            <a:srgbClr val="FFFFFF"/>
-          </a:solidFill>
-          <a:ln>
-            <a:solidFill>
-              <a:srgbClr val="E2E8F0"/>
-            </a:solidFill>
-          </a:ln>
-        </p:spPr>
-        <p:style>
-          <a:lnRef idx="1">
-            <a:schemeClr val="accent1"/>
-          </a:lnRef>
-          <a:fillRef idx="3">
-            <a:schemeClr val="accent1"/>
-          </a:fillRef>
-          <a:effectRef idx="2">
-            <a:schemeClr val="accent1"/>
-          </a:effectRef>
-          <a:fontRef idx="minor">
-            <a:schemeClr val="lt1"/>
-          </a:fontRef>
-        </p:style>
-        <p:txBody>
-          <a:bodyPr rtlCol="0" anchor="ctr" wrap="square" lIns="36576" rIns="36576" tIns="36576" bIns="36576"/>
-          <a:lstStyle/>
-          <a:p>
-            <a:pPr algn="ctr">
-              <a:defRPr sz="900" b="1">
-                <a:solidFill>
-                  <a:srgbClr val="0F172A"/>
-                </a:solidFill>
-              </a:defRPr>
-            </a:pPr>
-            <a:r>
-              <a:t>[LOG KIỂM ĐỊNH TOÁN HỌC: 7/7 THÍ NGHIỆM ĐẠT CHUẨN]</a:t>
-            </a:r>
-          </a:p>
-          <a:p>
-            <a:pPr algn="ctr">
-              <a:defRPr sz="900" b="0">
-                <a:solidFill>
-                  <a:srgbClr val="0F172A"/>
-                </a:solidFill>
-              </a:defRPr>
-            </a:pPr>
-            <a:r>
-              <a:t>PPT Integrity: 100% phát hiện | RFC 6962: Chặn Node-Leaf | SAC: 50.00% | Time: 2,885 ms</a:t>
-            </a:r>
-          </a:p>
-        </p:txBody>
-      </p:sp>
-      <p:sp>
-        <p:nvSpPr>
-          <p:cNvPr id="17" name="TextBox 16"/>
-          <p:cNvSpPr txBox="1"/>
-          <p:nvPr/>
-        </p:nvSpPr>
-        <p:spPr>
-          <a:xfrm>
-            <a:off x="6400800" y="3611880"/>
-            <a:ext cx="4846320" cy="2286000"/>
-          </a:xfrm>
-          <a:prstGeom prst="rect">
-            <a:avLst/>
-          </a:prstGeom>
-          <a:noFill/>
-        </p:spPr>
-        <p:txBody>
-          <a:bodyPr wrap="square">
-            <a:spAutoFit/>
-          </a:bodyPr>
-          <a:lstStyle/>
-          <a:p/>
-          <a:p>
-            <a:pPr>
-              <a:spcBef>
-                <a:spcPts val="400"/>
-              </a:spcBef>
-            </a:pPr>
-            <a:r>
-              <a:rPr b="1" sz="1000">
-                <a:solidFill>
-                  <a:srgbClr val="1E293B"/>
-                </a:solidFill>
-              </a:rPr>
-              <a:t>• Bản chất minh họa: </a:t>
-            </a:r>
-            <a:r>
-              <a:rPr sz="950">
-                <a:solidFill>
-                  <a:srgbClr val="475569"/>
-                </a:solidFill>
-              </a:rPr>
-              <a:t>Thực nghiệm độc lập kiểm chứng logic các khái niệm; không phải chạy lại số liệu bài báo.</a:t>
-            </a:r>
-          </a:p>
-          <a:p>
-            <a:pPr>
-              <a:spcBef>
-                <a:spcPts val="400"/>
-              </a:spcBef>
-            </a:pPr>
-            <a:r>
-              <a:rPr b="1" sz="1000">
-                <a:solidFill>
-                  <a:srgbClr val="1E293B"/>
-                </a:solidFill>
-              </a:rPr>
-              <a:t>• Môi trường đo đạc: </a:t>
-            </a:r>
-            <a:r>
-              <a:rPr sz="950">
-                <a:solidFill>
-                  <a:srgbClr val="475569"/>
-                </a:solidFill>
-              </a:rPr>
-              <a:t>CPU Intel i7, Windows 11; tốc độ duyệt đạt 2.325 tệp/giây trên kaggle_dataset.</a:t>
-            </a:r>
-          </a:p>
-          <a:p>
-            <a:pPr>
-              <a:spcBef>
-                <a:spcPts val="400"/>
-              </a:spcBef>
-            </a:pPr>
-            <a:r>
-              <a:rPr b="1" sz="1000">
-                <a:solidFill>
-                  <a:srgbClr val="1E293B"/>
-                </a:solidFill>
-              </a:rPr>
-              <a:t>• Kịch bản thao tác: </a:t>
-            </a:r>
-            <a:r>
-              <a:rPr sz="950">
-                <a:solidFill>
-                  <a:srgbClr val="475569"/>
-                </a:solidFill>
-              </a:rPr>
-              <a:t>Hướng dẫn lệnh chạy và quy trình demo 2 màn hình xem tại MIDTERM_DEMO.md.</a:t>
-            </a:r>
-          </a:p>
-        </p:txBody>
-      </p:sp>
-      <p:sp>
-        <p:nvSpPr>
-          <p:cNvPr id="18" name="TextBox 17"/>
-          <p:cNvSpPr txBox="1"/>
-          <p:nvPr/>
-        </p:nvSpPr>
-        <p:spPr>
-          <a:xfrm>
-            <a:off x="731520" y="6217920"/>
-            <a:ext cx="10698480" cy="365760"/>
-          </a:xfrm>
-          <a:prstGeom prst="rect">
-            <a:avLst/>
-          </a:prstGeom>
-          <a:noFill/>
-        </p:spPr>
-        <p:txBody>
-          <a:bodyPr wrap="none">
-            <a:spAutoFit/>
-          </a:bodyPr>
-          <a:lstStyle/>
-          <a:p>
-            <a:pPr>
               <a:defRPr sz="1000" i="1">
                 <a:solidFill>
                   <a:srgbClr val="64748B"/>
@@ -5696,7 +5095,7 @@
               </a:defRPr>
             </a:pPr>
             <a:r>
-              <a:t>Số liệu thực tế đo đạc trực tiếp từ mã nguồn DT005. [Mã nguồn sơ đồ draw.io lưu tại docs/diagram_slide_14_adversary_architecture.drawio]</a:t>
+              <a:t>Sơ đồ kiến trúc kiểm thử đối kháng do sinh viên tự thiết kế minh họa các luận điểm của Halpin (2025).</a:t>
             </a:r>
           </a:p>
         </p:txBody>
@@ -8624,51 +8023,30 @@
           </a:p>
         </p:txBody>
       </p:sp>
-      <p:sp>
-        <p:nvSpPr>
-          <p:cNvPr id="6" name="Rounded Rectangle 5"/>
-          <p:cNvSpPr/>
-          <p:nvPr/>
-        </p:nvSpPr>
-        <p:spPr>
-          <a:xfrm>
-            <a:off x="731520" y="1691640"/>
-            <a:ext cx="5212080" cy="4343400"/>
-          </a:xfrm>
-          <a:prstGeom prst="roundRect">
-            <a:avLst/>
-          </a:prstGeom>
-          <a:solidFill>
-            <a:srgbClr val="F8FAFC"/>
-          </a:solidFill>
-          <a:ln>
-            <a:solidFill>
-              <a:srgbClr val="BFDBFE"/>
-            </a:solidFill>
-          </a:ln>
-        </p:spPr>
-        <p:style>
-          <a:lnRef idx="1">
-            <a:schemeClr val="accent1"/>
-          </a:lnRef>
-          <a:fillRef idx="3">
-            <a:schemeClr val="accent1"/>
-          </a:fillRef>
-          <a:effectRef idx="2">
-            <a:schemeClr val="accent1"/>
-          </a:effectRef>
-          <a:fontRef idx="minor">
-            <a:schemeClr val="lt1"/>
-          </a:fontRef>
-        </p:style>
-        <p:txBody>
-          <a:bodyPr rtlCol="0" anchor="ctr"/>
-          <a:lstStyle/>
-          <a:p>
-            <a:pPr algn="ctr"/>
-          </a:p>
-        </p:txBody>
-      </p:sp>
+      <p:pic>
+        <p:nvPicPr>
+          <p:cNvPr id="6" name="Picture 5" descr="Slide6.drawio.png"/>
+          <p:cNvPicPr>
+            <a:picLocks noChangeAspect="1"/>
+          </p:cNvPicPr>
+          <p:nvPr/>
+        </p:nvPicPr>
+        <p:blipFill>
+          <a:blip r:embed="rId2"/>
+          <a:stretch>
+            <a:fillRect/>
+          </a:stretch>
+        </p:blipFill>
+        <p:spPr>
+          <a:xfrm>
+            <a:off x="1386687" y="1664208"/>
+            <a:ext cx="9418320" cy="4425696"/>
+          </a:xfrm>
+          <a:prstGeom prst="rect">
+            <a:avLst/>
+          </a:prstGeom>
+        </p:spPr>
+      </p:pic>
       <p:sp>
         <p:nvSpPr>
           <p:cNvPr id="7" name="TextBox 6"/>
@@ -8677,8 +8055,8 @@
         </p:nvSpPr>
         <p:spPr>
           <a:xfrm>
-            <a:off x="914400" y="1783080"/>
-            <a:ext cx="4846320" cy="365760"/>
+            <a:off x="731520" y="6217920"/>
+            <a:ext cx="10698480" cy="365760"/>
           </a:xfrm>
           <a:prstGeom prst="rect">
             <a:avLst/>
@@ -8692,769 +8070,6 @@
           <a:lstStyle/>
           <a:p>
             <a:pPr>
-              <a:defRPr sz="1200" b="1">
-                <a:solidFill>
-                  <a:srgbClr val="1E40AF"/>
-                </a:solidFill>
-              </a:defRPr>
-            </a:pPr>
-            <a:r>
-              <a:t>1. Mô Hình Điểm - Điểm Cổ Điển Shannon (1949)</a:t>
-            </a:r>
-          </a:p>
-        </p:txBody>
-      </p:sp>
-      <p:sp>
-        <p:nvSpPr>
-          <p:cNvPr id="8" name="Rounded Rectangle 7"/>
-          <p:cNvSpPr/>
-          <p:nvPr/>
-        </p:nvSpPr>
-        <p:spPr>
-          <a:xfrm>
-            <a:off x="1005840" y="2240280"/>
-            <a:ext cx="1280160" cy="594360"/>
-          </a:xfrm>
-          <a:prstGeom prst="roundRect">
-            <a:avLst/>
-          </a:prstGeom>
-          <a:solidFill>
-            <a:srgbClr val="EFF6FF"/>
-          </a:solidFill>
-          <a:ln>
-            <a:solidFill>
-              <a:srgbClr val="2563EB"/>
-            </a:solidFill>
-          </a:ln>
-        </p:spPr>
-        <p:style>
-          <a:lnRef idx="1">
-            <a:schemeClr val="accent1"/>
-          </a:lnRef>
-          <a:fillRef idx="3">
-            <a:schemeClr val="accent1"/>
-          </a:fillRef>
-          <a:effectRef idx="2">
-            <a:schemeClr val="accent1"/>
-          </a:effectRef>
-          <a:fontRef idx="minor">
-            <a:schemeClr val="lt1"/>
-          </a:fontRef>
-        </p:style>
-        <p:txBody>
-          <a:bodyPr rtlCol="0" anchor="ctr" wrap="square" lIns="36576" rIns="36576" tIns="36576" bIns="36576"/>
-          <a:lstStyle/>
-          <a:p>
-            <a:pPr algn="ctr">
-              <a:defRPr sz="950" b="1">
-                <a:solidFill>
-                  <a:srgbClr val="1E40AF"/>
-                </a:solidFill>
-              </a:defRPr>
-            </a:pPr>
-            <a:r>
-              <a:t>Người gửi Alice</a:t>
-            </a:r>
-          </a:p>
-          <a:p>
-            <a:pPr algn="ctr">
-              <a:defRPr sz="950" b="0">
-                <a:solidFill>
-                  <a:srgbClr val="1E40AF"/>
-                </a:solidFill>
-              </a:defRPr>
-            </a:pPr>
-            <a:r>
-              <a:t>(Bản rõ M)</a:t>
-            </a:r>
-          </a:p>
-        </p:txBody>
-      </p:sp>
-      <p:sp>
-        <p:nvSpPr>
-          <p:cNvPr id="9" name="Rounded Rectangle 8"/>
-          <p:cNvSpPr/>
-          <p:nvPr/>
-        </p:nvSpPr>
-        <p:spPr>
-          <a:xfrm>
-            <a:off x="2651760" y="2240280"/>
-            <a:ext cx="1463040" cy="594360"/>
-          </a:xfrm>
-          <a:prstGeom prst="roundRect">
-            <a:avLst/>
-          </a:prstGeom>
-          <a:solidFill>
-            <a:srgbClr val="FEF2F2"/>
-          </a:solidFill>
-          <a:ln>
-            <a:solidFill>
-              <a:srgbClr val="DC2626"/>
-            </a:solidFill>
-          </a:ln>
-        </p:spPr>
-        <p:style>
-          <a:lnRef idx="1">
-            <a:schemeClr val="accent1"/>
-          </a:lnRef>
-          <a:fillRef idx="3">
-            <a:schemeClr val="accent1"/>
-          </a:fillRef>
-          <a:effectRef idx="2">
-            <a:schemeClr val="accent1"/>
-          </a:effectRef>
-          <a:fontRef idx="minor">
-            <a:schemeClr val="lt1"/>
-          </a:fontRef>
-        </p:style>
-        <p:txBody>
-          <a:bodyPr rtlCol="0" anchor="ctr" wrap="square" lIns="36576" rIns="36576" tIns="36576" bIns="36576"/>
-          <a:lstStyle/>
-          <a:p>
-            <a:pPr algn="ctr">
-              <a:defRPr sz="950" b="1">
-                <a:solidFill>
-                  <a:srgbClr val="B91C1C"/>
-                </a:solidFill>
-              </a:defRPr>
-            </a:pPr>
-            <a:r>
-              <a:t>Kênh truyền</a:t>
-            </a:r>
-          </a:p>
-          <a:p>
-            <a:pPr algn="ctr">
-              <a:defRPr sz="950" b="0">
-                <a:solidFill>
-                  <a:srgbClr val="B91C1C"/>
-                </a:solidFill>
-              </a:defRPr>
-            </a:pPr>
-            <a:r>
-              <a:t>C = Enc(K, M)</a:t>
-            </a:r>
-          </a:p>
-        </p:txBody>
-      </p:sp>
-      <p:sp>
-        <p:nvSpPr>
-          <p:cNvPr id="10" name="Rounded Rectangle 9"/>
-          <p:cNvSpPr/>
-          <p:nvPr/>
-        </p:nvSpPr>
-        <p:spPr>
-          <a:xfrm>
-            <a:off x="4480560" y="2240280"/>
-            <a:ext cx="1188720" cy="594360"/>
-          </a:xfrm>
-          <a:prstGeom prst="roundRect">
-            <a:avLst/>
-          </a:prstGeom>
-          <a:solidFill>
-            <a:srgbClr val="ECFDF5"/>
-          </a:solidFill>
-          <a:ln>
-            <a:solidFill>
-              <a:srgbClr val="059669"/>
-            </a:solidFill>
-          </a:ln>
-        </p:spPr>
-        <p:style>
-          <a:lnRef idx="1">
-            <a:schemeClr val="accent1"/>
-          </a:lnRef>
-          <a:fillRef idx="3">
-            <a:schemeClr val="accent1"/>
-          </a:fillRef>
-          <a:effectRef idx="2">
-            <a:schemeClr val="accent1"/>
-          </a:effectRef>
-          <a:fontRef idx="minor">
-            <a:schemeClr val="lt1"/>
-          </a:fontRef>
-        </p:style>
-        <p:txBody>
-          <a:bodyPr rtlCol="0" anchor="ctr" wrap="square" lIns="36576" rIns="36576" tIns="36576" bIns="36576"/>
-          <a:lstStyle/>
-          <a:p>
-            <a:pPr algn="ctr">
-              <a:defRPr sz="950" b="1">
-                <a:solidFill>
-                  <a:srgbClr val="059669"/>
-                </a:solidFill>
-              </a:defRPr>
-            </a:pPr>
-            <a:r>
-              <a:t>Người nhận Bob</a:t>
-            </a:r>
-          </a:p>
-          <a:p>
-            <a:pPr algn="ctr">
-              <a:defRPr sz="950" b="0">
-                <a:solidFill>
-                  <a:srgbClr val="059669"/>
-                </a:solidFill>
-              </a:defRPr>
-            </a:pPr>
-            <a:r>
-              <a:t>(Dec(K, C))</a:t>
-            </a:r>
-          </a:p>
-        </p:txBody>
-      </p:sp>
-      <p:sp>
-        <p:nvSpPr>
-          <p:cNvPr id="11" name="Rounded Rectangle 10"/>
-          <p:cNvSpPr/>
-          <p:nvPr/>
-        </p:nvSpPr>
-        <p:spPr>
-          <a:xfrm>
-            <a:off x="2468880" y="2971800"/>
-            <a:ext cx="1828800" cy="502920"/>
-          </a:xfrm>
-          <a:prstGeom prst="roundRect">
-            <a:avLst/>
-          </a:prstGeom>
-          <a:solidFill>
-            <a:srgbClr val="FEE2E2"/>
-          </a:solidFill>
-          <a:ln>
-            <a:solidFill>
-              <a:srgbClr val="B91C1C"/>
-            </a:solidFill>
-          </a:ln>
-        </p:spPr>
-        <p:style>
-          <a:lnRef idx="1">
-            <a:schemeClr val="accent1"/>
-          </a:lnRef>
-          <a:fillRef idx="3">
-            <a:schemeClr val="accent1"/>
-          </a:fillRef>
-          <a:effectRef idx="2">
-            <a:schemeClr val="accent1"/>
-          </a:effectRef>
-          <a:fontRef idx="minor">
-            <a:schemeClr val="lt1"/>
-          </a:fontRef>
-        </p:style>
-        <p:txBody>
-          <a:bodyPr rtlCol="0" anchor="ctr" wrap="square" lIns="36576" rIns="36576" tIns="36576" bIns="36576"/>
-          <a:lstStyle/>
-          <a:p>
-            <a:pPr algn="ctr">
-              <a:defRPr sz="900" b="1">
-                <a:solidFill>
-                  <a:srgbClr val="991B1B"/>
-                </a:solidFill>
-              </a:defRPr>
-            </a:pPr>
-            <a:r>
-              <a:t>Đối thủ Eve (Passive)</a:t>
-            </a:r>
-          </a:p>
-          <a:p>
-            <a:pPr algn="ctr">
-              <a:defRPr sz="900" b="0">
-                <a:solidFill>
-                  <a:srgbClr val="991B1B"/>
-                </a:solidFill>
-              </a:defRPr>
-            </a:pPr>
-            <a:r>
-              <a:t>Chỉ nghe lén đường truyền</a:t>
-            </a:r>
-          </a:p>
-        </p:txBody>
-      </p:sp>
-      <p:sp>
-        <p:nvSpPr>
-          <p:cNvPr id="12" name="TextBox 11"/>
-          <p:cNvSpPr txBox="1"/>
-          <p:nvPr/>
-        </p:nvSpPr>
-        <p:spPr>
-          <a:xfrm>
-            <a:off x="914400" y="3611880"/>
-            <a:ext cx="4846320" cy="2194560"/>
-          </a:xfrm>
-          <a:prstGeom prst="rect">
-            <a:avLst/>
-          </a:prstGeom>
-          <a:noFill/>
-        </p:spPr>
-        <p:txBody>
-          <a:bodyPr wrap="square">
-            <a:spAutoFit/>
-          </a:bodyPr>
-          <a:lstStyle/>
-          <a:p/>
-          <a:p>
-            <a:pPr>
-              <a:spcBef>
-                <a:spcPts val="400"/>
-              </a:spcBef>
-            </a:pPr>
-            <a:r>
-              <a:rPr b="1" sz="1000">
-                <a:solidFill>
-                  <a:srgbClr val="1E293B"/>
-                </a:solidFill>
-              </a:rPr>
-              <a:t>• Bí mật hoàn hảo: </a:t>
-            </a:r>
-            <a:r>
-              <a:rPr sz="950">
-                <a:solidFill>
-                  <a:srgbClr val="475569"/>
-                </a:solidFill>
-              </a:rPr>
-              <a:t>OTP an toàn tuyệt đối khi H(K) &gt;= H(M), nhưng bất khả thi khi triển khai diện rộng.</a:t>
-            </a:r>
-          </a:p>
-          <a:p>
-            <a:pPr>
-              <a:spcBef>
-                <a:spcPts val="400"/>
-              </a:spcBef>
-            </a:pPr>
-            <a:r>
-              <a:rPr b="1" sz="1000">
-                <a:solidFill>
-                  <a:srgbClr val="1E293B"/>
-                </a:solidFill>
-              </a:rPr>
-              <a:t>• Giả định Shannon: </a:t>
-            </a:r>
-            <a:r>
-              <a:rPr sz="950">
-                <a:solidFill>
-                  <a:srgbClr val="475569"/>
-                </a:solidFill>
-              </a:rPr>
-              <a:t>Xem sai lệch dữ liệu là 'nhiễu ngẫu nhiên'. Đối thủ thực tế là tác nhân có chủ đích!</a:t>
-            </a:r>
-          </a:p>
-          <a:p>
-            <a:pPr>
-              <a:spcBef>
-                <a:spcPts val="400"/>
-              </a:spcBef>
-            </a:pPr>
-            <a:r>
-              <a:rPr b="1" sz="1000">
-                <a:solidFill>
-                  <a:srgbClr val="1E293B"/>
-                </a:solidFill>
-              </a:rPr>
-              <a:t>• Hạn chế: </a:t>
-            </a:r>
-            <a:r>
-              <a:rPr sz="950">
-                <a:solidFill>
-                  <a:srgbClr val="475569"/>
-                </a:solidFill>
-              </a:rPr>
-              <a:t>Bỏ qua chi phí lưu trữ/phân phối khóa, rò rỉ kênh kề và ranh giới hệ thống vật lý.</a:t>
-            </a:r>
-          </a:p>
-        </p:txBody>
-      </p:sp>
-      <p:sp>
-        <p:nvSpPr>
-          <p:cNvPr id="13" name="Rounded Rectangle 12"/>
-          <p:cNvSpPr/>
-          <p:nvPr/>
-        </p:nvSpPr>
-        <p:spPr>
-          <a:xfrm>
-            <a:off x="6217920" y="1691640"/>
-            <a:ext cx="5212080" cy="4343400"/>
-          </a:xfrm>
-          <a:prstGeom prst="roundRect">
-            <a:avLst/>
-          </a:prstGeom>
-          <a:solidFill>
-            <a:srgbClr val="ECFDF5"/>
-          </a:solidFill>
-          <a:ln>
-            <a:solidFill>
-              <a:srgbClr val="A7F3D0"/>
-            </a:solidFill>
-          </a:ln>
-        </p:spPr>
-        <p:style>
-          <a:lnRef idx="1">
-            <a:schemeClr val="accent1"/>
-          </a:lnRef>
-          <a:fillRef idx="3">
-            <a:schemeClr val="accent1"/>
-          </a:fillRef>
-          <a:effectRef idx="2">
-            <a:schemeClr val="accent1"/>
-          </a:effectRef>
-          <a:fontRef idx="minor">
-            <a:schemeClr val="lt1"/>
-          </a:fontRef>
-        </p:style>
-        <p:txBody>
-          <a:bodyPr rtlCol="0" anchor="ctr"/>
-          <a:lstStyle/>
-          <a:p>
-            <a:pPr algn="ctr"/>
-          </a:p>
-        </p:txBody>
-      </p:sp>
-      <p:sp>
-        <p:nvSpPr>
-          <p:cNvPr id="14" name="TextBox 13"/>
-          <p:cNvSpPr txBox="1"/>
-          <p:nvPr/>
-        </p:nvSpPr>
-        <p:spPr>
-          <a:xfrm>
-            <a:off x="6400800" y="1783080"/>
-            <a:ext cx="4846320" cy="365760"/>
-          </a:xfrm>
-          <a:prstGeom prst="rect">
-            <a:avLst/>
-          </a:prstGeom>
-          <a:noFill/>
-        </p:spPr>
-        <p:txBody>
-          <a:bodyPr wrap="none">
-            <a:spAutoFit/>
-          </a:bodyPr>
-          <a:lstStyle/>
-          <a:p>
-            <a:pPr>
-              <a:defRPr sz="1200" b="1">
-                <a:solidFill>
-                  <a:srgbClr val="059669"/>
-                </a:solidFill>
-              </a:defRPr>
-            </a:pPr>
-            <a:r>
-              <a:t>2. Thực Tế: Mạng Xã Hội - Kỹ Thuật Không Đồng Nhất</a:t>
-            </a:r>
-          </a:p>
-        </p:txBody>
-      </p:sp>
-      <p:sp>
-        <p:nvSpPr>
-          <p:cNvPr id="15" name="Rounded Rectangle 14"/>
-          <p:cNvSpPr/>
-          <p:nvPr/>
-        </p:nvSpPr>
-        <p:spPr>
-          <a:xfrm>
-            <a:off x="6492240" y="2240280"/>
-            <a:ext cx="2194560" cy="594360"/>
-          </a:xfrm>
-          <a:prstGeom prst="roundRect">
-            <a:avLst/>
-          </a:prstGeom>
-          <a:solidFill>
-            <a:srgbClr val="FFFFFF"/>
-          </a:solidFill>
-          <a:ln>
-            <a:solidFill>
-              <a:srgbClr val="059669"/>
-            </a:solidFill>
-          </a:ln>
-        </p:spPr>
-        <p:style>
-          <a:lnRef idx="1">
-            <a:schemeClr val="accent1"/>
-          </a:lnRef>
-          <a:fillRef idx="3">
-            <a:schemeClr val="accent1"/>
-          </a:fillRef>
-          <a:effectRef idx="2">
-            <a:schemeClr val="accent1"/>
-          </a:effectRef>
-          <a:fontRef idx="minor">
-            <a:schemeClr val="lt1"/>
-          </a:fontRef>
-        </p:style>
-        <p:txBody>
-          <a:bodyPr rtlCol="0" anchor="ctr" wrap="square" lIns="36576" rIns="36576" tIns="36576" bIns="36576"/>
-          <a:lstStyle/>
-          <a:p>
-            <a:pPr algn="ctr">
-              <a:defRPr sz="950" b="1">
-                <a:solidFill>
-                  <a:srgbClr val="059669"/>
-                </a:solidFill>
-              </a:defRPr>
-            </a:pPr>
-            <a:r>
-              <a:t>Nhóm Người Giữ Bí Mật</a:t>
-            </a:r>
-          </a:p>
-          <a:p>
-            <a:pPr algn="ctr">
-              <a:defRPr sz="950" b="0">
-                <a:solidFill>
-                  <a:srgbClr val="059669"/>
-                </a:solidFill>
-              </a:defRPr>
-            </a:pPr>
-            <a:r>
-              <a:t>(Duy trì chính sách Policy)</a:t>
-            </a:r>
-          </a:p>
-        </p:txBody>
-      </p:sp>
-      <p:sp>
-        <p:nvSpPr>
-          <p:cNvPr id="16" name="Rounded Rectangle 15"/>
-          <p:cNvSpPr/>
-          <p:nvPr/>
-        </p:nvSpPr>
-        <p:spPr>
-          <a:xfrm>
-            <a:off x="8961120" y="2240280"/>
-            <a:ext cx="2194560" cy="594360"/>
-          </a:xfrm>
-          <a:prstGeom prst="roundRect">
-            <a:avLst/>
-          </a:prstGeom>
-          <a:solidFill>
-            <a:srgbClr val="FFFFFF"/>
-          </a:solidFill>
-          <a:ln>
-            <a:solidFill>
-              <a:srgbClr val="2563EB"/>
-            </a:solidFill>
-          </a:ln>
-        </p:spPr>
-        <p:style>
-          <a:lnRef idx="1">
-            <a:schemeClr val="accent1"/>
-          </a:lnRef>
-          <a:fillRef idx="3">
-            <a:schemeClr val="accent1"/>
-          </a:fillRef>
-          <a:effectRef idx="2">
-            <a:schemeClr val="accent1"/>
-          </a:effectRef>
-          <a:fontRef idx="minor">
-            <a:schemeClr val="lt1"/>
-          </a:fontRef>
-        </p:style>
-        <p:txBody>
-          <a:bodyPr rtlCol="0" anchor="ctr" wrap="square" lIns="36576" rIns="36576" tIns="36576" bIns="36576"/>
-          <a:lstStyle/>
-          <a:p>
-            <a:pPr algn="ctr">
-              <a:defRPr sz="950" b="1">
-                <a:solidFill>
-                  <a:srgbClr val="1E40AF"/>
-                </a:solidFill>
-              </a:defRPr>
-            </a:pPr>
-            <a:r>
-              <a:t>Hạ Tầng / ISP / Đám Mây</a:t>
-            </a:r>
-          </a:p>
-          <a:p>
-            <a:pPr algn="ctr">
-              <a:defRPr sz="950" b="0">
-                <a:solidFill>
-                  <a:srgbClr val="1E40AF"/>
-                </a:solidFill>
-              </a:defRPr>
-            </a:pPr>
-            <a:r>
-              <a:t>(Môi trường mở không tin cậy)</a:t>
-            </a:r>
-          </a:p>
-        </p:txBody>
-      </p:sp>
-      <p:sp>
-        <p:nvSpPr>
-          <p:cNvPr id="17" name="Rounded Rectangle 16"/>
-          <p:cNvSpPr/>
-          <p:nvPr/>
-        </p:nvSpPr>
-        <p:spPr>
-          <a:xfrm>
-            <a:off x="6492240" y="2971800"/>
-            <a:ext cx="4663440" cy="502920"/>
-          </a:xfrm>
-          <a:prstGeom prst="roundRect">
-            <a:avLst/>
-          </a:prstGeom>
-          <a:solidFill>
-            <a:srgbClr val="FEE2E2"/>
-          </a:solidFill>
-          <a:ln>
-            <a:solidFill>
-              <a:srgbClr val="DC2626"/>
-            </a:solidFill>
-          </a:ln>
-        </p:spPr>
-        <p:style>
-          <a:lnRef idx="1">
-            <a:schemeClr val="accent1"/>
-          </a:lnRef>
-          <a:fillRef idx="3">
-            <a:schemeClr val="accent1"/>
-          </a:fillRef>
-          <a:effectRef idx="2">
-            <a:schemeClr val="accent1"/>
-          </a:effectRef>
-          <a:fontRef idx="minor">
-            <a:schemeClr val="lt1"/>
-          </a:fontRef>
-        </p:style>
-        <p:txBody>
-          <a:bodyPr rtlCol="0" anchor="ctr" wrap="square" lIns="36576" rIns="36576" tIns="36576" bIns="36576"/>
-          <a:lstStyle/>
-          <a:p>
-            <a:pPr algn="ctr">
-              <a:defRPr sz="900" b="1">
-                <a:solidFill>
-                  <a:srgbClr val="991B1B"/>
-                </a:solidFill>
-              </a:defRPr>
-            </a:pPr>
-            <a:r>
-              <a:t>Đối Thủ Thể Chế (NSA / Five Eyes) &amp; Kênh Kề</a:t>
-            </a:r>
-          </a:p>
-          <a:p>
-            <a:pPr algn="ctr">
-              <a:defRPr sz="900" b="0">
-                <a:solidFill>
-                  <a:srgbClr val="991B1B"/>
-                </a:solidFill>
-              </a:defRPr>
-            </a:pPr>
-            <a:r>
-              <a:t>Tấn công chuỗi cung ứng, suy yếu chuẩn &amp; Giám sát siêu dữ liệu</a:t>
-            </a:r>
-          </a:p>
-        </p:txBody>
-      </p:sp>
-      <p:sp>
-        <p:nvSpPr>
-          <p:cNvPr id="18" name="TextBox 17"/>
-          <p:cNvSpPr txBox="1"/>
-          <p:nvPr/>
-        </p:nvSpPr>
-        <p:spPr>
-          <a:xfrm>
-            <a:off x="6400800" y="3611880"/>
-            <a:ext cx="4846320" cy="2194560"/>
-          </a:xfrm>
-          <a:prstGeom prst="rect">
-            <a:avLst/>
-          </a:prstGeom>
-          <a:noFill/>
-        </p:spPr>
-        <p:txBody>
-          <a:bodyPr wrap="square">
-            <a:spAutoFit/>
-          </a:bodyPr>
-          <a:lstStyle/>
-          <a:p/>
-          <a:p>
-            <a:pPr>
-              <a:spcBef>
-                <a:spcPts val="400"/>
-              </a:spcBef>
-            </a:pPr>
-            <a:r>
-              <a:rPr b="1" sz="1000">
-                <a:solidFill>
-                  <a:srgbClr val="1E293B"/>
-                </a:solidFill>
-              </a:rPr>
-              <a:t>• Mạng phức hợp: </a:t>
-            </a:r>
-            <a:r>
-              <a:rPr sz="950">
-                <a:solidFill>
-                  <a:srgbClr val="475569"/>
-                </a:solidFill>
-              </a:rPr>
-              <a:t>Thông tin chảy qua nhiều thực thể: người dùng, ISP, cáp quang biển, đám mây.</a:t>
-            </a:r>
-          </a:p>
-          <a:p>
-            <a:pPr>
-              <a:spcBef>
-                <a:spcPts val="400"/>
-              </a:spcBef>
-            </a:pPr>
-            <a:r>
-              <a:rPr b="1" sz="1000">
-                <a:solidFill>
-                  <a:srgbClr val="1E293B"/>
-                </a:solidFill>
-              </a:rPr>
-              <a:t>• Đối thủ thể chế: </a:t>
-            </a:r>
-            <a:r>
-              <a:rPr sz="950">
-                <a:solidFill>
-                  <a:srgbClr val="475569"/>
-                </a:solidFill>
-              </a:rPr>
-              <a:t>NSA/Five Eyes tấn công chuỗi cung ứng, suy yếu chuẩn &amp; giám sát siêu dữ liệu.</a:t>
-            </a:r>
-          </a:p>
-          <a:p>
-            <a:pPr>
-              <a:spcBef>
-                <a:spcPts val="400"/>
-              </a:spcBef>
-            </a:pPr>
-            <a:r>
-              <a:rPr b="1" sz="1000">
-                <a:solidFill>
-                  <a:srgbClr val="1E293B"/>
-                </a:solidFill>
-              </a:rPr>
-              <a:t>• Mục tiêu hiện đại: </a:t>
-            </a:r>
-            <a:r>
-              <a:rPr sz="950">
-                <a:solidFill>
-                  <a:srgbClr val="475569"/>
-                </a:solidFill>
-              </a:rPr>
-              <a:t>Bảo vệ siêu dữ liệu (Mixnet), kháng kênh kề thời gian và kiểm soát lỗi nội bộ.</a:t>
-            </a:r>
-          </a:p>
-        </p:txBody>
-      </p:sp>
-      <p:sp>
-        <p:nvSpPr>
-          <p:cNvPr id="19" name="TextBox 18"/>
-          <p:cNvSpPr txBox="1"/>
-          <p:nvPr/>
-        </p:nvSpPr>
-        <p:spPr>
-          <a:xfrm>
-            <a:off x="731520" y="6217920"/>
-            <a:ext cx="10698480" cy="365760"/>
-          </a:xfrm>
-          <a:prstGeom prst="rect">
-            <a:avLst/>
-          </a:prstGeom>
-          <a:noFill/>
-        </p:spPr>
-        <p:txBody>
-          <a:bodyPr wrap="none">
-            <a:spAutoFit/>
-          </a:bodyPr>
-          <a:lstStyle/>
-          <a:p>
-            <a:pPr>
               <a:defRPr sz="1000" i="1">
                 <a:solidFill>
                   <a:srgbClr val="64748B"/>
@@ -9462,7 +8077,7 @@
               </a:defRPr>
             </a:pPr>
             <a:r>
-              <a:t>Sơ đồ tổng hợp dựa trên Shannon (1949) và Halpin (2025). [Mã nguồn sơ đồ draw.io lưu tại docs/diagram_slide_06_shannon.drawio]</a:t>
+              <a:t>Sơ đồ tổng hợp dựa trên Shannon (1949) và Harry Halpin (2025), Journal of Cybersecurity, tr. 3–5.</a:t>
             </a:r>
           </a:p>
         </p:txBody>

</xml_diff>

<commit_message>
Audit and finalize 15-slide presentation Bao_Cao_Giua_Ky_DT05_Final and Word presentation script
</commit_message>
<xml_diff>
--- a/Bao_Cao_Giua_Ky_DT05_Final.pptx
+++ b/Bao_Cao_Giua_Ky_DT05_Final.pptx
@@ -3866,7 +3866,7 @@
                   <a:srgbClr val="475569"/>
                 </a:solidFill>
               </a:rPr>
-              <a:t>Thiết kế các thí nghiệm minh họa: sự bất lực của mã tuyến tính CRC32 trước kẻ thù toán học; can thiệp đường truyền Dolev-Yao; rò rỉ siêu dữ liệu kênh truyền.</a:t>
+              <a:t>Thiết kế các kịch bản kiểm thử: đối đầu toán học trên mã tuyến tính CRC32; can thiệp đường truyền Dolev-Yao; rò rỉ kênh kề thời gian so sánh chuỗi.</a:t>
             </a:r>
           </a:p>
           <a:p>
@@ -3904,7 +3904,7 @@
                   <a:srgbClr val="1E293B"/>
                 </a:solidFill>
               </a:rPr>
-              <a:t>• Báo cáo khoa học nghiêm túc: </a:t>
+              <a:t>• Kiểm toán khoa học: </a:t>
             </a:r>
             <a:r>
               <a:rPr sz="1050">
@@ -3912,7 +3912,7 @@
                   <a:srgbClr val="475569"/>
                 </a:solidFill>
               </a:rPr>
-              <a:t>Tất cả kết quả đo đạc được lưu vết kiểm toán tại file MIDTERM_CODE_AUDIT.md.</a:t>
+              <a:t>Tất cả quy trình kiểm toán mã nguồn và đối chiếu thực nghiệm được lưu vết kỹ thuật tại MIDTERM_CODE_AUDIT.md.</a:t>
             </a:r>
           </a:p>
         </p:txBody>
@@ -3947,7 +3947,7 @@
               </a:defRPr>
             </a:pPr>
             <a:r>
-              <a:t>Báo cáo phân định phương pháp luận của nhóm nghiên cứu đề tài DT005.</a:t>
+              <a:t>Báo cáo phân định phương pháp luận độc lập của nhóm nghiên cứu đề tài DT005.</a:t>
             </a:r>
           </a:p>
         </p:txBody>
@@ -4206,75 +4206,75 @@
           <a:p>
             <a:pPr>
               <a:spcAft>
-                <a:spcPts val="1000"/>
-              </a:spcAft>
-              <a:defRPr sz="1200" b="1">
-                <a:solidFill>
-                  <a:srgbClr val="0F172A"/>
-                </a:solidFill>
-              </a:defRPr>
-            </a:pPr>
-            <a:r>
-              <a:t>1. NHIỄU vs KẺ THÙ CHỦ ĐÍCH</a:t>
-            </a:r>
-          </a:p>
-          <a:p>
-            <a:pPr>
-              <a:defRPr sz="1050" b="1">
-                <a:solidFill>
-                  <a:srgbClr val="1E293B"/>
-                </a:solidFill>
-              </a:defRPr>
-            </a:pPr>
-            <a:r>
-              <a:t>Luận điểm bài báo Halpin:</a:t>
-            </a:r>
-          </a:p>
-          <a:p>
-            <a:pPr>
-              <a:spcAft>
                 <a:spcPts val="800"/>
               </a:spcAft>
-              <a:defRPr sz="950">
+              <a:defRPr sz="1150" b="1">
+                <a:solidFill>
+                  <a:srgbClr val="0F172A"/>
+                </a:solidFill>
+              </a:defRPr>
+            </a:pPr>
+            <a:r>
+              <a:t>1. NHIỄU vs ĐỐI THỦ CHỦ ĐÍCH</a:t>
+            </a:r>
+          </a:p>
+          <a:p>
+            <a:pPr>
+              <a:defRPr sz="1000" b="1">
+                <a:solidFill>
+                  <a:srgbClr val="1E293B"/>
+                </a:solidFill>
+              </a:defRPr>
+            </a:pPr>
+            <a:r>
+              <a:t>Luận điểm Halpin (Sec. 1–2):</a:t>
+            </a:r>
+          </a:p>
+          <a:p>
+            <a:pPr>
+              <a:spcAft>
+                <a:spcPts val="600"/>
+              </a:spcAft>
+              <a:defRPr sz="919">
                 <a:solidFill>
                   <a:srgbClr val="475569"/>
                 </a:solidFill>
               </a:defRPr>
             </a:pPr>
             <a:r>
-              <a:t>Mật mã học khác lý thuyết Shannon: đối thủ có chủ đích, không phải nhiễu ngẫu nhiên. Mã toàn vẹn tuyến tính CRC32 hoàn toàn bất lực.</a:t>
-            </a:r>
-          </a:p>
-          <a:p>
-            <a:pPr>
-              <a:defRPr sz="1050" b="1">
+              <a:t>Đối thủ là tác nhân có chủ đích, không phải nhiễu ngẫu nhiên. Mã kiểm tra lỗi tuyến tính được thiết kế cho nhiễu ngẫu nhiên, không phòng vệ được trước đối thủ chủ đích.</a:t>
+            </a:r>
+          </a:p>
+          <a:p>
+            <a:pPr>
+              <a:defRPr sz="1000" b="1">
                 <a:solidFill>
                   <a:srgbClr val="1E293B"/>
                 </a:solidFill>
               </a:defRPr>
             </a:pPr>
             <a:r>
-              <a:t>Minh họa thực nghiệm DT005:</a:t>
+              <a:t>Minh họa độc lập (DT005):</a:t>
             </a:r>
           </a:p>
           <a:p>
             <a:pPr>
               <a:spcAft>
-                <a:spcPts val="800"/>
+                <a:spcPts val="600"/>
               </a:spcAft>
-              <a:defRPr sz="950">
+              <a:defRPr sz="919">
                 <a:solidFill>
                   <a:srgbClr val="475569"/>
                 </a:solidFill>
               </a:defRPr>
             </a:pPr>
             <a:r>
-              <a:t>Giải hệ phương trình bù đại số GF(2), tìm 4 byte giả mạo qua mặt CRC32 100%. Hàm băm SHA-256 phát hiện thay đổi ngay lập tức.</a:t>
-            </a:r>
-          </a:p>
-          <a:p>
-            <a:pPr>
-              <a:defRPr sz="1050" b="1">
+              <a:t>Thử nghiệm kịch bản bù 4 byte GF(2): Kẻ tấn công giải hệ phương trình tuyến tính để qua mặt CRC32 trong tệp bị can thiệp; hàm băm phi tuyến SHA-256 phát hiện tức thì.</a:t>
+            </a:r>
+          </a:p>
+          <a:p>
+            <a:pPr>
+              <a:defRPr sz="1000" b="1">
                 <a:solidFill>
                   <a:srgbClr val="1E293B"/>
                 </a:solidFill>
@@ -4286,14 +4286,14 @@
           </a:p>
           <a:p>
             <a:pPr>
-              <a:defRPr sz="950">
+              <a:defRPr sz="919">
                 <a:solidFill>
                   <a:srgbClr val="64748B"/>
                 </a:solidFill>
               </a:defRPr>
             </a:pPr>
             <a:r>
-              <a:t>Chỉ minh họa tính phi tuyến của hàm băm; không chứng minh an toàn toàn diện cho toàn bộ hệ thống.</a:t>
+              <a:t>Chỉ minh họa tính phi tuyến của hàm băm trong kịch bản giả mạo đã kiểm thử; không kết luận CRC32 bất lực trong vai trò phát hiện lỗi ngẫu nhiên vật lý.</a:t>
             </a:r>
           </a:p>
         </p:txBody>
@@ -4367,75 +4367,75 @@
           <a:p>
             <a:pPr>
               <a:spcAft>
-                <a:spcPts val="1000"/>
-              </a:spcAft>
-              <a:defRPr sz="1200" b="1">
-                <a:solidFill>
-                  <a:srgbClr val="0F172A"/>
-                </a:solidFill>
-              </a:defRPr>
-            </a:pPr>
-            <a:r>
-              <a:t>2. NHẬP NHẰNG NÚT LÁ MERKLE</a:t>
-            </a:r>
-          </a:p>
-          <a:p>
-            <a:pPr>
-              <a:defRPr sz="1050" b="1">
-                <a:solidFill>
-                  <a:srgbClr val="1E293B"/>
-                </a:solidFill>
-              </a:defRPr>
-            </a:pPr>
-            <a:r>
-              <a:t>Luận điểm bài báo Halpin:</a:t>
-            </a:r>
-          </a:p>
-          <a:p>
-            <a:pPr>
-              <a:spcAft>
                 <a:spcPts val="800"/>
               </a:spcAft>
-              <a:defRPr sz="950">
+              <a:defRPr sz="1150" b="1">
+                <a:solidFill>
+                  <a:srgbClr val="0F172A"/>
+                </a:solidFill>
+              </a:defRPr>
+            </a:pPr>
+            <a:r>
+              <a:t>2. PHÂN TÁCH MIỀN NÚT LÁ (RFC 6962)</a:t>
+            </a:r>
+          </a:p>
+          <a:p>
+            <a:pPr>
+              <a:defRPr sz="1000" b="1">
+                <a:solidFill>
+                  <a:srgbClr val="1E293B"/>
+                </a:solidFill>
+              </a:defRPr>
+            </a:pPr>
+            <a:r>
+              <a:t>Gốc lý thuyết bài báo:</a:t>
+            </a:r>
+          </a:p>
+          <a:p>
+            <a:pPr>
+              <a:spcAft>
+                <a:spcPts val="600"/>
+              </a:spcAft>
+              <a:defRPr sz="919">
                 <a:solidFill>
                   <a:srgbClr val="475569"/>
                 </a:solidFill>
               </a:defRPr>
             </a:pPr>
             <a:r>
-              <a:t>Ghép chuỗi thô H(L || R) khiến kẻ thù có thể đánh tráo nút nhánh nội bộ thành nút lá, gây va chạm cấu trúc tầng cây.</a:t>
-            </a:r>
-          </a:p>
-          <a:p>
-            <a:pPr>
-              <a:defRPr sz="1050" b="1">
+              <a:t>Halpin nhấn mạnh điểm mù khi triển khai cấu trúc dữ liệu trong thực tế, nhưng KHÔNG trực tiếp đề cập cấu trúc cây Merkle hay kỹ thuật phân tách miền.</a:t>
+            </a:r>
+          </a:p>
+          <a:p>
+            <a:pPr>
+              <a:defRPr sz="1000" b="1">
                 <a:solidFill>
                   <a:srgbClr val="1E293B"/>
                 </a:solidFill>
               </a:defRPr>
             </a:pPr>
             <a:r>
-              <a:t>Minh họa thực nghiệm DT005:</a:t>
+              <a:t>Minh họa độc lập (DT005):</a:t>
             </a:r>
           </a:p>
           <a:p>
             <a:pPr>
               <a:spcAft>
-                <a:spcPts val="800"/>
+                <a:spcPts val="600"/>
               </a:spcAft>
-              <a:defRPr sz="950">
+              <a:defRPr sz="919">
                 <a:solidFill>
                   <a:srgbClr val="475569"/>
                 </a:solidFill>
               </a:defRPr>
             </a:pPr>
             <a:r>
-              <a:t>Cài đặt phân tách miền chuẩn RFC 6962: gắn tiền tố 0x00 cho nút lá và 0x01 cho nút nhánh để triệt tiêu hoàn toàn nhập nhằng.</a:t>
-            </a:r>
-          </a:p>
-          <a:p>
-            <a:pPr>
-              <a:defRPr sz="1050" b="1">
+              <a:t>Sinh viên chủ động mở rộng bài toán toàn vẹn: Cài đặt phân tách miền theo chuẩn IETF RFC 6962 (tiền tố byte 0x00 cho lá, 0x01 cho nhánh) để phòng ngừa va chạm cấu trúc tầng cây.</a:t>
+            </a:r>
+          </a:p>
+          <a:p>
+            <a:pPr>
+              <a:defRPr sz="1000" b="1">
                 <a:solidFill>
                   <a:srgbClr val="1E293B"/>
                 </a:solidFill>
@@ -4447,14 +4447,14 @@
           </a:p>
           <a:p>
             <a:pPr>
-              <a:defRPr sz="950">
+              <a:defRPr sz="919">
                 <a:solidFill>
                   <a:srgbClr val="64748B"/>
                 </a:solidFill>
               </a:defRPr>
             </a:pPr>
             <a:r>
-              <a:t>Chỉ giải quyết va chạm cấu trúc tầng cây Merkle; không loại trừ va chạm ngẫu nhiên 2^256 của SHA-256.</a:t>
+              <a:t>Kỹ thuật RFC 6962 do sinh viên tự nghiên cứu tích hợp, không phải đề xuất của Halpin; chỉ phòng ngừa va chạm cấu trúc, không thay đổi độ phức tạp 2^256 của SHA-256.</a:t>
             </a:r>
           </a:p>
         </p:txBody>
@@ -4528,75 +4528,75 @@
           <a:p>
             <a:pPr>
               <a:spcAft>
-                <a:spcPts val="1000"/>
-              </a:spcAft>
-              <a:defRPr sz="1200" b="1">
-                <a:solidFill>
-                  <a:srgbClr val="0F172A"/>
-                </a:solidFill>
-              </a:defRPr>
-            </a:pPr>
-            <a:r>
-              <a:t>3. KÊNH KỀ THỜI GIAN SO SÁNH</a:t>
-            </a:r>
-          </a:p>
-          <a:p>
-            <a:pPr>
-              <a:defRPr sz="1050" b="1">
-                <a:solidFill>
-                  <a:srgbClr val="1E293B"/>
-                </a:solidFill>
-              </a:defRPr>
-            </a:pPr>
-            <a:r>
-              <a:t>Luận điểm bài báo Halpin:</a:t>
-            </a:r>
-          </a:p>
-          <a:p>
-            <a:pPr>
-              <a:spcAft>
                 <a:spcPts val="800"/>
               </a:spcAft>
-              <a:defRPr sz="950">
+              <a:defRPr sz="1150" b="1">
+                <a:solidFill>
+                  <a:srgbClr val="0F172A"/>
+                </a:solidFill>
+              </a:defRPr>
+            </a:pPr>
+            <a:r>
+              <a:t>3. RÒ RỈ KÊNH KỀ THỜI GIAN</a:t>
+            </a:r>
+          </a:p>
+          <a:p>
+            <a:pPr>
+              <a:defRPr sz="1000" b="1">
+                <a:solidFill>
+                  <a:srgbClr val="1E293B"/>
+                </a:solidFill>
+              </a:defRPr>
+            </a:pPr>
+            <a:r>
+              <a:t>Luận điểm Halpin (Sec. 5):</a:t>
+            </a:r>
+          </a:p>
+          <a:p>
+            <a:pPr>
+              <a:spcAft>
+                <a:spcPts val="600"/>
+              </a:spcAft>
+              <a:defRPr sz="919">
                 <a:solidFill>
                   <a:srgbClr val="475569"/>
                 </a:solidFill>
               </a:defRPr>
             </a:pPr>
             <a:r>
-              <a:t>Lý thuyết xem mật mã là hàm toán học lý tưởng, nhưng thực tế việc dừng sớm (early-return) làm rò rỉ dữ liệu qua thời gian thực thi.</a:t>
-            </a:r>
-          </a:p>
-          <a:p>
-            <a:pPr>
-              <a:defRPr sz="1050" b="1">
+              <a:t>Mô hình toán học trừu tượng xem mật mã là hàm lý tưởng, nhưng thời gian thực thi thực tế làm rò rỉ dữ liệu bí mật (dẫn theo Paul Kocher 1996).</a:t>
+            </a:r>
+          </a:p>
+          <a:p>
+            <a:pPr>
+              <a:defRPr sz="1000" b="1">
                 <a:solidFill>
                   <a:srgbClr val="1E293B"/>
                 </a:solidFill>
               </a:defRPr>
             </a:pPr>
             <a:r>
-              <a:t>Minh họa thực nghiệm DT005:</a:t>
+              <a:t>Minh họa độc lập (DT005):</a:t>
             </a:r>
           </a:p>
           <a:p>
             <a:pPr>
               <a:spcAft>
-                <a:spcPts val="800"/>
+                <a:spcPts val="600"/>
               </a:spcAft>
-              <a:defRPr sz="950">
+              <a:defRPr sz="919">
                 <a:solidFill>
                   <a:srgbClr val="475569"/>
                 </a:solidFill>
               </a:defRPr>
             </a:pPr>
             <a:r>
-              <a:t>Đo đạc 5 vòng so sánh chuỗi tuần tự (lộ chênh lệch thời gian) so với hàm thời gian hằng số hmac.compare_digest triệt tiêu độ lệch.</a:t>
-            </a:r>
-          </a:p>
-          <a:p>
-            <a:pPr>
-              <a:defRPr sz="1050" b="1">
+              <a:t>Sinh viên xây dựng kịch bản kiểm thử đo đạc thời gian so sánh chuỗi tuần tự (dừng sớm khi gặp byte lệch) so với việc sử dụng hàm thời gian hằng số hmac.compare_digest.</a:t>
+            </a:r>
+          </a:p>
+          <a:p>
+            <a:pPr>
+              <a:defRPr sz="1000" b="1">
                 <a:solidFill>
                   <a:srgbClr val="1E293B"/>
                 </a:solidFill>
@@ -4608,14 +4608,14 @@
           </a:p>
           <a:p>
             <a:pPr>
-              <a:defRPr sz="950">
+              <a:defRPr sz="919">
                 <a:solidFill>
                   <a:srgbClr val="64748B"/>
                 </a:solidFill>
               </a:defRPr>
             </a:pPr>
             <a:r>
-              <a:t>Đo đạc trên máy tính đơn có nhiễu hệ điều hành; chỉ minh họa ở mức thư viện phần mềm, không phải phần cứng.</a:t>
+              <a:t>Đo đạc trên môi trường máy tính đơn có jitter hệ điều hành; chỉ minh họa rò rỉ logic ở mức phần mềm ứng dụng, không đại diện cho kênh kề phần cứng chuyên sâu.</a:t>
             </a:r>
           </a:p>
         </p:txBody>
@@ -4724,16 +4724,16 @@
         </p:nvSpPr>
         <p:spPr>
           <a:xfrm>
-            <a:off x="1371600" y="1371600"/>
-            <a:ext cx="9448495" cy="4114800"/>
+            <a:off x="731520" y="365760"/>
+            <a:ext cx="4114800" cy="320040"/>
           </a:xfrm>
           <a:prstGeom prst="roundRect">
             <a:avLst/>
           </a:prstGeom>
           <a:solidFill>
-            <a:srgbClr val="F8FAFC"/>
+            <a:srgbClr val="EFF6FF"/>
           </a:solidFill>
-          <a:ln>
+          <a:ln w="12700">
             <a:solidFill>
               <a:srgbClr val="BFDBFE"/>
             </a:solidFill>
@@ -4754,10 +4754,19 @@
           </a:fontRef>
         </p:style>
         <p:txBody>
-          <a:bodyPr rtlCol="0" anchor="ctr"/>
-          <a:lstStyle/>
-          <a:p>
-            <a:pPr algn="ctr"/>
+          <a:bodyPr rtlCol="0" anchor="ctr" wrap="square"/>
+          <a:lstStyle/>
+          <a:p>
+            <a:pPr algn="ctr">
+              <a:defRPr sz="1000" b="1">
+                <a:solidFill>
+                  <a:srgbClr val="1D4ED8"/>
+                </a:solidFill>
+              </a:defRPr>
+            </a:pPr>
+            <a:r>
+              <a:t>MINH HỌA THỰC NGHIỆM ĐỘC LẬP (LIVE DEMO)</a:t>
+            </a:r>
           </a:p>
         </p:txBody>
       </p:sp>
@@ -4769,8 +4778,8 @@
         </p:nvSpPr>
         <p:spPr>
           <a:xfrm>
-            <a:off x="1645920" y="1645920"/>
-            <a:ext cx="8899855" cy="3566160"/>
+            <a:off x="731520" y="749808"/>
+            <a:ext cx="10698480" cy="502920"/>
           </a:xfrm>
           <a:prstGeom prst="rect">
             <a:avLst/>
@@ -4778,80 +4787,114 @@
           <a:noFill/>
         </p:spPr>
         <p:txBody>
-          <a:bodyPr wrap="square">
+          <a:bodyPr wrap="square" lIns="0" rIns="0" tIns="0" bIns="0">
             <a:spAutoFit/>
           </a:bodyPr>
           <a:lstStyle/>
           <a:p>
-            <a:pPr algn="ctr">
-              <a:defRPr sz="1200" b="1">
-                <a:solidFill>
-                  <a:srgbClr val="1E40AF"/>
-                </a:solidFill>
-              </a:defRPr>
-            </a:pPr>
-            <a:r>
-              <a:t>DIỄN TẬP AN NINH MẠNG TRỰC TIẾP</a:t>
-            </a:r>
-          </a:p>
-          <a:p>
-            <a:pPr algn="ctr">
-              <a:spcBef>
-                <a:spcPts val="1400"/>
-              </a:spcBef>
-              <a:defRPr sz="6400" b="1">
+            <a:pPr>
+              <a:defRPr sz="2100" b="1">
                 <a:solidFill>
                   <a:srgbClr val="0F172A"/>
                 </a:solidFill>
               </a:defRPr>
             </a:pPr>
             <a:r>
-              <a:t>DEMO</a:t>
-            </a:r>
-          </a:p>
-          <a:p>
-            <a:pPr algn="ctr">
-              <a:spcBef>
-                <a:spcPts val="1400"/>
-              </a:spcBef>
-              <a:defRPr sz="1500" b="1">
-                <a:solidFill>
-                  <a:srgbClr val="1E293B"/>
-                </a:solidFill>
-              </a:defRPr>
-            </a:pPr>
-            <a:r>
-              <a:t>HỆ THỐNG GIÁM SÁT TOÀN VẸN TỆP &amp; MÔ HÌNH ĐỐI KHÁNG RED TEAM VS BLUE TEAM</a:t>
-            </a:r>
-          </a:p>
-          <a:p>
-            <a:pPr algn="ctr">
-              <a:spcBef>
-                <a:spcPts val="1000"/>
-              </a:spcBef>
-              <a:defRPr sz="1100" i="1">
+              <a:t>GIAO DIỆN BẢNG ĐIỀU KHIỂN GIÁM SÁT TOÀN VẸN (BLUE TEAM)</a:t>
+            </a:r>
+          </a:p>
+        </p:txBody>
+      </p:sp>
+      <p:sp>
+        <p:nvSpPr>
+          <p:cNvPr id="5" name="TextBox 4"/>
+          <p:cNvSpPr txBox="1"/>
+          <p:nvPr/>
+        </p:nvSpPr>
+        <p:spPr>
+          <a:xfrm>
+            <a:off x="731520" y="1261872"/>
+            <a:ext cx="10698480" cy="320040"/>
+          </a:xfrm>
+          <a:prstGeom prst="rect">
+            <a:avLst/>
+          </a:prstGeom>
+          <a:noFill/>
+        </p:spPr>
+        <p:txBody>
+          <a:bodyPr wrap="square" lIns="0" rIns="0" tIns="0" bIns="0">
+            <a:spAutoFit/>
+          </a:bodyPr>
+          <a:lstStyle/>
+          <a:p>
+            <a:pPr>
+              <a:defRPr sz="1200">
                 <a:solidFill>
                   <a:srgbClr val="475569"/>
                 </a:solidFill>
               </a:defRPr>
             </a:pPr>
             <a:r>
-              <a:t>Minh họa thực nghiệm các luận điểm lý thuyết: Can thiệp dữ liệu, Nhập nhằng nút lá RFC 6962, và So sánh chuỗi thời gian hằng số</a:t>
-            </a:r>
-          </a:p>
-          <a:p>
-            <a:pPr algn="ctr">
-              <a:spcBef>
-                <a:spcPts val="1200"/>
-              </a:spcBef>
-              <a:defRPr sz="1050" b="1">
-                <a:solidFill>
-                  <a:srgbClr val="1E40AF"/>
-                </a:solidFill>
-              </a:defRPr>
-            </a:pPr>
-            <a:r>
-              <a:t>Blue Team Dashboard: http://localhost:8080   |   Red Team Adversary Engine: http://localhost:8081</a:t>
+              <a:t>Ảnh chụp thực tế từ hệ thống: Bắt quả tang tệp tin Resume/Resume.csv bị sửa đổi tại Port 8080</a:t>
+            </a:r>
+          </a:p>
+        </p:txBody>
+      </p:sp>
+      <p:pic>
+        <p:nvPicPr>
+          <p:cNvPr id="6" name="Picture 5" descr="dashboard_real_results.png"/>
+          <p:cNvPicPr>
+            <a:picLocks noChangeAspect="1"/>
+          </p:cNvPicPr>
+          <p:nvPr/>
+        </p:nvPicPr>
+        <p:blipFill>
+          <a:blip r:embed="rId2"/>
+          <a:stretch>
+            <a:fillRect/>
+          </a:stretch>
+        </p:blipFill>
+        <p:spPr>
+          <a:xfrm>
+            <a:off x="1432407" y="1691640"/>
+            <a:ext cx="9326880" cy="4361688"/>
+          </a:xfrm>
+          <a:prstGeom prst="rect">
+            <a:avLst/>
+          </a:prstGeom>
+        </p:spPr>
+      </p:pic>
+      <p:sp>
+        <p:nvSpPr>
+          <p:cNvPr id="7" name="TextBox 6"/>
+          <p:cNvSpPr txBox="1"/>
+          <p:nvPr/>
+        </p:nvSpPr>
+        <p:spPr>
+          <a:xfrm>
+            <a:off x="731520" y="6217920"/>
+            <a:ext cx="10698480" cy="365760"/>
+          </a:xfrm>
+          <a:prstGeom prst="rect">
+            <a:avLst/>
+          </a:prstGeom>
+          <a:noFill/>
+        </p:spPr>
+        <p:txBody>
+          <a:bodyPr wrap="none">
+            <a:spAutoFit/>
+          </a:bodyPr>
+          <a:lstStyle/>
+          <a:p>
+            <a:pPr>
+              <a:defRPr sz="1000" i="1">
+                <a:solidFill>
+                  <a:srgbClr val="64748B"/>
+                </a:solidFill>
+              </a:defRPr>
+            </a:pPr>
+            <a:r>
+              <a:t>Ảnh chụp màn hình thực tế từ phiên chạy thử nghiệm của đề tài; không dùng hình ảnh giả lập.</a:t>
             </a:r>
           </a:p>
         </p:txBody>
@@ -4966,7 +5009,7 @@
               </a:defRPr>
             </a:pPr>
             <a:r>
-              <a:t>SƠ ĐỒ 5: KIẾN TRÚC ĐỐI KHÁNG THỰC TẾ &amp; BẰNG CHỨNG KIỂM ĐỊNH</a:t>
+              <a:t>SƠ ĐỒ 5: KIẾN TRÚC DIỄN TẬP ĐỐI KHÁNG (DEMO ARCHITECTURE)</a:t>
             </a:r>
           </a:p>
         </p:txBody>
@@ -5036,7 +5079,7 @@
               </a:defRPr>
             </a:pPr>
             <a:r>
-              <a:t>Mô hình đối kháng thực tế 2 màn hình trên tập dữ liệu kaggle_dataset (2.483 tệp tin)</a:t>
+              <a:t>Mô hình đối kháng thực tế 2 màn hình trên tập dữ liệu kaggle_dataset (2.485 tệp tin / ~112,81 MiB theo benchmark)</a:t>
             </a:r>
           </a:p>
         </p:txBody>
@@ -5095,7 +5138,7 @@
               </a:defRPr>
             </a:pPr>
             <a:r>
-              <a:t>Sơ đồ kiến trúc kiểm thử đối kháng do sinh viên tự thiết kế minh họa các luận điểm của Halpin (2025).</a:t>
+              <a:t>Sơ đồ kiến trúc diễn tập đối kháng độc lập do sinh viên thiết kế minh họa các khái niệm an ninh.</a:t>
             </a:r>
           </a:p>
         </p:txBody>
@@ -5280,7 +5323,7 @@
               </a:defRPr>
             </a:pPr>
             <a:r>
-              <a:t>Tổng kết các đóng góp lý thuyết của Halpin và lộ trình kỹ thuật cho giai đoạn cuối kỳ</a:t>
+              <a:t>Tổng kết các đóng góp lý thuyết của Halpin và định hướng nghiên cứu tiếp theo</a:t>
             </a:r>
           </a:p>
         </p:txBody>
@@ -5532,7 +5575,7 @@
                   <a:srgbClr val="475569"/>
                 </a:solidFill>
               </a:rPr>
-              <a:t>Hoàn thành thẩm định học thuật sâu sắc toàn văn bài báo gốc (17 trang PDF), phân tích đầy đủ 7 mục nội dung và xây dựng bộ diễn tập minh họa thực nghiệm sống động phục vụ báo cáo.</a:t>
+              <a:t>Hoàn thành thẩm định học thuật sâu sắc toàn văn bài báo gốc (17 trang PDF), phân tích đầy đủ 7 mục nội dung và làm rõ khoảng cách giữa lý thuyết trừu tượng với an ninh thực tế.</a:t>
             </a:r>
           </a:p>
           <a:p>
@@ -5555,7 +5598,7 @@
                   <a:srgbClr val="475569"/>
                 </a:solidFill>
               </a:rPr>
-              <a:t>Không ngụy tạo số liệu tác giả; phân định rạch ròi giữa công trình triết học của Halpin và các thử nghiệm độc lập của sinh viên.</a:t>
+              <a:t>Không ngụy tạo số liệu tác giả; phân định rõ ràng giữa công trình khảo cứu triết học của Halpin và các kịch bản thực nghiệm minh họa độc lập do sinh viên tự xây dựng.</a:t>
             </a:r>
           </a:p>
           <a:p>
@@ -5570,7 +5613,7 @@
                   <a:srgbClr val="1E293B"/>
                 </a:solidFill>
               </a:rPr>
-              <a:t>• Lộ trình nghiên cứu cuối kỳ: </a:t>
+              <a:t>• Định hướng nghiên cứu cuối kỳ: </a:t>
             </a:r>
             <a:r>
               <a:rPr sz="1050">
@@ -5578,7 +5621,7 @@
                   <a:srgbClr val="475569"/>
                 </a:solidFill>
               </a:rPr>
-              <a:t>Đề xuất phát triển chuyên sâu giải pháp tối ưu hóa cấu trúc cây Merkle phân cấp (HD-Merkle Dirty-Path Caching, nén CompactProof O(1)) làm đóng góp kỹ thuật trọng tâm cho đồ án cuối kỳ.</a:t>
+              <a:t>Tiếp tục nghiên cứu và hoàn thiện mô hình cấu trúc cây phân cấp tối ưu cho bài toán kiểm tra toàn vẹn dữ liệu, tiến hành đo đạc và đánh giá thực nghiệm toàn diện.</a:t>
             </a:r>
           </a:p>
         </p:txBody>
@@ -5613,7 +5656,7 @@
               </a:defRPr>
             </a:pPr>
             <a:r>
-              <a:t>Tài liệu tham khảo chính: [1] H. Halpin, Oxford J. Cybersec., 2025 (DOI: 10.1093/cybsec/tyaf006); [2] Shannon (1949); [3] Goldwasser-Micali (1984); [4] Dolev-Yao (1983); [5] Kocher (1996); [6] RFC 6962 (2013).</a:t>
+              <a:t>Tài liệu tham khảo chính: Halpin (2025), Shannon (1949), Goldwasser-Micali (1984), Dolev-Yao (1983), Kocher (1996), RFC 6962.</a:t>
             </a:r>
           </a:p>
         </p:txBody>
@@ -7085,7 +7128,7 @@
                   <a:srgbClr val="475569"/>
                 </a:solidFill>
               </a:rPr>
-              <a:t>Bí mật không vĩnh cửu. Không có hệ thống nào tuyệt đối; bí mật phụ thuộc vào năng lực tính toán và thời gian của đối thủ.</a:t>
+              <a:t>Bí mật không tồn tại tự thân; nó là mối quan hệ giữa nhóm người giữ bí mật và thế giới bên ngoài trong một khoảng thời gian.</a:t>
             </a:r>
           </a:p>
           <a:p>
@@ -7108,7 +7151,7 @@
                   <a:srgbClr val="475569"/>
                 </a:solidFill>
               </a:rPr>
-              <a:t>Bản mã là tri thức công cộng (public); nhưng ý nghĩa bản rõ chỉ có thể thành tri thức phổ thông nếu có khóa.</a:t>
+              <a:t>Common Knowledge (Lewis): Mọi tác nhân đều biết và tin trạng thái sự việc. Public Knowledge: Thông tin mà bất kỳ ai cũng có tiềm năng tiếp cận (như khi bí mật bị rò rỉ - leak).</a:t>
             </a:r>
           </a:p>
         </p:txBody>
@@ -7422,7 +7465,7 @@
                   <a:srgbClr val="475569"/>
                 </a:solidFill>
               </a:rPr>
-              <a:t>Claude Shannon hình thức hóa mật mã học bằng xác suất; định nghĩa Bí mật hoàn hảo (OTP). Giả định sai lệch do 'Nhiễu ngẫu nhiên'.</a:t>
+              <a:t>Mô hình truyền thông bảo mật điểm - điểm; định nghĩa Bí mật hoàn hảo H(K) &gt;= H(M). Giới hạn: Giản lược đối thủ thành kẻ nghe lén trên kênh trừu tượng, bỏ qua chi phí phân phối khóa và thực tế xã hội - kỹ thuật.</a:t>
             </a:r>
           </a:p>
         </p:txBody>
@@ -9259,7 +9302,7 @@
               </a:defRPr>
             </a:pPr>
             <a:r>
-              <a:t>Tấn công kênh kề (Timing Attack - Kocher 1996), phân tích lưu lượng siêu dữ liệu, tấn công tiền ảnh cấp hai cấu trúc (Node-Leaf Confusion).</a:t>
+              <a:t>Tấn công kênh kề (Timing Attack - Kocher 1996), phân tích độ dài và lưu lượng siêu dữ liệu (Traffic Analysis), khai thác lỗi cài đặt phần mềm và quản lý (Anderson 2001).</a:t>
             </a:r>
           </a:p>
         </p:txBody>

</xml_diff>

<commit_message>
Update Slide 12 to clean DEMO-only slide and streamline demo script for core Halpin paper scenarios
</commit_message>
<xml_diff>
--- a/Bao_Cao_Giua_Ky_DT05_Final.pptx
+++ b/Bao_Cao_Giua_Ky_DT05_Final.pptx
@@ -4688,7 +4688,7 @@
             <a:avLst/>
           </a:prstGeom>
           <a:solidFill>
-            <a:srgbClr val="FFFFFF"/>
+            <a:srgbClr val="F8FAFC"/>
           </a:solidFill>
           <a:ln>
             <a:noFill/>
@@ -4718,68 +4718,14 @@
       </p:sp>
       <p:sp>
         <p:nvSpPr>
-          <p:cNvPr id="3" name="Rounded Rectangle 2"/>
-          <p:cNvSpPr/>
-          <p:nvPr/>
-        </p:nvSpPr>
-        <p:spPr>
-          <a:xfrm>
-            <a:off x="731520" y="365760"/>
-            <a:ext cx="4114800" cy="320040"/>
-          </a:xfrm>
-          <a:prstGeom prst="roundRect">
-            <a:avLst/>
-          </a:prstGeom>
-          <a:solidFill>
-            <a:srgbClr val="EFF6FF"/>
-          </a:solidFill>
-          <a:ln w="12700">
-            <a:solidFill>
-              <a:srgbClr val="BFDBFE"/>
-            </a:solidFill>
-          </a:ln>
-        </p:spPr>
-        <p:style>
-          <a:lnRef idx="1">
-            <a:schemeClr val="accent1"/>
-          </a:lnRef>
-          <a:fillRef idx="3">
-            <a:schemeClr val="accent1"/>
-          </a:fillRef>
-          <a:effectRef idx="2">
-            <a:schemeClr val="accent1"/>
-          </a:effectRef>
-          <a:fontRef idx="minor">
-            <a:schemeClr val="lt1"/>
-          </a:fontRef>
-        </p:style>
-        <p:txBody>
-          <a:bodyPr rtlCol="0" anchor="ctr" wrap="square"/>
-          <a:lstStyle/>
-          <a:p>
-            <a:pPr algn="ctr">
-              <a:defRPr sz="1000" b="1">
-                <a:solidFill>
-                  <a:srgbClr val="1D4ED8"/>
-                </a:solidFill>
-              </a:defRPr>
-            </a:pPr>
-            <a:r>
-              <a:t>MINH HỌA THỰC NGHIỆM ĐỘC LẬP (LIVE DEMO)</a:t>
-            </a:r>
-          </a:p>
-        </p:txBody>
-      </p:sp>
-      <p:sp>
-        <p:nvSpPr>
-          <p:cNvPr id="4" name="TextBox 3"/>
+          <p:cNvPr id="3" name="TextBox 2"/>
           <p:cNvSpPr txBox="1"/>
           <p:nvPr/>
         </p:nvSpPr>
         <p:spPr>
           <a:xfrm>
-            <a:off x="731520" y="749808"/>
-            <a:ext cx="10698480" cy="502920"/>
+            <a:off x="1828800" y="2377440"/>
+            <a:ext cx="8534095" cy="2011680"/>
           </a:xfrm>
           <a:prstGeom prst="rect">
             <a:avLst/>
@@ -4787,114 +4733,21 @@
           <a:noFill/>
         </p:spPr>
         <p:txBody>
-          <a:bodyPr wrap="square" lIns="0" rIns="0" tIns="0" bIns="0">
+          <a:bodyPr wrap="square">
             <a:spAutoFit/>
           </a:bodyPr>
           <a:lstStyle/>
           <a:p>
-            <a:pPr>
-              <a:defRPr sz="2100" b="1">
-                <a:solidFill>
-                  <a:srgbClr val="0F172A"/>
-                </a:solidFill>
-              </a:defRPr>
-            </a:pPr>
-            <a:r>
-              <a:t>GIAO DIỆN BẢNG ĐIỀU KHIỂN GIÁM SÁT TOÀN VẸN (BLUE TEAM)</a:t>
-            </a:r>
-          </a:p>
-        </p:txBody>
-      </p:sp>
-      <p:sp>
-        <p:nvSpPr>
-          <p:cNvPr id="5" name="TextBox 4"/>
-          <p:cNvSpPr txBox="1"/>
-          <p:nvPr/>
-        </p:nvSpPr>
-        <p:spPr>
-          <a:xfrm>
-            <a:off x="731520" y="1261872"/>
-            <a:ext cx="10698480" cy="320040"/>
-          </a:xfrm>
-          <a:prstGeom prst="rect">
-            <a:avLst/>
-          </a:prstGeom>
-          <a:noFill/>
-        </p:spPr>
-        <p:txBody>
-          <a:bodyPr wrap="square" lIns="0" rIns="0" tIns="0" bIns="0">
-            <a:spAutoFit/>
-          </a:bodyPr>
-          <a:lstStyle/>
-          <a:p>
-            <a:pPr>
-              <a:defRPr sz="1200">
-                <a:solidFill>
-                  <a:srgbClr val="475569"/>
-                </a:solidFill>
-              </a:defRPr>
-            </a:pPr>
-            <a:r>
-              <a:t>Ảnh chụp thực tế từ hệ thống: Bắt quả tang tệp tin Resume/Resume.csv bị sửa đổi tại Port 8080</a:t>
-            </a:r>
-          </a:p>
-        </p:txBody>
-      </p:sp>
-      <p:pic>
-        <p:nvPicPr>
-          <p:cNvPr id="6" name="Picture 5" descr="dashboard_real_results.png"/>
-          <p:cNvPicPr>
-            <a:picLocks noChangeAspect="1"/>
-          </p:cNvPicPr>
-          <p:nvPr/>
-        </p:nvPicPr>
-        <p:blipFill>
-          <a:blip r:embed="rId2"/>
-          <a:stretch>
-            <a:fillRect/>
-          </a:stretch>
-        </p:blipFill>
-        <p:spPr>
-          <a:xfrm>
-            <a:off x="1432407" y="1691640"/>
-            <a:ext cx="9326880" cy="4361688"/>
-          </a:xfrm>
-          <a:prstGeom prst="rect">
-            <a:avLst/>
-          </a:prstGeom>
-        </p:spPr>
-      </p:pic>
-      <p:sp>
-        <p:nvSpPr>
-          <p:cNvPr id="7" name="TextBox 6"/>
-          <p:cNvSpPr txBox="1"/>
-          <p:nvPr/>
-        </p:nvSpPr>
-        <p:spPr>
-          <a:xfrm>
-            <a:off x="731520" y="6217920"/>
-            <a:ext cx="10698480" cy="365760"/>
-          </a:xfrm>
-          <a:prstGeom prst="rect">
-            <a:avLst/>
-          </a:prstGeom>
-          <a:noFill/>
-        </p:spPr>
-        <p:txBody>
-          <a:bodyPr wrap="none">
-            <a:spAutoFit/>
-          </a:bodyPr>
-          <a:lstStyle/>
-          <a:p>
-            <a:pPr>
-              <a:defRPr sz="1000" i="1">
-                <a:solidFill>
-                  <a:srgbClr val="64748B"/>
-                </a:solidFill>
-              </a:defRPr>
-            </a:pPr>
-            <a:r>
-              <a:t>Ảnh chụp màn hình thực tế từ phiên chạy thử nghiệm của đề tài; không dùng hình ảnh giả lập.</a:t>
+            <a:pPr algn="ctr">
+              <a:defRPr sz="8800" b="1">
+                <a:solidFill>
+                  <a:srgbClr val="1E40AF"/>
+                </a:solidFill>
+                <a:latin typeface="Calibri"/>
+              </a:defRPr>
+            </a:pPr>
+            <a:r>
+              <a:t>DEMO</a:t>
             </a:r>
           </a:p>
         </p:txBody>

</xml_diff>

<commit_message>
Streamline slides 10, 11, 13 content in presentation and speaking script
</commit_message>
<xml_diff>
--- a/Bao_Cao_Giua_Ky_DT05_Final.pptx
+++ b/Bao_Cao_Giua_Ky_DT05_Final.pptx
@@ -3568,7 +3568,7 @@
               </a:defRPr>
             </a:pPr>
             <a:r>
-              <a:t>Làm rõ tính khả thi tái lập đối với một công trình triết học và định hướng thí nghiệm độc lập</a:t>
+              <a:t>Làm rõ tính khả thi tái lập đối với công trình triết học và định hướng thí nghiệm độc lập</a:t>
             </a:r>
           </a:p>
         </p:txBody>
@@ -3648,13 +3648,13 @@
               </a:defRPr>
             </a:pPr>
             <a:r>
-              <a:t>1. Đánh Giá Khả Năng Tái Lập (Replication Feasibility)</a:t>
+              <a:t>1. Đặc Thù Bài Báo &amp; Tính Trung Thực Khoa Học</a:t>
             </a:r>
           </a:p>
           <a:p>
             <a:pPr>
               <a:spcBef>
-                <a:spcPts val="800"/>
+                <a:spcPts val="1200"/>
               </a:spcBef>
             </a:pPr>
             <a:r>
@@ -3663,7 +3663,7 @@
                   <a:srgbClr val="1E293B"/>
                 </a:solidFill>
               </a:rPr>
-              <a:t>• Bản chất công trình: </a:t>
+              <a:t>• Khảo luận triết học thuần túy: </a:t>
             </a:r>
             <a:r>
               <a:rPr sz="1050">
@@ -3671,13 +3671,13 @@
                   <a:srgbClr val="475569"/>
                 </a:solidFill>
               </a:rPr>
-              <a:t>Bài báo của TS. Harry Halpin là một luận văn tổng quan triết học và phân tích nhận thức luận, không phải là một công trình kỹ thuật phần mềm.</a:t>
+              <a:t>Bài báo của TS. Harry Halpin là nghiên cứu nhận thức luận, hoàn toàn không có mã nguồn, không có tập dữ liệu hay bảng đo benchmark.</a:t>
             </a:r>
           </a:p>
           <a:p>
             <a:pPr>
               <a:spcBef>
-                <a:spcPts val="800"/>
+                <a:spcPts val="1200"/>
               </a:spcBef>
             </a:pPr>
             <a:r>
@@ -3686,7 +3686,7 @@
                   <a:srgbClr val="1E293B"/>
                 </a:solidFill>
               </a:rPr>
-              <a:t>• Không có tài nguyên phần mềm: </a:t>
+              <a:t>• Không tuyên bố sai lệch: </a:t>
             </a:r>
             <a:r>
               <a:rPr sz="1050">
@@ -3694,53 +3694,7 @@
                   <a:srgbClr val="475569"/>
                 </a:solidFill>
               </a:rPr>
-              <a:t>Bài báo HOÀN TOÀN KHÔNG có mã nguồn triển khai, không có tập dữ liệu thực nghiệm, không có các bảng đo thời gian (ms) hay dung lượng benchmark.</a:t>
-            </a:r>
-          </a:p>
-          <a:p>
-            <a:pPr>
-              <a:spcBef>
-                <a:spcPts val="800"/>
-              </a:spcBef>
-            </a:pPr>
-            <a:r>
-              <a:rPr b="1" sz="1100">
-                <a:solidFill>
-                  <a:srgbClr val="1E293B"/>
-                </a:solidFill>
-              </a:rPr>
-              <a:t>• Phương pháp thẩm định: </a:t>
-            </a:r>
-            <a:r>
-              <a:rPr sz="1050">
-                <a:solidFill>
-                  <a:srgbClr val="475569"/>
-                </a:solidFill>
-              </a:rPr>
-              <a:t>Nhóm sinh viên thực hiện thẩm định học thuật (Scholarly Audit) đối chiếu toàn bộ 17 trang bản in PDF, 7 mục nội dung và 134 tài liệu tham khảo.</a:t>
-            </a:r>
-          </a:p>
-          <a:p>
-            <a:pPr>
-              <a:spcBef>
-                <a:spcPts val="800"/>
-              </a:spcBef>
-            </a:pPr>
-            <a:r>
-              <a:rPr b="1" sz="1100">
-                <a:solidFill>
-                  <a:srgbClr val="1E293B"/>
-                </a:solidFill>
-              </a:rPr>
-              <a:t>• Tính trung thực học thuật: </a:t>
-            </a:r>
-            <a:r>
-              <a:rPr sz="1050">
-                <a:solidFill>
-                  <a:srgbClr val="475569"/>
-                </a:solidFill>
-              </a:rPr>
-              <a:t>Không bịa đặt số liệu gốc của tác giả; không tuyên bố 'tái lập 100% benchmark bài báo' khi tác giả không công bố benchmark.</a:t>
+              <a:t>Nhóm thẩm định toàn văn 17 trang PDF và 134 tài liệu tham khảo; tuyệt đối không bịa đặt số liệu hay tuyên bố 'tái lập 100% benchmark' của tác giả.</a:t>
             </a:r>
           </a:p>
         </p:txBody>
@@ -3826,7 +3780,7 @@
           <a:p>
             <a:pPr>
               <a:spcBef>
-                <a:spcPts val="800"/>
+                <a:spcPts val="1200"/>
               </a:spcBef>
             </a:pPr>
             <a:r>
@@ -3835,7 +3789,7 @@
                   <a:srgbClr val="1E293B"/>
                 </a:solidFill>
               </a:rPr>
-              <a:t>• Mục tiêu thực nghiệm: </a:t>
+              <a:t>• Minh họa trực quan luận điểm: </a:t>
             </a:r>
             <a:r>
               <a:rPr sz="1050">
@@ -3843,13 +3797,13 @@
                   <a:srgbClr val="475569"/>
                 </a:solidFill>
               </a:rPr>
-              <a:t>Sinh viên tự xây dựng hệ thống kiểm tra toàn vẹn tệp nhằm chuyển hóa các luận điểm lý thuyết trừu tượng của Halpin thành các kịch bản quan sát được.</a:t>
+              <a:t>Sinh viên tự phát triển hệ thống kiểm tra toàn vẹn tệp để đưa các luận điểm đối kháng trừu tượng của Halpin vào kiểm chứng thực nghiệm.</a:t>
             </a:r>
           </a:p>
           <a:p>
             <a:pPr>
               <a:spcBef>
-                <a:spcPts val="800"/>
+                <a:spcPts val="1200"/>
               </a:spcBef>
             </a:pPr>
             <a:r>
@@ -3858,7 +3812,7 @@
                   <a:srgbClr val="1E293B"/>
                 </a:solidFill>
               </a:rPr>
-              <a:t>• Minh họa trực quan: </a:t>
+              <a:t>• Phân định ranh giới rạch ròi: </a:t>
             </a:r>
             <a:r>
               <a:rPr sz="1050">
@@ -3866,53 +3820,7 @@
                   <a:srgbClr val="475569"/>
                 </a:solidFill>
               </a:rPr>
-              <a:t>Thiết kế các kịch bản kiểm thử: đối đầu toán học trên mã tuyến tính CRC32; can thiệp đường truyền Dolev-Yao; rò rỉ kênh kề thời gian so sánh chuỗi.</a:t>
-            </a:r>
-          </a:p>
-          <a:p>
-            <a:pPr>
-              <a:spcBef>
-                <a:spcPts val="800"/>
-              </a:spcBef>
-            </a:pPr>
-            <a:r>
-              <a:rPr b="1" sz="1100">
-                <a:solidFill>
-                  <a:srgbClr val="1E293B"/>
-                </a:solidFill>
-              </a:rPr>
-              <a:t>• Phân định ranh giới rõ ràng: </a:t>
-            </a:r>
-            <a:r>
-              <a:rPr sz="1050">
-                <a:solidFill>
-                  <a:srgbClr val="475569"/>
-                </a:solidFill>
-              </a:rPr>
-              <a:t>Mã nguồn và hệ thống kiểm tra toàn vẹn là đóng góp kỹ thuật độc lập của sinh viên; không được nhầm lẫn là thuật toán do Halpin đề xuất.</a:t>
-            </a:r>
-          </a:p>
-          <a:p>
-            <a:pPr>
-              <a:spcBef>
-                <a:spcPts val="800"/>
-              </a:spcBef>
-            </a:pPr>
-            <a:r>
-              <a:rPr b="1" sz="1100">
-                <a:solidFill>
-                  <a:srgbClr val="1E293B"/>
-                </a:solidFill>
-              </a:rPr>
-              <a:t>• Kiểm toán khoa học: </a:t>
-            </a:r>
-            <a:r>
-              <a:rPr sz="1050">
-                <a:solidFill>
-                  <a:srgbClr val="475569"/>
-                </a:solidFill>
-              </a:rPr>
-              <a:t>Tất cả quy trình kiểm toán mã nguồn và đối chiếu thực nghiệm được lưu vết kỹ thuật tại MIDTERM_CODE_AUDIT.md.</a:t>
+              <a:t>Mã nguồn và kịch bản đối kháng là sản phẩm độc lập của sinh viên, không phải thuật toán của Halpin (lưu vết tại MIDTERM_CODE_AUDIT.md).</a:t>
             </a:r>
           </a:p>
         </p:txBody>
@@ -4235,14 +4143,14 @@
               <a:spcAft>
                 <a:spcPts val="600"/>
               </a:spcAft>
-              <a:defRPr sz="919">
+              <a:defRPr sz="950">
                 <a:solidFill>
                   <a:srgbClr val="475569"/>
                 </a:solidFill>
               </a:defRPr>
             </a:pPr>
             <a:r>
-              <a:t>Đối thủ là tác nhân có chủ đích, không phải nhiễu ngẫu nhiên. Mã kiểm tra lỗi tuyến tính được thiết kế cho nhiễu ngẫu nhiên, không phòng vệ được trước đối thủ chủ đích.</a:t>
+              <a:t>Mã kiểm tra tuyến tính chỉ bắt lỗi ngẫu nhiên, không cản được đối thủ có chủ đích.</a:t>
             </a:r>
           </a:p>
           <a:p>
@@ -4262,14 +4170,14 @@
               <a:spcAft>
                 <a:spcPts val="600"/>
               </a:spcAft>
-              <a:defRPr sz="919">
+              <a:defRPr sz="950">
                 <a:solidFill>
                   <a:srgbClr val="475569"/>
                 </a:solidFill>
               </a:defRPr>
             </a:pPr>
             <a:r>
-              <a:t>Thử nghiệm kịch bản bù 4 byte GF(2): Kẻ tấn công giải hệ phương trình tuyến tính để qua mặt CRC32 trong tệp bị can thiệp; hàm băm phi tuyến SHA-256 phát hiện tức thì.</a:t>
+              <a:t>Giải hệ phương trình GF(2) bù 4 byte qua mặt CRC32; SHA-256 phát hiện ngay nhờ tính phi tuyến.</a:t>
             </a:r>
           </a:p>
           <a:p>
@@ -4286,14 +4194,14 @@
           </a:p>
           <a:p>
             <a:pPr>
-              <a:defRPr sz="919">
+              <a:defRPr sz="950">
                 <a:solidFill>
                   <a:srgbClr val="64748B"/>
                 </a:solidFill>
               </a:defRPr>
             </a:pPr>
             <a:r>
-              <a:t>Chỉ minh họa tính phi tuyến của hàm băm trong kịch bản giả mạo đã kiểm thử; không kết luận CRC32 bất lực trong vai trò phát hiện lỗi ngẫu nhiên vật lý.</a:t>
+              <a:t>Chỉ minh họa kịch bản giả mạo cụ thể; không phủ nhận vai trò bắt lỗi phần cứng của CRC32.</a:t>
             </a:r>
           </a:p>
         </p:txBody>
@@ -4376,7 +4284,7 @@
               </a:defRPr>
             </a:pPr>
             <a:r>
-              <a:t>2. PHÂN TÁCH MIỀN NÚT LÁ (RFC 6962)</a:t>
+              <a:t>2. PHÂN TÁCH MIỀN NÚT LÁ</a:t>
             </a:r>
           </a:p>
           <a:p>
@@ -4396,14 +4304,14 @@
               <a:spcAft>
                 <a:spcPts val="600"/>
               </a:spcAft>
-              <a:defRPr sz="919">
+              <a:defRPr sz="950">
                 <a:solidFill>
                   <a:srgbClr val="475569"/>
                 </a:solidFill>
               </a:defRPr>
             </a:pPr>
             <a:r>
-              <a:t>Halpin nhấn mạnh điểm mù khi triển khai cấu trúc dữ liệu trong thực tế, nhưng KHÔNG trực tiếp đề cập cấu trúc cây Merkle hay kỹ thuật phân tách miền.</a:t>
+              <a:t>Halpin nhấn mạnh điểm mù cấu trúc dữ liệu, nhưng không đề cập cây Merkle.</a:t>
             </a:r>
           </a:p>
           <a:p>
@@ -4423,14 +4331,14 @@
               <a:spcAft>
                 <a:spcPts val="600"/>
               </a:spcAft>
-              <a:defRPr sz="919">
+              <a:defRPr sz="950">
                 <a:solidFill>
                   <a:srgbClr val="475569"/>
                 </a:solidFill>
               </a:defRPr>
             </a:pPr>
             <a:r>
-              <a:t>Sinh viên chủ động mở rộng bài toán toàn vẹn: Cài đặt phân tách miền theo chuẩn IETF RFC 6962 (tiền tố byte 0x00 cho lá, 0x01 cho nhánh) để phòng ngừa va chạm cấu trúc tầng cây.</a:t>
+              <a:t>Cài đặt chuẩn RFC 6962 (tiền tố 0x00 cho lá, 0x01 cho nhánh) để tránh nhầm lẫn cấu trúc cây.</a:t>
             </a:r>
           </a:p>
           <a:p>
@@ -4447,14 +4355,14 @@
           </a:p>
           <a:p>
             <a:pPr>
-              <a:defRPr sz="919">
+              <a:defRPr sz="950">
                 <a:solidFill>
                   <a:srgbClr val="64748B"/>
                 </a:solidFill>
               </a:defRPr>
             </a:pPr>
             <a:r>
-              <a:t>Kỹ thuật RFC 6962 do sinh viên tự nghiên cứu tích hợp, không phải đề xuất của Halpin; chỉ phòng ngừa va chạm cấu trúc, không thay đổi độ phức tạp 2^256 của SHA-256.</a:t>
+              <a:t>Đây là giải pháp kỹ thuật độc lập do sinh viên tích hợp, không phải đề xuất của Halpin.</a:t>
             </a:r>
           </a:p>
         </p:txBody>
@@ -4557,14 +4465,14 @@
               <a:spcAft>
                 <a:spcPts val="600"/>
               </a:spcAft>
-              <a:defRPr sz="919">
+              <a:defRPr sz="950">
                 <a:solidFill>
                   <a:srgbClr val="475569"/>
                 </a:solidFill>
               </a:defRPr>
             </a:pPr>
             <a:r>
-              <a:t>Mô hình toán học trừu tượng xem mật mã là hàm lý tưởng, nhưng thời gian thực thi thực tế làm rò rỉ dữ liệu bí mật (dẫn theo Paul Kocher 1996).</a:t>
+              <a:t>Thời gian xử lý thực tế làm rò rỉ dữ liệu ngoài mô hình toán (dẫn Kocher 1996).</a:t>
             </a:r>
           </a:p>
           <a:p>
@@ -4584,14 +4492,14 @@
               <a:spcAft>
                 <a:spcPts val="600"/>
               </a:spcAft>
-              <a:defRPr sz="919">
+              <a:defRPr sz="950">
                 <a:solidFill>
                   <a:srgbClr val="475569"/>
                 </a:solidFill>
               </a:defRPr>
             </a:pPr>
             <a:r>
-              <a:t>Sinh viên xây dựng kịch bản kiểm thử đo đạc thời gian so sánh chuỗi tuần tự (dừng sớm khi gặp byte lệch) so với việc sử dụng hàm thời gian hằng số hmac.compare_digest.</a:t>
+              <a:t>Đo đạc so sánh chuỗi ngắt sớm làm rò rỉ ký tự; áp dụng hàm thời gian hằng số hmac.compare_digest.</a:t>
             </a:r>
           </a:p>
           <a:p>
@@ -4608,14 +4516,14 @@
           </a:p>
           <a:p>
             <a:pPr>
-              <a:defRPr sz="919">
+              <a:defRPr sz="950">
                 <a:solidFill>
                   <a:srgbClr val="64748B"/>
                 </a:solidFill>
               </a:defRPr>
             </a:pPr>
             <a:r>
-              <a:t>Đo đạc trên môi trường máy tính đơn có jitter hệ điều hành; chỉ minh họa rò rỉ logic ở mức phần mềm ứng dụng, không đại diện cho kênh kề phần cứng chuyên sâu.</a:t>
+              <a:t>Chỉ minh họa rò rỉ logic ở mức phần mềm ứng dụng; đo trên Python có độ trễ hệ điều hành.</a:t>
             </a:r>
           </a:p>
         </p:txBody>

</xml_diff>

<commit_message>
Streamline presentation to 13 slides: remove slides 10-11, move architecture before DEMO, add summary table, and enrich demo script
</commit_message>
<xml_diff>
--- a/Bao_Cao_Giua_Ky_DT05_Final.pptx
+++ b/Bao_Cao_Giua_Ky_DT05_Final.pptx
@@ -18,8 +18,6 @@
     <p:sldId id="266" r:id="rId17"/>
     <p:sldId id="267" r:id="rId18"/>
     <p:sldId id="268" r:id="rId19"/>
-    <p:sldId id="269" r:id="rId20"/>
-    <p:sldId id="270" r:id="rId21"/>
   </p:sldIdLst>
   <p:sldSz cx="12191695" cy="6858000" type="screen4x3"/>
   <p:notesSz cx="6858000" cy="9144000"/>
@@ -3498,7 +3496,7 @@
               </a:defRPr>
             </a:pPr>
             <a:r>
-              <a:t>ĐÁNH GIÁ PHƯƠNG PHÁP LUẬN &amp; HƯỚNG TIẾP CẬN THỰC NGHIỆM</a:t>
+              <a:t>SƠ ĐỒ 4: KIẾN TRÚC DIỄN TẬP ĐỐI KHÁNG (PRE-DEMO ARCHITECTURE)</a:t>
             </a:r>
           </a:p>
         </p:txBody>
@@ -3533,7 +3531,7 @@
               </a:defRPr>
             </a:pPr>
             <a:r>
-              <a:t>PHƯƠNG PHÁP LUẬN &amp; KHẢ NĂNG TÁI LẬP BÀI BÁO</a:t>
+              <a:t>KIẾN TRÚC DIỄN TẬP ĐỐI KHÁNG: RED TEAM VS BLUE TEAM</a:t>
             </a:r>
           </a:p>
         </p:txBody>
@@ -3568,31 +3566,55 @@
               </a:defRPr>
             </a:pPr>
             <a:r>
-              <a:t>Làm rõ tính khả thi tái lập đối với công trình triết học và định hướng thí nghiệm độc lập</a:t>
-            </a:r>
-          </a:p>
-        </p:txBody>
-      </p:sp>
-      <p:sp>
-        <p:nvSpPr>
-          <p:cNvPr id="6" name="Rounded Rectangle 5"/>
+              <a:t>Mô hình đối kháng 2 màn hình trên tập dữ liệu kaggle_dataset (2.485 tệp tin) kiểm chứng trực quan luận điểm bài báo</a:t>
+            </a:r>
+          </a:p>
+        </p:txBody>
+      </p:sp>
+      <p:pic>
+        <p:nvPicPr>
+          <p:cNvPr id="6" name="Picture 5" descr="Slide14.drawio.png"/>
+          <p:cNvPicPr>
+            <a:picLocks noChangeAspect="1"/>
+          </p:cNvPicPr>
+          <p:nvPr/>
+        </p:nvPicPr>
+        <p:blipFill>
+          <a:blip r:embed="rId2"/>
+          <a:stretch>
+            <a:fillRect/>
+          </a:stretch>
+        </p:blipFill>
+        <p:spPr>
+          <a:xfrm>
+            <a:off x="1706727" y="1572768"/>
+            <a:ext cx="8778240" cy="3794760"/>
+          </a:xfrm>
+          <a:prstGeom prst="rect">
+            <a:avLst/>
+          </a:prstGeom>
+        </p:spPr>
+      </p:pic>
+      <p:sp>
+        <p:nvSpPr>
+          <p:cNvPr id="7" name="Rounded Rectangle 6"/>
           <p:cNvSpPr/>
           <p:nvPr/>
         </p:nvSpPr>
         <p:spPr>
           <a:xfrm>
-            <a:off x="731520" y="1691640"/>
-            <a:ext cx="5212080" cy="4389120"/>
+            <a:off x="731520" y="5468112"/>
+            <a:ext cx="10728655" cy="749808"/>
           </a:xfrm>
           <a:prstGeom prst="roundRect">
             <a:avLst/>
           </a:prstGeom>
           <a:solidFill>
-            <a:srgbClr val="FFFBEB"/>
+            <a:srgbClr val="F8FAFC"/>
           </a:solidFill>
           <a:ln>
             <a:solidFill>
-              <a:srgbClr val="FDE68A"/>
+              <a:srgbClr val="BFDBFE"/>
             </a:solidFill>
           </a:ln>
         </p:spPr>
@@ -3620,14 +3642,14 @@
       </p:sp>
       <p:sp>
         <p:nvSpPr>
-          <p:cNvPr id="7" name="TextBox 6"/>
+          <p:cNvPr id="8" name="TextBox 7"/>
           <p:cNvSpPr txBox="1"/>
           <p:nvPr/>
         </p:nvSpPr>
         <p:spPr>
           <a:xfrm>
-            <a:off x="914400" y="1828800"/>
-            <a:ext cx="4846320" cy="4114800"/>
+            <a:off x="914400" y="5504688"/>
+            <a:ext cx="10362895" cy="676656"/>
           </a:xfrm>
           <a:prstGeom prst="rect">
             <a:avLst/>
@@ -3640,107 +3662,37 @@
           </a:bodyPr>
           <a:lstStyle/>
           <a:p>
-            <a:pPr>
-              <a:defRPr sz="1300" b="1">
-                <a:solidFill>
-                  <a:srgbClr val="D97706"/>
-                </a:solidFill>
-              </a:defRPr>
-            </a:pPr>
-            <a:r>
-              <a:t>1. Đặc Thù Bài Báo &amp; Tính Trung Thực Khoa Học</a:t>
+            <a:r>
+              <a:rPr b="1" sz="1050">
+                <a:solidFill>
+                  <a:srgbClr val="1E40AF"/>
+                </a:solidFill>
+              </a:rPr>
+              <a:t>Mô hình hóa thực nghiệm độc lập: </a:t>
+            </a:r>
+            <a:r>
+              <a:rPr sz="950">
+                <a:solidFill>
+                  <a:srgbClr val="1E293B"/>
+                </a:solidFill>
+              </a:rPr>
+              <a:t>Bài báo Halpin là khảo luận triết học thuần túy (không có mã nguồn). Nhóm tự phát triển hệ thống kiểm tra toàn vẹn trên tập dữ liệu kaggle_dataset để kiểm chứng trực quan 3 luận điểm cốt lõi:</a:t>
             </a:r>
           </a:p>
           <a:p>
             <a:pPr>
               <a:spcBef>
-                <a:spcPts val="1200"/>
+                <a:spcPts val="200"/>
               </a:spcBef>
             </a:pPr>
             <a:r>
-              <a:rPr b="1" sz="1100">
-                <a:solidFill>
-                  <a:srgbClr val="1E293B"/>
+              <a:rPr sz="950">
+                <a:solidFill>
+                  <a:srgbClr val="475569"/>
                 </a:solidFill>
               </a:rPr>
-              <a:t>• Khảo luận triết học thuần túy: </a:t>
-            </a:r>
-            <a:r>
-              <a:rPr sz="1050">
-                <a:solidFill>
-                  <a:srgbClr val="475569"/>
-                </a:solidFill>
-              </a:rPr>
-              <a:t>Bài báo của TS. Harry Halpin là nghiên cứu nhận thức luận, hoàn toàn không có mã nguồn, không có tập dữ liệu hay bảng đo benchmark.</a:t>
-            </a:r>
-          </a:p>
-          <a:p>
-            <a:pPr>
-              <a:spcBef>
-                <a:spcPts val="1200"/>
-              </a:spcBef>
-            </a:pPr>
-            <a:r>
-              <a:rPr b="1" sz="1100">
-                <a:solidFill>
-                  <a:srgbClr val="1E293B"/>
-                </a:solidFill>
-              </a:rPr>
-              <a:t>• Không tuyên bố sai lệch: </a:t>
-            </a:r>
-            <a:r>
-              <a:rPr sz="1050">
-                <a:solidFill>
-                  <a:srgbClr val="475569"/>
-                </a:solidFill>
-              </a:rPr>
-              <a:t>Nhóm thẩm định toàn văn 17 trang PDF và 134 tài liệu tham khảo; tuyệt đối không bịa đặt số liệu hay tuyên bố 'tái lập 100% benchmark' của tác giả.</a:t>
-            </a:r>
-          </a:p>
-        </p:txBody>
-      </p:sp>
-      <p:sp>
-        <p:nvSpPr>
-          <p:cNvPr id="8" name="Rounded Rectangle 7"/>
-          <p:cNvSpPr/>
-          <p:nvPr/>
-        </p:nvSpPr>
-        <p:spPr>
-          <a:xfrm>
-            <a:off x="6217920" y="1691640"/>
-            <a:ext cx="5212080" cy="4389120"/>
-          </a:xfrm>
-          <a:prstGeom prst="roundRect">
-            <a:avLst/>
-          </a:prstGeom>
-          <a:solidFill>
-            <a:srgbClr val="ECFDF5"/>
-          </a:solidFill>
-          <a:ln>
-            <a:solidFill>
-              <a:srgbClr val="A7F3D0"/>
-            </a:solidFill>
-          </a:ln>
-        </p:spPr>
-        <p:style>
-          <a:lnRef idx="1">
-            <a:schemeClr val="accent1"/>
-          </a:lnRef>
-          <a:fillRef idx="3">
-            <a:schemeClr val="accent1"/>
-          </a:fillRef>
-          <a:effectRef idx="2">
-            <a:schemeClr val="accent1"/>
-          </a:effectRef>
-          <a:fontRef idx="minor">
-            <a:schemeClr val="lt1"/>
-          </a:fontRef>
-        </p:style>
-        <p:txBody>
-          <a:bodyPr rtlCol="0" anchor="ctr"/>
-          <a:lstStyle/>
-          <a:p>
-            <a:pPr algn="ctr"/>
+              <a:t>• (1) Nhiễu vs Kẻ thù (Mã CRC32 bị qua mặt trên GF(2) vs SHA-256 phi tuyến) | • (2) Phân tách miền nút lá RFC 6962 | • (3) Rò rỉ kênh kề thời gian (Kocher 1996).</a:t>
+            </a:r>
           </a:p>
         </p:txBody>
       </p:sp>
@@ -3752,89 +3704,8 @@
         </p:nvSpPr>
         <p:spPr>
           <a:xfrm>
-            <a:off x="6400800" y="1828800"/>
-            <a:ext cx="4846320" cy="4114800"/>
-          </a:xfrm>
-          <a:prstGeom prst="rect">
-            <a:avLst/>
-          </a:prstGeom>
-          <a:noFill/>
-        </p:spPr>
-        <p:txBody>
-          <a:bodyPr wrap="square">
-            <a:spAutoFit/>
-          </a:bodyPr>
-          <a:lstStyle/>
-          <a:p>
-            <a:pPr>
-              <a:defRPr sz="1300" b="1">
-                <a:solidFill>
-                  <a:srgbClr val="059669"/>
-                </a:solidFill>
-              </a:defRPr>
-            </a:pPr>
-            <a:r>
-              <a:t>2. Định Hướng Thí Nghiệm Minh Họa Độc Lập</a:t>
-            </a:r>
-          </a:p>
-          <a:p>
-            <a:pPr>
-              <a:spcBef>
-                <a:spcPts val="1200"/>
-              </a:spcBef>
-            </a:pPr>
-            <a:r>
-              <a:rPr b="1" sz="1100">
-                <a:solidFill>
-                  <a:srgbClr val="1E293B"/>
-                </a:solidFill>
-              </a:rPr>
-              <a:t>• Minh họa trực quan luận điểm: </a:t>
-            </a:r>
-            <a:r>
-              <a:rPr sz="1050">
-                <a:solidFill>
-                  <a:srgbClr val="475569"/>
-                </a:solidFill>
-              </a:rPr>
-              <a:t>Sinh viên tự phát triển hệ thống kiểm tra toàn vẹn tệp để đưa các luận điểm đối kháng trừu tượng của Halpin vào kiểm chứng thực nghiệm.</a:t>
-            </a:r>
-          </a:p>
-          <a:p>
-            <a:pPr>
-              <a:spcBef>
-                <a:spcPts val="1200"/>
-              </a:spcBef>
-            </a:pPr>
-            <a:r>
-              <a:rPr b="1" sz="1100">
-                <a:solidFill>
-                  <a:srgbClr val="1E293B"/>
-                </a:solidFill>
-              </a:rPr>
-              <a:t>• Phân định ranh giới rạch ròi: </a:t>
-            </a:r>
-            <a:r>
-              <a:rPr sz="1050">
-                <a:solidFill>
-                  <a:srgbClr val="475569"/>
-                </a:solidFill>
-              </a:rPr>
-              <a:t>Mã nguồn và kịch bản đối kháng là sản phẩm độc lập của sinh viên, không phải thuật toán của Halpin (lưu vết tại MIDTERM_CODE_AUDIT.md).</a:t>
-            </a:r>
-          </a:p>
-        </p:txBody>
-      </p:sp>
-      <p:sp>
-        <p:nvSpPr>
-          <p:cNvPr id="10" name="TextBox 9"/>
-          <p:cNvSpPr txBox="1"/>
-          <p:nvPr/>
-        </p:nvSpPr>
-        <p:spPr>
-          <a:xfrm>
-            <a:off x="731520" y="6217920"/>
-            <a:ext cx="10698480" cy="365760"/>
+            <a:off x="731520" y="6291072"/>
+            <a:ext cx="10698480" cy="320040"/>
           </a:xfrm>
           <a:prstGeom prst="rect">
             <a:avLst/>
@@ -3848,14 +3719,14 @@
           <a:lstStyle/>
           <a:p>
             <a:pPr>
-              <a:defRPr sz="1000" i="1">
+              <a:defRPr sz="950" i="1">
                 <a:solidFill>
                   <a:srgbClr val="64748B"/>
                 </a:solidFill>
               </a:defRPr>
             </a:pPr>
             <a:r>
-              <a:t>Báo cáo phân định phương pháp luận độc lập của nhóm nghiên cứu đề tài DT005.</a:t>
+              <a:t>Sơ đồ kiến trúc diễn tập đối kháng độc lập do sinh viên thiết kế minh họa các khái niệm an ninh.</a:t>
             </a:r>
           </a:p>
         </p:txBody>
@@ -3893,7 +3764,7 @@
             <a:avLst/>
           </a:prstGeom>
           <a:solidFill>
-            <a:srgbClr val="FFFFFF"/>
+            <a:srgbClr val="F8FAFC"/>
           </a:solidFill>
           <a:ln>
             <a:noFill/>
@@ -3923,183 +3794,14 @@
       </p:sp>
       <p:sp>
         <p:nvSpPr>
-          <p:cNvPr id="3" name="Rounded Rectangle 2"/>
-          <p:cNvSpPr/>
-          <p:nvPr/>
-        </p:nvSpPr>
-        <p:spPr>
-          <a:xfrm>
-            <a:off x="731520" y="365760"/>
-            <a:ext cx="4114800" cy="320040"/>
-          </a:xfrm>
-          <a:prstGeom prst="roundRect">
-            <a:avLst/>
-          </a:prstGeom>
-          <a:solidFill>
-            <a:srgbClr val="EFF6FF"/>
-          </a:solidFill>
-          <a:ln w="12700">
-            <a:solidFill>
-              <a:srgbClr val="BFDBFE"/>
-            </a:solidFill>
-          </a:ln>
-        </p:spPr>
-        <p:style>
-          <a:lnRef idx="1">
-            <a:schemeClr val="accent1"/>
-          </a:lnRef>
-          <a:fillRef idx="3">
-            <a:schemeClr val="accent1"/>
-          </a:fillRef>
-          <a:effectRef idx="2">
-            <a:schemeClr val="accent1"/>
-          </a:effectRef>
-          <a:fontRef idx="minor">
-            <a:schemeClr val="lt1"/>
-          </a:fontRef>
-        </p:style>
-        <p:txBody>
-          <a:bodyPr rtlCol="0" anchor="ctr" wrap="square"/>
-          <a:lstStyle/>
-          <a:p>
-            <a:pPr algn="ctr">
-              <a:defRPr sz="1000" b="1">
-                <a:solidFill>
-                  <a:srgbClr val="1D4ED8"/>
-                </a:solidFill>
-              </a:defRPr>
-            </a:pPr>
-            <a:r>
-              <a:t>SƠ ĐỒ 4: PHÂN ĐỊNH LÝ THUYẾT &amp; THÍ NGHIỆM ĐỘC LẬP</a:t>
-            </a:r>
-          </a:p>
-        </p:txBody>
-      </p:sp>
-      <p:sp>
-        <p:nvSpPr>
-          <p:cNvPr id="4" name="TextBox 3"/>
+          <p:cNvPr id="3" name="TextBox 2"/>
           <p:cNvSpPr txBox="1"/>
           <p:nvPr/>
         </p:nvSpPr>
         <p:spPr>
           <a:xfrm>
-            <a:off x="731520" y="749808"/>
-            <a:ext cx="10698480" cy="502920"/>
-          </a:xfrm>
-          <a:prstGeom prst="rect">
-            <a:avLst/>
-          </a:prstGeom>
-          <a:noFill/>
-        </p:spPr>
-        <p:txBody>
-          <a:bodyPr wrap="square" lIns="0" rIns="0" tIns="0" bIns="0">
-            <a:spAutoFit/>
-          </a:bodyPr>
-          <a:lstStyle/>
-          <a:p>
-            <a:pPr>
-              <a:defRPr sz="2100" b="1">
-                <a:solidFill>
-                  <a:srgbClr val="0F172A"/>
-                </a:solidFill>
-              </a:defRPr>
-            </a:pPr>
-            <a:r>
-              <a:t>MINH HỌA PAPER-TO-CODE ĐỘC LẬP &amp; GIỚI HẠN DIỄN GIẢI</a:t>
-            </a:r>
-          </a:p>
-        </p:txBody>
-      </p:sp>
-      <p:sp>
-        <p:nvSpPr>
-          <p:cNvPr id="5" name="TextBox 4"/>
-          <p:cNvSpPr txBox="1"/>
-          <p:nvPr/>
-        </p:nvSpPr>
-        <p:spPr>
-          <a:xfrm>
-            <a:off x="731520" y="1261872"/>
-            <a:ext cx="10698480" cy="320040"/>
-          </a:xfrm>
-          <a:prstGeom prst="rect">
-            <a:avLst/>
-          </a:prstGeom>
-          <a:noFill/>
-        </p:spPr>
-        <p:txBody>
-          <a:bodyPr wrap="square" lIns="0" rIns="0" tIns="0" bIns="0">
-            <a:spAutoFit/>
-          </a:bodyPr>
-          <a:lstStyle/>
-          <a:p>
-            <a:pPr>
-              <a:defRPr sz="1200">
-                <a:solidFill>
-                  <a:srgbClr val="475569"/>
-                </a:solidFill>
-              </a:defRPr>
-            </a:pPr>
-            <a:r>
-              <a:t>Đối sánh minh bạch giữa các luận điểm bài báo và thí nghiệm minh họa do sinh viên xây dựng</a:t>
-            </a:r>
-          </a:p>
-        </p:txBody>
-      </p:sp>
-      <p:sp>
-        <p:nvSpPr>
-          <p:cNvPr id="6" name="Rounded Rectangle 5"/>
-          <p:cNvSpPr/>
-          <p:nvPr/>
-        </p:nvSpPr>
-        <p:spPr>
-          <a:xfrm>
-            <a:off x="731520" y="1691640"/>
-            <a:ext cx="3383280" cy="4389120"/>
-          </a:xfrm>
-          <a:prstGeom prst="roundRect">
-            <a:avLst/>
-          </a:prstGeom>
-          <a:solidFill>
-            <a:srgbClr val="F8FAFC"/>
-          </a:solidFill>
-          <a:ln>
-            <a:solidFill>
-              <a:srgbClr val="E2E8F0"/>
-            </a:solidFill>
-          </a:ln>
-        </p:spPr>
-        <p:style>
-          <a:lnRef idx="1">
-            <a:schemeClr val="accent1"/>
-          </a:lnRef>
-          <a:fillRef idx="3">
-            <a:schemeClr val="accent1"/>
-          </a:fillRef>
-          <a:effectRef idx="2">
-            <a:schemeClr val="accent1"/>
-          </a:effectRef>
-          <a:fontRef idx="minor">
-            <a:schemeClr val="lt1"/>
-          </a:fontRef>
-        </p:style>
-        <p:txBody>
-          <a:bodyPr rtlCol="0" anchor="ctr"/>
-          <a:lstStyle/>
-          <a:p>
-            <a:pPr algn="ctr"/>
-          </a:p>
-        </p:txBody>
-      </p:sp>
-      <p:sp>
-        <p:nvSpPr>
-          <p:cNvPr id="7" name="TextBox 6"/>
-          <p:cNvSpPr txBox="1"/>
-          <p:nvPr/>
-        </p:nvSpPr>
-        <p:spPr>
-          <a:xfrm>
-            <a:off x="914400" y="1828800"/>
-            <a:ext cx="3017520" cy="4114800"/>
+            <a:off x="1828800" y="2377440"/>
+            <a:ext cx="8534095" cy="2011680"/>
           </a:xfrm>
           <a:prstGeom prst="rect">
             <a:avLst/>
@@ -4112,453 +3814,16 @@
           </a:bodyPr>
           <a:lstStyle/>
           <a:p>
-            <a:pPr>
-              <a:spcAft>
-                <a:spcPts val="800"/>
-              </a:spcAft>
-              <a:defRPr sz="1150" b="1">
-                <a:solidFill>
-                  <a:srgbClr val="0F172A"/>
-                </a:solidFill>
-              </a:defRPr>
-            </a:pPr>
-            <a:r>
-              <a:t>1. NHIỄU vs ĐỐI THỦ CHỦ ĐÍCH</a:t>
-            </a:r>
-          </a:p>
-          <a:p>
-            <a:pPr>
-              <a:defRPr sz="1000" b="1">
-                <a:solidFill>
-                  <a:srgbClr val="1E293B"/>
-                </a:solidFill>
-              </a:defRPr>
-            </a:pPr>
-            <a:r>
-              <a:t>Luận điểm Halpin (Sec. 1–2):</a:t>
-            </a:r>
-          </a:p>
-          <a:p>
-            <a:pPr>
-              <a:spcAft>
-                <a:spcPts val="600"/>
-              </a:spcAft>
-              <a:defRPr sz="950">
-                <a:solidFill>
-                  <a:srgbClr val="475569"/>
-                </a:solidFill>
-              </a:defRPr>
-            </a:pPr>
-            <a:r>
-              <a:t>Mã kiểm tra tuyến tính chỉ bắt lỗi ngẫu nhiên, không cản được đối thủ có chủ đích.</a:t>
-            </a:r>
-          </a:p>
-          <a:p>
-            <a:pPr>
-              <a:defRPr sz="1000" b="1">
-                <a:solidFill>
-                  <a:srgbClr val="1E293B"/>
-                </a:solidFill>
-              </a:defRPr>
-            </a:pPr>
-            <a:r>
-              <a:t>Minh họa độc lập (DT005):</a:t>
-            </a:r>
-          </a:p>
-          <a:p>
-            <a:pPr>
-              <a:spcAft>
-                <a:spcPts val="600"/>
-              </a:spcAft>
-              <a:defRPr sz="950">
-                <a:solidFill>
-                  <a:srgbClr val="475569"/>
-                </a:solidFill>
-              </a:defRPr>
-            </a:pPr>
-            <a:r>
-              <a:t>Giải hệ phương trình GF(2) bù 4 byte qua mặt CRC32; SHA-256 phát hiện ngay nhờ tính phi tuyến.</a:t>
-            </a:r>
-          </a:p>
-          <a:p>
-            <a:pPr>
-              <a:defRPr sz="1000" b="1">
-                <a:solidFill>
-                  <a:srgbClr val="1E293B"/>
-                </a:solidFill>
-              </a:defRPr>
-            </a:pPr>
-            <a:r>
-              <a:t>Giới hạn diễn giải:</a:t>
-            </a:r>
-          </a:p>
-          <a:p>
-            <a:pPr>
-              <a:defRPr sz="950">
-                <a:solidFill>
-                  <a:srgbClr val="64748B"/>
-                </a:solidFill>
-              </a:defRPr>
-            </a:pPr>
-            <a:r>
-              <a:t>Chỉ minh họa kịch bản giả mạo cụ thể; không phủ nhận vai trò bắt lỗi phần cứng của CRC32.</a:t>
-            </a:r>
-          </a:p>
-        </p:txBody>
-      </p:sp>
-      <p:sp>
-        <p:nvSpPr>
-          <p:cNvPr id="8" name="Rounded Rectangle 7"/>
-          <p:cNvSpPr/>
-          <p:nvPr/>
-        </p:nvSpPr>
-        <p:spPr>
-          <a:xfrm>
-            <a:off x="4389120" y="1691640"/>
-            <a:ext cx="3383280" cy="4389120"/>
-          </a:xfrm>
-          <a:prstGeom prst="roundRect">
-            <a:avLst/>
-          </a:prstGeom>
-          <a:solidFill>
-            <a:srgbClr val="F8FAFC"/>
-          </a:solidFill>
-          <a:ln>
-            <a:solidFill>
-              <a:srgbClr val="E2E8F0"/>
-            </a:solidFill>
-          </a:ln>
-        </p:spPr>
-        <p:style>
-          <a:lnRef idx="1">
-            <a:schemeClr val="accent1"/>
-          </a:lnRef>
-          <a:fillRef idx="3">
-            <a:schemeClr val="accent1"/>
-          </a:fillRef>
-          <a:effectRef idx="2">
-            <a:schemeClr val="accent1"/>
-          </a:effectRef>
-          <a:fontRef idx="minor">
-            <a:schemeClr val="lt1"/>
-          </a:fontRef>
-        </p:style>
-        <p:txBody>
-          <a:bodyPr rtlCol="0" anchor="ctr"/>
-          <a:lstStyle/>
-          <a:p>
-            <a:pPr algn="ctr"/>
-          </a:p>
-        </p:txBody>
-      </p:sp>
-      <p:sp>
-        <p:nvSpPr>
-          <p:cNvPr id="9" name="TextBox 8"/>
-          <p:cNvSpPr txBox="1"/>
-          <p:nvPr/>
-        </p:nvSpPr>
-        <p:spPr>
-          <a:xfrm>
-            <a:off x="4572000" y="1828800"/>
-            <a:ext cx="3017520" cy="4114800"/>
-          </a:xfrm>
-          <a:prstGeom prst="rect">
-            <a:avLst/>
-          </a:prstGeom>
-          <a:noFill/>
-        </p:spPr>
-        <p:txBody>
-          <a:bodyPr wrap="square">
-            <a:spAutoFit/>
-          </a:bodyPr>
-          <a:lstStyle/>
-          <a:p>
-            <a:pPr>
-              <a:spcAft>
-                <a:spcPts val="800"/>
-              </a:spcAft>
-              <a:defRPr sz="1150" b="1">
-                <a:solidFill>
-                  <a:srgbClr val="0F172A"/>
-                </a:solidFill>
-              </a:defRPr>
-            </a:pPr>
-            <a:r>
-              <a:t>2. PHÂN TÁCH MIỀN NÚT LÁ</a:t>
-            </a:r>
-          </a:p>
-          <a:p>
-            <a:pPr>
-              <a:defRPr sz="1000" b="1">
-                <a:solidFill>
-                  <a:srgbClr val="1E293B"/>
-                </a:solidFill>
-              </a:defRPr>
-            </a:pPr>
-            <a:r>
-              <a:t>Gốc lý thuyết bài báo:</a:t>
-            </a:r>
-          </a:p>
-          <a:p>
-            <a:pPr>
-              <a:spcAft>
-                <a:spcPts val="600"/>
-              </a:spcAft>
-              <a:defRPr sz="950">
-                <a:solidFill>
-                  <a:srgbClr val="475569"/>
-                </a:solidFill>
-              </a:defRPr>
-            </a:pPr>
-            <a:r>
-              <a:t>Halpin nhấn mạnh điểm mù cấu trúc dữ liệu, nhưng không đề cập cây Merkle.</a:t>
-            </a:r>
-          </a:p>
-          <a:p>
-            <a:pPr>
-              <a:defRPr sz="1000" b="1">
-                <a:solidFill>
-                  <a:srgbClr val="1E293B"/>
-                </a:solidFill>
-              </a:defRPr>
-            </a:pPr>
-            <a:r>
-              <a:t>Minh họa độc lập (DT005):</a:t>
-            </a:r>
-          </a:p>
-          <a:p>
-            <a:pPr>
-              <a:spcAft>
-                <a:spcPts val="600"/>
-              </a:spcAft>
-              <a:defRPr sz="950">
-                <a:solidFill>
-                  <a:srgbClr val="475569"/>
-                </a:solidFill>
-              </a:defRPr>
-            </a:pPr>
-            <a:r>
-              <a:t>Cài đặt chuẩn RFC 6962 (tiền tố 0x00 cho lá, 0x01 cho nhánh) để tránh nhầm lẫn cấu trúc cây.</a:t>
-            </a:r>
-          </a:p>
-          <a:p>
-            <a:pPr>
-              <a:defRPr sz="1000" b="1">
-                <a:solidFill>
-                  <a:srgbClr val="1E293B"/>
-                </a:solidFill>
-              </a:defRPr>
-            </a:pPr>
-            <a:r>
-              <a:t>Giới hạn diễn giải:</a:t>
-            </a:r>
-          </a:p>
-          <a:p>
-            <a:pPr>
-              <a:defRPr sz="950">
-                <a:solidFill>
-                  <a:srgbClr val="64748B"/>
-                </a:solidFill>
-              </a:defRPr>
-            </a:pPr>
-            <a:r>
-              <a:t>Đây là giải pháp kỹ thuật độc lập do sinh viên tích hợp, không phải đề xuất của Halpin.</a:t>
-            </a:r>
-          </a:p>
-        </p:txBody>
-      </p:sp>
-      <p:sp>
-        <p:nvSpPr>
-          <p:cNvPr id="10" name="Rounded Rectangle 9"/>
-          <p:cNvSpPr/>
-          <p:nvPr/>
-        </p:nvSpPr>
-        <p:spPr>
-          <a:xfrm>
-            <a:off x="8046720" y="1691640"/>
-            <a:ext cx="3383280" cy="4389120"/>
-          </a:xfrm>
-          <a:prstGeom prst="roundRect">
-            <a:avLst/>
-          </a:prstGeom>
-          <a:solidFill>
-            <a:srgbClr val="F8FAFC"/>
-          </a:solidFill>
-          <a:ln>
-            <a:solidFill>
-              <a:srgbClr val="E2E8F0"/>
-            </a:solidFill>
-          </a:ln>
-        </p:spPr>
-        <p:style>
-          <a:lnRef idx="1">
-            <a:schemeClr val="accent1"/>
-          </a:lnRef>
-          <a:fillRef idx="3">
-            <a:schemeClr val="accent1"/>
-          </a:fillRef>
-          <a:effectRef idx="2">
-            <a:schemeClr val="accent1"/>
-          </a:effectRef>
-          <a:fontRef idx="minor">
-            <a:schemeClr val="lt1"/>
-          </a:fontRef>
-        </p:style>
-        <p:txBody>
-          <a:bodyPr rtlCol="0" anchor="ctr"/>
-          <a:lstStyle/>
-          <a:p>
-            <a:pPr algn="ctr"/>
-          </a:p>
-        </p:txBody>
-      </p:sp>
-      <p:sp>
-        <p:nvSpPr>
-          <p:cNvPr id="11" name="TextBox 10"/>
-          <p:cNvSpPr txBox="1"/>
-          <p:nvPr/>
-        </p:nvSpPr>
-        <p:spPr>
-          <a:xfrm>
-            <a:off x="8229600" y="1828800"/>
-            <a:ext cx="3017520" cy="4114800"/>
-          </a:xfrm>
-          <a:prstGeom prst="rect">
-            <a:avLst/>
-          </a:prstGeom>
-          <a:noFill/>
-        </p:spPr>
-        <p:txBody>
-          <a:bodyPr wrap="square">
-            <a:spAutoFit/>
-          </a:bodyPr>
-          <a:lstStyle/>
-          <a:p>
-            <a:pPr>
-              <a:spcAft>
-                <a:spcPts val="800"/>
-              </a:spcAft>
-              <a:defRPr sz="1150" b="1">
-                <a:solidFill>
-                  <a:srgbClr val="0F172A"/>
-                </a:solidFill>
-              </a:defRPr>
-            </a:pPr>
-            <a:r>
-              <a:t>3. RÒ RỈ KÊNH KỀ THỜI GIAN</a:t>
-            </a:r>
-          </a:p>
-          <a:p>
-            <a:pPr>
-              <a:defRPr sz="1000" b="1">
-                <a:solidFill>
-                  <a:srgbClr val="1E293B"/>
-                </a:solidFill>
-              </a:defRPr>
-            </a:pPr>
-            <a:r>
-              <a:t>Luận điểm Halpin (Sec. 5):</a:t>
-            </a:r>
-          </a:p>
-          <a:p>
-            <a:pPr>
-              <a:spcAft>
-                <a:spcPts val="600"/>
-              </a:spcAft>
-              <a:defRPr sz="950">
-                <a:solidFill>
-                  <a:srgbClr val="475569"/>
-                </a:solidFill>
-              </a:defRPr>
-            </a:pPr>
-            <a:r>
-              <a:t>Thời gian xử lý thực tế làm rò rỉ dữ liệu ngoài mô hình toán (dẫn Kocher 1996).</a:t>
-            </a:r>
-          </a:p>
-          <a:p>
-            <a:pPr>
-              <a:defRPr sz="1000" b="1">
-                <a:solidFill>
-                  <a:srgbClr val="1E293B"/>
-                </a:solidFill>
-              </a:defRPr>
-            </a:pPr>
-            <a:r>
-              <a:t>Minh họa độc lập (DT005):</a:t>
-            </a:r>
-          </a:p>
-          <a:p>
-            <a:pPr>
-              <a:spcAft>
-                <a:spcPts val="600"/>
-              </a:spcAft>
-              <a:defRPr sz="950">
-                <a:solidFill>
-                  <a:srgbClr val="475569"/>
-                </a:solidFill>
-              </a:defRPr>
-            </a:pPr>
-            <a:r>
-              <a:t>Đo đạc so sánh chuỗi ngắt sớm làm rò rỉ ký tự; áp dụng hàm thời gian hằng số hmac.compare_digest.</a:t>
-            </a:r>
-          </a:p>
-          <a:p>
-            <a:pPr>
-              <a:defRPr sz="1000" b="1">
-                <a:solidFill>
-                  <a:srgbClr val="1E293B"/>
-                </a:solidFill>
-              </a:defRPr>
-            </a:pPr>
-            <a:r>
-              <a:t>Giới hạn diễn giải:</a:t>
-            </a:r>
-          </a:p>
-          <a:p>
-            <a:pPr>
-              <a:defRPr sz="950">
-                <a:solidFill>
-                  <a:srgbClr val="64748B"/>
-                </a:solidFill>
-              </a:defRPr>
-            </a:pPr>
-            <a:r>
-              <a:t>Chỉ minh họa rò rỉ logic ở mức phần mềm ứng dụng; đo trên Python có độ trễ hệ điều hành.</a:t>
-            </a:r>
-          </a:p>
-        </p:txBody>
-      </p:sp>
-      <p:sp>
-        <p:nvSpPr>
-          <p:cNvPr id="12" name="TextBox 11"/>
-          <p:cNvSpPr txBox="1"/>
-          <p:nvPr/>
-        </p:nvSpPr>
-        <p:spPr>
-          <a:xfrm>
-            <a:off x="731520" y="6217920"/>
-            <a:ext cx="10698480" cy="365760"/>
-          </a:xfrm>
-          <a:prstGeom prst="rect">
-            <a:avLst/>
-          </a:prstGeom>
-          <a:noFill/>
-        </p:spPr>
-        <p:txBody>
-          <a:bodyPr wrap="none">
-            <a:spAutoFit/>
-          </a:bodyPr>
-          <a:lstStyle/>
-          <a:p>
-            <a:pPr>
-              <a:defRPr sz="1000" i="1">
-                <a:solidFill>
-                  <a:srgbClr val="64748B"/>
-                </a:solidFill>
-              </a:defRPr>
-            </a:pPr>
-            <a:r>
-              <a:t>Bảng đối chiếu minh bạch do sinh viên tự xây dựng; chi tiết mã nguồn lưu tại MIDTERM_CODE_AUDIT.md.</a:t>
+            <a:pPr algn="ctr">
+              <a:defRPr sz="8800" b="1">
+                <a:solidFill>
+                  <a:srgbClr val="1E40AF"/>
+                </a:solidFill>
+                <a:latin typeface="Calibri"/>
+              </a:defRPr>
+            </a:pPr>
+            <a:r>
+              <a:t>DEMO</a:t>
             </a:r>
           </a:p>
         </p:txBody>
@@ -4596,7 +3861,7 @@
             <a:avLst/>
           </a:prstGeom>
           <a:solidFill>
-            <a:srgbClr val="F8FAFC"/>
+            <a:srgbClr val="FFFFFF"/>
           </a:solidFill>
           <a:ln>
             <a:noFill/>
@@ -4626,14 +3891,68 @@
       </p:sp>
       <p:sp>
         <p:nvSpPr>
-          <p:cNvPr id="3" name="TextBox 2"/>
+          <p:cNvPr id="3" name="Rounded Rectangle 2"/>
+          <p:cNvSpPr/>
+          <p:nvPr/>
+        </p:nvSpPr>
+        <p:spPr>
+          <a:xfrm>
+            <a:off x="731520" y="365760"/>
+            <a:ext cx="4114800" cy="320040"/>
+          </a:xfrm>
+          <a:prstGeom prst="roundRect">
+            <a:avLst/>
+          </a:prstGeom>
+          <a:solidFill>
+            <a:srgbClr val="EFF6FF"/>
+          </a:solidFill>
+          <a:ln w="12700">
+            <a:solidFill>
+              <a:srgbClr val="BFDBFE"/>
+            </a:solidFill>
+          </a:ln>
+        </p:spPr>
+        <p:style>
+          <a:lnRef idx="1">
+            <a:schemeClr val="accent1"/>
+          </a:lnRef>
+          <a:fillRef idx="3">
+            <a:schemeClr val="accent1"/>
+          </a:fillRef>
+          <a:effectRef idx="2">
+            <a:schemeClr val="accent1"/>
+          </a:effectRef>
+          <a:fontRef idx="minor">
+            <a:schemeClr val="lt1"/>
+          </a:fontRef>
+        </p:style>
+        <p:txBody>
+          <a:bodyPr rtlCol="0" anchor="ctr" wrap="square"/>
+          <a:lstStyle/>
+          <a:p>
+            <a:pPr algn="ctr">
+              <a:defRPr sz="1000" b="1">
+                <a:solidFill>
+                  <a:srgbClr val="1D4ED8"/>
+                </a:solidFill>
+              </a:defRPr>
+            </a:pPr>
+            <a:r>
+              <a:t>SECTION 7 — TỔNG KẾT TOÀN VĂN BÀI BÁO (HARRY HALPIN 2025)</a:t>
+            </a:r>
+          </a:p>
+        </p:txBody>
+      </p:sp>
+      <p:sp>
+        <p:nvSpPr>
+          <p:cNvPr id="4" name="TextBox 3"/>
           <p:cNvSpPr txBox="1"/>
           <p:nvPr/>
         </p:nvSpPr>
         <p:spPr>
           <a:xfrm>
-            <a:off x="1828800" y="2377440"/>
-            <a:ext cx="8534095" cy="2011680"/>
+            <a:off x="731520" y="749808"/>
+            <a:ext cx="10698480" cy="502920"/>
           </a:xfrm>
           <a:prstGeom prst="rect">
             <a:avLst/>
@@ -4641,21 +3960,616 @@
           <a:noFill/>
         </p:spPr>
         <p:txBody>
-          <a:bodyPr wrap="square">
+          <a:bodyPr wrap="square" lIns="0" rIns="0" tIns="0" bIns="0">
             <a:spAutoFit/>
           </a:bodyPr>
           <a:lstStyle/>
           <a:p>
-            <a:pPr algn="ctr">
-              <a:defRPr sz="8800" b="1">
-                <a:solidFill>
-                  <a:srgbClr val="1E40AF"/>
-                </a:solidFill>
-                <a:latin typeface="Calibri"/>
-              </a:defRPr>
-            </a:pPr>
-            <a:r>
-              <a:t>DEMO</a:t>
+            <a:pPr>
+              <a:defRPr sz="2100" b="1">
+                <a:solidFill>
+                  <a:srgbClr val="0F172A"/>
+                </a:solidFill>
+              </a:defRPr>
+            </a:pPr>
+            <a:r>
+              <a:t>TỔNG KẾT BÁO CÁO: ĐÓNG GÓP HỌC THUẬT &amp; BÀI HỌC AN NINH</a:t>
+            </a:r>
+          </a:p>
+        </p:txBody>
+      </p:sp>
+      <p:sp>
+        <p:nvSpPr>
+          <p:cNvPr id="5" name="TextBox 4"/>
+          <p:cNvSpPr txBox="1"/>
+          <p:nvPr/>
+        </p:nvSpPr>
+        <p:spPr>
+          <a:xfrm>
+            <a:off x="731520" y="1261872"/>
+            <a:ext cx="10698480" cy="320040"/>
+          </a:xfrm>
+          <a:prstGeom prst="rect">
+            <a:avLst/>
+          </a:prstGeom>
+          <a:noFill/>
+        </p:spPr>
+        <p:txBody>
+          <a:bodyPr wrap="square" lIns="0" rIns="0" tIns="0" bIns="0">
+            <a:spAutoFit/>
+          </a:bodyPr>
+          <a:lstStyle/>
+          <a:p>
+            <a:pPr>
+              <a:defRPr sz="1200">
+                <a:solidFill>
+                  <a:srgbClr val="475569"/>
+                </a:solidFill>
+              </a:defRPr>
+            </a:pPr>
+            <a:r>
+              <a:t>Bảng đối sánh giữa các giả định hình thức truyền thống và nhận thức luận của Harry Halpin</a:t>
+            </a:r>
+          </a:p>
+        </p:txBody>
+      </p:sp>
+      <p:graphicFrame>
+        <p:nvGraphicFramePr>
+          <p:cNvPr id="6" name="Table 5"/>
+          <p:cNvGraphicFramePr>
+            <a:graphicFrameLocks noGrp="1"/>
+          </p:cNvGraphicFramePr>
+          <p:nvPr/>
+        </p:nvGraphicFramePr>
+        <p:xfrm>
+          <a:off x="731520" y="1691640"/>
+          <a:ext cx="10728655" cy="4297680"/>
+        </p:xfrm>
+        <a:graphic>
+          <a:graphicData uri="http://schemas.openxmlformats.org/drawingml/2006/table">
+            <a:tbl>
+              <a:tblPr firstRow="1" bandRow="1">
+                <a:tableStyleId>{5C22544A-7EE6-4342-B048-85BDC9FD1C3A}</a:tableStyleId>
+              </a:tblPr>
+              <a:tblGrid>
+                <a:gridCol w="1920240"/>
+                <a:gridCol w="2834640"/>
+                <a:gridCol w="3017520"/>
+                <a:gridCol w="2956255"/>
+              </a:tblGrid>
+              <a:tr h="859536">
+                <a:tc>
+                  <a:txBody>
+                    <a:bodyPr wrap="square" lIns="73152" rIns="73152"/>
+                    <a:lstStyle/>
+                    <a:p>
+                      <a:pPr algn="ctr">
+                        <a:defRPr b="1" sz="1050">
+                          <a:solidFill>
+                            <a:srgbClr val="FFFFFF"/>
+                          </a:solidFill>
+                        </a:defRPr>
+                      </a:pPr>
+                      <a:r>
+                        <a:t>Trụ Cột Khảo Cứu</a:t>
+                      </a:r>
+                    </a:p>
+                  </a:txBody>
+                  <a:tcPr anchor="ctr">
+                    <a:solidFill>
+                      <a:srgbClr val="1E40AF"/>
+                    </a:solidFill>
+                  </a:tcPr>
+                </a:tc>
+                <a:tc>
+                  <a:txBody>
+                    <a:bodyPr wrap="square" lIns="73152" rIns="73152"/>
+                    <a:lstStyle/>
+                    <a:p>
+                      <a:pPr algn="ctr">
+                        <a:defRPr b="1" sz="1050">
+                          <a:solidFill>
+                            <a:srgbClr val="FFFFFF"/>
+                          </a:solidFill>
+                        </a:defRPr>
+                      </a:pPr>
+                      <a:r>
+                        <a:t>Mô Hình Toán Hình Thức</a:t>
+                      </a:r>
+                      <a:br/>
+                      <a:r>
+                        <a:t>(Shannon &amp; Hộp Đen)</a:t>
+                      </a:r>
+                    </a:p>
+                  </a:txBody>
+                  <a:tcPr anchor="ctr">
+                    <a:solidFill>
+                      <a:srgbClr val="1E40AF"/>
+                    </a:solidFill>
+                  </a:tcPr>
+                </a:tc>
+                <a:tc>
+                  <a:txBody>
+                    <a:bodyPr wrap="square" lIns="73152" rIns="73152"/>
+                    <a:lstStyle/>
+                    <a:p>
+                      <a:pPr algn="ctr">
+                        <a:defRPr b="1" sz="1050">
+                          <a:solidFill>
+                            <a:srgbClr val="FFFFFF"/>
+                          </a:solidFill>
+                        </a:defRPr>
+                      </a:pPr>
+                      <a:r>
+                        <a:t>Phê Phán Nhận Thức Luận</a:t>
+                      </a:r>
+                      <a:br/>
+                      <a:r>
+                        <a:t>(Harry Halpin 2025)</a:t>
+                      </a:r>
+                    </a:p>
+                  </a:txBody>
+                  <a:tcPr anchor="ctr">
+                    <a:solidFill>
+                      <a:srgbClr val="1E40AF"/>
+                    </a:solidFill>
+                  </a:tcPr>
+                </a:tc>
+                <a:tc>
+                  <a:txBody>
+                    <a:bodyPr wrap="square" lIns="73152" rIns="73152"/>
+                    <a:lstStyle/>
+                    <a:p>
+                      <a:pPr algn="ctr">
+                        <a:defRPr b="1" sz="1050">
+                          <a:solidFill>
+                            <a:srgbClr val="FFFFFF"/>
+                          </a:solidFill>
+                        </a:defRPr>
+                      </a:pPr>
+                      <a:r>
+                        <a:t>Bài Học &amp; Định Hướng</a:t>
+                      </a:r>
+                      <a:br/>
+                      <a:r>
+                        <a:t>An Ninh Thực Tế</a:t>
+                      </a:r>
+                    </a:p>
+                  </a:txBody>
+                  <a:tcPr anchor="ctr">
+                    <a:solidFill>
+                      <a:srgbClr val="1E40AF"/>
+                    </a:solidFill>
+                  </a:tcPr>
+                </a:tc>
+              </a:tr>
+              <a:tr h="859536">
+                <a:tc>
+                  <a:txBody>
+                    <a:bodyPr wrap="square" lIns="73152" rIns="73152"/>
+                    <a:lstStyle/>
+                    <a:p>
+                      <a:pPr>
+                        <a:defRPr b="1" sz="1000">
+                          <a:solidFill>
+                            <a:srgbClr val="1E40AF"/>
+                          </a:solidFill>
+                        </a:defRPr>
+                      </a:pPr>
+                      <a:r>
+                        <a:t>1. Bản chất thông tin &amp;</a:t>
+                      </a:r>
+                      <a:br/>
+                      <a:r>
+                        <a:t>Bí mật an toàn (Sec 1–2)</a:t>
+                      </a:r>
+                    </a:p>
+                  </a:txBody>
+                  <a:tcPr anchor="ctr">
+                    <a:solidFill>
+                      <a:srgbClr val="F8FAFC"/>
+                    </a:solidFill>
+                  </a:tcPr>
+                </a:tc>
+                <a:tc>
+                  <a:txBody>
+                    <a:bodyPr wrap="square" lIns="73152" rIns="73152"/>
+                    <a:lstStyle/>
+                    <a:p>
+                      <a:pPr>
+                        <a:defRPr sz="950">
+                          <a:solidFill>
+                            <a:srgbClr val="1E293B"/>
+                          </a:solidFill>
+                        </a:defRPr>
+                      </a:pPr>
+                      <a:r>
+                        <a:t>Coi thông tin là xác suất thống kê; kênh truyền chỉ chịu nhiễu ngẫu nhiên; an toàn tuyệt đối là One-Time Pad.</a:t>
+                      </a:r>
+                    </a:p>
+                  </a:txBody>
+                  <a:tcPr anchor="ctr">
+                    <a:solidFill>
+                      <a:srgbClr val="F8FAFC"/>
+                    </a:solidFill>
+                  </a:tcPr>
+                </a:tc>
+                <a:tc>
+                  <a:txBody>
+                    <a:bodyPr wrap="square" lIns="73152" rIns="73152"/>
+                    <a:lstStyle/>
+                    <a:p>
+                      <a:pPr>
+                        <a:defRPr sz="950">
+                          <a:solidFill>
+                            <a:srgbClr val="1E293B"/>
+                          </a:solidFill>
+                        </a:defRPr>
+                      </a:pPr>
+                      <a:r>
+                        <a:t>Thông tin mang ngữ nghĩa khách quan (Dretske); đối thủ là tác nhân có chủ đích, liên tục tìm cách khai thác.</a:t>
+                      </a:r>
+                    </a:p>
+                  </a:txBody>
+                  <a:tcPr anchor="ctr">
+                    <a:solidFill>
+                      <a:srgbClr val="F8FAFC"/>
+                    </a:solidFill>
+                  </a:tcPr>
+                </a:tc>
+                <a:tc>
+                  <a:txBody>
+                    <a:bodyPr wrap="square" lIns="73152" rIns="73152"/>
+                    <a:lstStyle/>
+                    <a:p>
+                      <a:pPr>
+                        <a:defRPr sz="950">
+                          <a:solidFill>
+                            <a:srgbClr val="1E293B"/>
+                          </a:solidFill>
+                        </a:defRPr>
+                      </a:pPr>
+                      <a:r>
+                        <a:t>Phân định rạch ròi giữa bắt lỗi ngẫu nhiên và an ninh đối kháng; mã tuyến tính (CRC32) không thể thay thế hàm băm phi tuyến (SHA-256).</a:t>
+                      </a:r>
+                    </a:p>
+                  </a:txBody>
+                  <a:tcPr anchor="ctr">
+                    <a:solidFill>
+                      <a:srgbClr val="F8FAFC"/>
+                    </a:solidFill>
+                  </a:tcPr>
+                </a:tc>
+              </a:tr>
+              <a:tr h="859536">
+                <a:tc>
+                  <a:txBody>
+                    <a:bodyPr wrap="square" lIns="73152" rIns="73152"/>
+                    <a:lstStyle/>
+                    <a:p>
+                      <a:pPr>
+                        <a:defRPr b="1" sz="1000">
+                          <a:solidFill>
+                            <a:srgbClr val="1E40AF"/>
+                          </a:solidFill>
+                        </a:defRPr>
+                      </a:pPr>
+                      <a:r>
+                        <a:t>2. Giới hạn của sự</a:t>
+                      </a:r>
+                      <a:br/>
+                      <a:r>
+                        <a:t>hình thức hóa (Sec 5)</a:t>
+                      </a:r>
+                    </a:p>
+                  </a:txBody>
+                  <a:tcPr anchor="ctr">
+                    <a:solidFill>
+                      <a:srgbClr val="FFFFFF"/>
+                    </a:solidFill>
+                  </a:tcPr>
+                </a:tc>
+                <a:tc>
+                  <a:txBody>
+                    <a:bodyPr wrap="square" lIns="73152" rIns="73152"/>
+                    <a:lstStyle/>
+                    <a:p>
+                      <a:pPr>
+                        <a:defRPr sz="950">
+                          <a:solidFill>
+                            <a:srgbClr val="1E293B"/>
+                          </a:solidFill>
+                        </a:defRPr>
+                      </a:pPr>
+                      <a:r>
+                        <a:t>Coi thuật toán mật mã là hộp đen toán học lý tưởng; thời gian và phần cứng thực thi là vô hình.</a:t>
+                      </a:r>
+                    </a:p>
+                  </a:txBody>
+                  <a:tcPr anchor="ctr">
+                    <a:solidFill>
+                      <a:srgbClr val="FFFFFF"/>
+                    </a:solidFill>
+                  </a:tcPr>
+                </a:tc>
+                <a:tc>
+                  <a:txBody>
+                    <a:bodyPr wrap="square" lIns="73152" rIns="73152"/>
+                    <a:lstStyle/>
+                    <a:p>
+                      <a:pPr>
+                        <a:defRPr sz="950">
+                          <a:solidFill>
+                            <a:srgbClr val="1E293B"/>
+                          </a:solidFill>
+                        </a:defRPr>
+                      </a:pPr>
+                      <a:r>
+                        <a:t>Sự trừu tượng hóa làm mật mã học mù quáng trước thế giới vật lý: bỏ qua thời gian CPU, năng lượng, lỗi cài đặt.</a:t>
+                      </a:r>
+                    </a:p>
+                  </a:txBody>
+                  <a:tcPr anchor="ctr">
+                    <a:solidFill>
+                      <a:srgbClr val="FFFFFF"/>
+                    </a:solidFill>
+                  </a:tcPr>
+                </a:tc>
+                <a:tc>
+                  <a:txBody>
+                    <a:bodyPr wrap="square" lIns="73152" rIns="73152"/>
+                    <a:lstStyle/>
+                    <a:p>
+                      <a:pPr>
+                        <a:defRPr sz="950">
+                          <a:solidFill>
+                            <a:srgbClr val="1E293B"/>
+                          </a:solidFill>
+                        </a:defRPr>
+                      </a:pPr>
+                      <a:r>
+                        <a:t>Xây dựng hệ thống an toàn đa tầng; áp dụng hàm so sánh thời gian hằng số (hmac.compare_digest) triệt tiêu rò rỉ kênh kề.</a:t>
+                      </a:r>
+                    </a:p>
+                  </a:txBody>
+                  <a:tcPr anchor="ctr">
+                    <a:solidFill>
+                      <a:srgbClr val="FFFFFF"/>
+                    </a:solidFill>
+                  </a:tcPr>
+                </a:tc>
+              </a:tr>
+              <a:tr h="859536">
+                <a:tc>
+                  <a:txBody>
+                    <a:bodyPr wrap="square" lIns="73152" rIns="73152"/>
+                    <a:lstStyle/>
+                    <a:p>
+                      <a:pPr>
+                        <a:defRPr b="1" sz="1000">
+                          <a:solidFill>
+                            <a:srgbClr val="1E40AF"/>
+                          </a:solidFill>
+                        </a:defRPr>
+                      </a:pPr>
+                      <a:r>
+                        <a:t>3. Đối thủ trong</a:t>
+                      </a:r>
+                      <a:br/>
+                      <a:r>
+                        <a:t>thế giới thực (Sec 6)</a:t>
+                      </a:r>
+                    </a:p>
+                  </a:txBody>
+                  <a:tcPr anchor="ctr">
+                    <a:solidFill>
+                      <a:srgbClr val="F8FAFC"/>
+                    </a:solidFill>
+                  </a:tcPr>
+                </a:tc>
+                <a:tc>
+                  <a:txBody>
+                    <a:bodyPr wrap="square" lIns="73152" rIns="73152"/>
+                    <a:lstStyle/>
+                    <a:p>
+                      <a:pPr>
+                        <a:defRPr sz="950">
+                          <a:solidFill>
+                            <a:srgbClr val="1E293B"/>
+                          </a:solidFill>
+                        </a:defRPr>
+                      </a:pPr>
+                      <a:r>
+                        <a:t>Đối thủ bị giới hạn trong năng lực tính toán đa thức (PPT) hoặc tấn công vào đường truyền (Dolev-Yao).</a:t>
+                      </a:r>
+                    </a:p>
+                  </a:txBody>
+                  <a:tcPr anchor="ctr">
+                    <a:solidFill>
+                      <a:srgbClr val="F8FAFC"/>
+                    </a:solidFill>
+                  </a:tcPr>
+                </a:tc>
+                <a:tc>
+                  <a:txBody>
+                    <a:bodyPr wrap="square" lIns="73152" rIns="73152"/>
+                    <a:lstStyle/>
+                    <a:p>
+                      <a:pPr>
+                        <a:defRPr sz="950">
+                          <a:solidFill>
+                            <a:srgbClr val="1E293B"/>
+                          </a:solidFill>
+                        </a:defRPr>
+                      </a:pPr>
+                      <a:r>
+                        <a:t>Snowden tiết lộ đối thủ thể chế (NSA) có nguồn lực khổng lồ: khai thác siêu dữ liệu, cài cửa sau chuẩn NIST.</a:t>
+                      </a:r>
+                    </a:p>
+                  </a:txBody>
+                  <a:tcPr anchor="ctr">
+                    <a:solidFill>
+                      <a:srgbClr val="F8FAFC"/>
+                    </a:solidFill>
+                  </a:tcPr>
+                </a:tc>
+                <a:tc>
+                  <a:txBody>
+                    <a:bodyPr wrap="square" lIns="73152" rIns="73152"/>
+                    <a:lstStyle/>
+                    <a:p>
+                      <a:pPr>
+                        <a:defRPr sz="950">
+                          <a:solidFill>
+                            <a:srgbClr val="1E293B"/>
+                          </a:solidFill>
+                        </a:defRPr>
+                      </a:pPr>
+                      <a:r>
+                        <a:t>Mở rộng nghiên cứu mật mã chống cửa sau (Cliptography); bảo vệ siêu dữ liệu và cấu trúc dữ liệu minh bạch (RFC 6962).</a:t>
+                      </a:r>
+                    </a:p>
+                  </a:txBody>
+                  <a:tcPr anchor="ctr">
+                    <a:solidFill>
+                      <a:srgbClr val="F8FAFC"/>
+                    </a:solidFill>
+                  </a:tcPr>
+                </a:tc>
+              </a:tr>
+              <a:tr h="859536">
+                <a:tc>
+                  <a:txBody>
+                    <a:bodyPr wrap="square" lIns="73152" rIns="73152"/>
+                    <a:lstStyle/>
+                    <a:p>
+                      <a:pPr>
+                        <a:defRPr b="1" sz="1000">
+                          <a:solidFill>
+                            <a:srgbClr val="1E40AF"/>
+                          </a:solidFill>
+                        </a:defRPr>
+                      </a:pPr>
+                      <a:r>
+                        <a:t>4. Chương trình nghiên cứu</a:t>
+                      </a:r>
+                      <a:br/>
+                      <a:r>
+                        <a:t>tương lai (Sec 7)</a:t>
+                      </a:r>
+                    </a:p>
+                  </a:txBody>
+                  <a:tcPr anchor="ctr">
+                    <a:solidFill>
+                      <a:srgbClr val="FFFFFF"/>
+                    </a:solidFill>
+                  </a:tcPr>
+                </a:tc>
+                <a:tc>
+                  <a:txBody>
+                    <a:bodyPr wrap="square" lIns="73152" rIns="73152"/>
+                    <a:lstStyle/>
+                    <a:p>
+                      <a:pPr>
+                        <a:defRPr sz="950">
+                          <a:solidFill>
+                            <a:srgbClr val="1E293B"/>
+                          </a:solidFill>
+                        </a:defRPr>
+                      </a:pPr>
+                      <a:r>
+                        <a:t>Mật mã học là phân nhánh độc lập thuần túy của toán học rời rạc và khoa học máy tính lý thuyết.</a:t>
+                      </a:r>
+                    </a:p>
+                  </a:txBody>
+                  <a:tcPr anchor="ctr">
+                    <a:solidFill>
+                      <a:srgbClr val="FFFFFF"/>
+                    </a:solidFill>
+                  </a:tcPr>
+                </a:tc>
+                <a:tc>
+                  <a:txBody>
+                    <a:bodyPr wrap="square" lIns="73152" rIns="73152"/>
+                    <a:lstStyle/>
+                    <a:p>
+                      <a:pPr>
+                        <a:defRPr sz="950">
+                          <a:solidFill>
+                            <a:srgbClr val="1E293B"/>
+                          </a:solidFill>
+                        </a:defRPr>
+                      </a:pPr>
+                      <a:r>
+                        <a:t>Đặt ra 4 câu hỏi mở: tích hợp phương pháp liên ngành, dùng thống kê lượng hóa đối thủ, mô hình hóa hệ thống phức hợp.</a:t>
+                      </a:r>
+                    </a:p>
+                  </a:txBody>
+                  <a:tcPr anchor="ctr">
+                    <a:solidFill>
+                      <a:srgbClr val="FFFFFF"/>
+                    </a:solidFill>
+                  </a:tcPr>
+                </a:tc>
+                <a:tc>
+                  <a:txBody>
+                    <a:bodyPr wrap="square" lIns="73152" rIns="73152"/>
+                    <a:lstStyle/>
+                    <a:p>
+                      <a:pPr>
+                        <a:defRPr sz="950">
+                          <a:solidFill>
+                            <a:srgbClr val="1E293B"/>
+                          </a:solidFill>
+                        </a:defRPr>
+                      </a:pPr>
+                      <a:r>
+                        <a:t>Kết hợp toán học với triết học nhận thức và dữ liệu thực nghiệm để xây dựng một khoa học an ninh hoàn chỉnh.</a:t>
+                      </a:r>
+                    </a:p>
+                  </a:txBody>
+                  <a:tcPr anchor="ctr">
+                    <a:solidFill>
+                      <a:srgbClr val="FFFFFF"/>
+                    </a:solidFill>
+                  </a:tcPr>
+                </a:tc>
+              </a:tr>
+            </a:tbl>
+          </a:graphicData>
+        </a:graphic>
+      </p:graphicFrame>
+      <p:sp>
+        <p:nvSpPr>
+          <p:cNvPr id="7" name="TextBox 6"/>
+          <p:cNvSpPr txBox="1"/>
+          <p:nvPr/>
+        </p:nvSpPr>
+        <p:spPr>
+          <a:xfrm>
+            <a:off x="731520" y="6217920"/>
+            <a:ext cx="10698480" cy="365760"/>
+          </a:xfrm>
+          <a:prstGeom prst="rect">
+            <a:avLst/>
+          </a:prstGeom>
+          <a:noFill/>
+        </p:spPr>
+        <p:txBody>
+          <a:bodyPr wrap="none">
+            <a:spAutoFit/>
+          </a:bodyPr>
+          <a:lstStyle/>
+          <a:p>
+            <a:pPr>
+              <a:defRPr sz="950" i="1">
+                <a:solidFill>
+                  <a:srgbClr val="64748B"/>
+                </a:solidFill>
+              </a:defRPr>
+            </a:pPr>
+            <a:r>
+              <a:t>Tài liệu tham khảo chính: Halpin (2025), Shannon (1949), Goldwasser-Micali (1984), Dolev-Yao (1983), Kocher (1996), RFC 6962.</a:t>
             </a:r>
           </a:p>
         </p:txBody>
@@ -4669,768 +4583,6 @@
 </file>
 
 <file path=ppt/slides/slide13.xml><?xml version="1.0" encoding="utf-8"?>
-<p:sld xmlns:a="http://schemas.openxmlformats.org/drawingml/2006/main" xmlns:p="http://schemas.openxmlformats.org/presentationml/2006/main" xmlns:r="http://schemas.openxmlformats.org/officeDocument/2006/relationships">
-  <p:cSld>
-    <p:spTree>
-      <p:nvGrpSpPr>
-        <p:cNvPr id="1" name=""/>
-        <p:cNvGrpSpPr/>
-        <p:nvPr/>
-      </p:nvGrpSpPr>
-      <p:grpSpPr/>
-      <p:sp>
-        <p:nvSpPr>
-          <p:cNvPr id="2" name="Rectangle 1"/>
-          <p:cNvSpPr/>
-          <p:nvPr/>
-        </p:nvSpPr>
-        <p:spPr>
-          <a:xfrm>
-            <a:off x="0" y="0"/>
-            <a:ext cx="12191695" cy="6858000"/>
-          </a:xfrm>
-          <a:prstGeom prst="rect">
-            <a:avLst/>
-          </a:prstGeom>
-          <a:solidFill>
-            <a:srgbClr val="FFFFFF"/>
-          </a:solidFill>
-          <a:ln>
-            <a:noFill/>
-          </a:ln>
-        </p:spPr>
-        <p:style>
-          <a:lnRef idx="1">
-            <a:schemeClr val="accent1"/>
-          </a:lnRef>
-          <a:fillRef idx="3">
-            <a:schemeClr val="accent1"/>
-          </a:fillRef>
-          <a:effectRef idx="2">
-            <a:schemeClr val="accent1"/>
-          </a:effectRef>
-          <a:fontRef idx="minor">
-            <a:schemeClr val="lt1"/>
-          </a:fontRef>
-        </p:style>
-        <p:txBody>
-          <a:bodyPr rtlCol="0" anchor="ctr"/>
-          <a:lstStyle/>
-          <a:p>
-            <a:pPr algn="ctr"/>
-          </a:p>
-        </p:txBody>
-      </p:sp>
-      <p:sp>
-        <p:nvSpPr>
-          <p:cNvPr id="3" name="Rounded Rectangle 2"/>
-          <p:cNvSpPr/>
-          <p:nvPr/>
-        </p:nvSpPr>
-        <p:spPr>
-          <a:xfrm>
-            <a:off x="731520" y="365760"/>
-            <a:ext cx="4114800" cy="320040"/>
-          </a:xfrm>
-          <a:prstGeom prst="roundRect">
-            <a:avLst/>
-          </a:prstGeom>
-          <a:solidFill>
-            <a:srgbClr val="EFF6FF"/>
-          </a:solidFill>
-          <a:ln w="12700">
-            <a:solidFill>
-              <a:srgbClr val="BFDBFE"/>
-            </a:solidFill>
-          </a:ln>
-        </p:spPr>
-        <p:style>
-          <a:lnRef idx="1">
-            <a:schemeClr val="accent1"/>
-          </a:lnRef>
-          <a:fillRef idx="3">
-            <a:schemeClr val="accent1"/>
-          </a:fillRef>
-          <a:effectRef idx="2">
-            <a:schemeClr val="accent1"/>
-          </a:effectRef>
-          <a:fontRef idx="minor">
-            <a:schemeClr val="lt1"/>
-          </a:fontRef>
-        </p:style>
-        <p:txBody>
-          <a:bodyPr rtlCol="0" anchor="ctr" wrap="square"/>
-          <a:lstStyle/>
-          <a:p>
-            <a:pPr algn="ctr">
-              <a:defRPr sz="1000" b="1">
-                <a:solidFill>
-                  <a:srgbClr val="1D4ED8"/>
-                </a:solidFill>
-              </a:defRPr>
-            </a:pPr>
-            <a:r>
-              <a:t>SƠ ĐỒ 5: KIẾN TRÚC DIỄN TẬP ĐỐI KHÁNG (DEMO ARCHITECTURE)</a:t>
-            </a:r>
-          </a:p>
-        </p:txBody>
-      </p:sp>
-      <p:sp>
-        <p:nvSpPr>
-          <p:cNvPr id="4" name="TextBox 3"/>
-          <p:cNvSpPr txBox="1"/>
-          <p:nvPr/>
-        </p:nvSpPr>
-        <p:spPr>
-          <a:xfrm>
-            <a:off x="731520" y="749808"/>
-            <a:ext cx="10698480" cy="502920"/>
-          </a:xfrm>
-          <a:prstGeom prst="rect">
-            <a:avLst/>
-          </a:prstGeom>
-          <a:noFill/>
-        </p:spPr>
-        <p:txBody>
-          <a:bodyPr wrap="square" lIns="0" rIns="0" tIns="0" bIns="0">
-            <a:spAutoFit/>
-          </a:bodyPr>
-          <a:lstStyle/>
-          <a:p>
-            <a:pPr>
-              <a:defRPr sz="2100" b="1">
-                <a:solidFill>
-                  <a:srgbClr val="0F172A"/>
-                </a:solidFill>
-              </a:defRPr>
-            </a:pPr>
-            <a:r>
-              <a:t>KIẾN TRÚC DIỄN TẬP ĐỐI KHÁNG: RED TEAM VS BLUE TEAM</a:t>
-            </a:r>
-          </a:p>
-        </p:txBody>
-      </p:sp>
-      <p:sp>
-        <p:nvSpPr>
-          <p:cNvPr id="5" name="TextBox 4"/>
-          <p:cNvSpPr txBox="1"/>
-          <p:nvPr/>
-        </p:nvSpPr>
-        <p:spPr>
-          <a:xfrm>
-            <a:off x="731520" y="1261872"/>
-            <a:ext cx="10698480" cy="320040"/>
-          </a:xfrm>
-          <a:prstGeom prst="rect">
-            <a:avLst/>
-          </a:prstGeom>
-          <a:noFill/>
-        </p:spPr>
-        <p:txBody>
-          <a:bodyPr wrap="square" lIns="0" rIns="0" tIns="0" bIns="0">
-            <a:spAutoFit/>
-          </a:bodyPr>
-          <a:lstStyle/>
-          <a:p>
-            <a:pPr>
-              <a:defRPr sz="1200">
-                <a:solidFill>
-                  <a:srgbClr val="475569"/>
-                </a:solidFill>
-              </a:defRPr>
-            </a:pPr>
-            <a:r>
-              <a:t>Mô hình đối kháng thực tế 2 màn hình trên tập dữ liệu kaggle_dataset (2.485 tệp tin / ~112,81 MiB theo benchmark)</a:t>
-            </a:r>
-          </a:p>
-        </p:txBody>
-      </p:sp>
-      <p:pic>
-        <p:nvPicPr>
-          <p:cNvPr id="6" name="Picture 5" descr="Slide14.drawio.png"/>
-          <p:cNvPicPr>
-            <a:picLocks noChangeAspect="1"/>
-          </p:cNvPicPr>
-          <p:nvPr/>
-        </p:nvPicPr>
-        <p:blipFill>
-          <a:blip r:embed="rId2"/>
-          <a:stretch>
-            <a:fillRect/>
-          </a:stretch>
-        </p:blipFill>
-        <p:spPr>
-          <a:xfrm>
-            <a:off x="1386687" y="1664208"/>
-            <a:ext cx="9418320" cy="4425696"/>
-          </a:xfrm>
-          <a:prstGeom prst="rect">
-            <a:avLst/>
-          </a:prstGeom>
-        </p:spPr>
-      </p:pic>
-      <p:sp>
-        <p:nvSpPr>
-          <p:cNvPr id="7" name="TextBox 6"/>
-          <p:cNvSpPr txBox="1"/>
-          <p:nvPr/>
-        </p:nvSpPr>
-        <p:spPr>
-          <a:xfrm>
-            <a:off x="731520" y="6217920"/>
-            <a:ext cx="10698480" cy="365760"/>
-          </a:xfrm>
-          <a:prstGeom prst="rect">
-            <a:avLst/>
-          </a:prstGeom>
-          <a:noFill/>
-        </p:spPr>
-        <p:txBody>
-          <a:bodyPr wrap="none">
-            <a:spAutoFit/>
-          </a:bodyPr>
-          <a:lstStyle/>
-          <a:p>
-            <a:pPr>
-              <a:defRPr sz="1000" i="1">
-                <a:solidFill>
-                  <a:srgbClr val="64748B"/>
-                </a:solidFill>
-              </a:defRPr>
-            </a:pPr>
-            <a:r>
-              <a:t>Sơ đồ kiến trúc diễn tập đối kháng độc lập do sinh viên thiết kế minh họa các khái niệm an ninh.</a:t>
-            </a:r>
-          </a:p>
-        </p:txBody>
-      </p:sp>
-    </p:spTree>
-  </p:cSld>
-  <p:clrMapOvr>
-    <a:masterClrMapping/>
-  </p:clrMapOvr>
-</p:sld>
-</file>
-
-<file path=ppt/slides/slide14.xml><?xml version="1.0" encoding="utf-8"?>
-<p:sld xmlns:a="http://schemas.openxmlformats.org/drawingml/2006/main" xmlns:p="http://schemas.openxmlformats.org/presentationml/2006/main" xmlns:r="http://schemas.openxmlformats.org/officeDocument/2006/relationships">
-  <p:cSld>
-    <p:spTree>
-      <p:nvGrpSpPr>
-        <p:cNvPr id="1" name=""/>
-        <p:cNvGrpSpPr/>
-        <p:nvPr/>
-      </p:nvGrpSpPr>
-      <p:grpSpPr/>
-      <p:sp>
-        <p:nvSpPr>
-          <p:cNvPr id="2" name="Rectangle 1"/>
-          <p:cNvSpPr/>
-          <p:nvPr/>
-        </p:nvSpPr>
-        <p:spPr>
-          <a:xfrm>
-            <a:off x="0" y="0"/>
-            <a:ext cx="12191695" cy="6858000"/>
-          </a:xfrm>
-          <a:prstGeom prst="rect">
-            <a:avLst/>
-          </a:prstGeom>
-          <a:solidFill>
-            <a:srgbClr val="FFFFFF"/>
-          </a:solidFill>
-          <a:ln>
-            <a:noFill/>
-          </a:ln>
-        </p:spPr>
-        <p:style>
-          <a:lnRef idx="1">
-            <a:schemeClr val="accent1"/>
-          </a:lnRef>
-          <a:fillRef idx="3">
-            <a:schemeClr val="accent1"/>
-          </a:fillRef>
-          <a:effectRef idx="2">
-            <a:schemeClr val="accent1"/>
-          </a:effectRef>
-          <a:fontRef idx="minor">
-            <a:schemeClr val="lt1"/>
-          </a:fontRef>
-        </p:style>
-        <p:txBody>
-          <a:bodyPr rtlCol="0" anchor="ctr"/>
-          <a:lstStyle/>
-          <a:p>
-            <a:pPr algn="ctr"/>
-          </a:p>
-        </p:txBody>
-      </p:sp>
-      <p:sp>
-        <p:nvSpPr>
-          <p:cNvPr id="3" name="Rounded Rectangle 2"/>
-          <p:cNvSpPr/>
-          <p:nvPr/>
-        </p:nvSpPr>
-        <p:spPr>
-          <a:xfrm>
-            <a:off x="731520" y="365760"/>
-            <a:ext cx="4114800" cy="320040"/>
-          </a:xfrm>
-          <a:prstGeom prst="roundRect">
-            <a:avLst/>
-          </a:prstGeom>
-          <a:solidFill>
-            <a:srgbClr val="EFF6FF"/>
-          </a:solidFill>
-          <a:ln w="12700">
-            <a:solidFill>
-              <a:srgbClr val="BFDBFE"/>
-            </a:solidFill>
-          </a:ln>
-        </p:spPr>
-        <p:style>
-          <a:lnRef idx="1">
-            <a:schemeClr val="accent1"/>
-          </a:lnRef>
-          <a:fillRef idx="3">
-            <a:schemeClr val="accent1"/>
-          </a:fillRef>
-          <a:effectRef idx="2">
-            <a:schemeClr val="accent1"/>
-          </a:effectRef>
-          <a:fontRef idx="minor">
-            <a:schemeClr val="lt1"/>
-          </a:fontRef>
-        </p:style>
-        <p:txBody>
-          <a:bodyPr rtlCol="0" anchor="ctr" wrap="square"/>
-          <a:lstStyle/>
-          <a:p>
-            <a:pPr algn="ctr">
-              <a:defRPr sz="1000" b="1">
-                <a:solidFill>
-                  <a:srgbClr val="1D4ED8"/>
-                </a:solidFill>
-              </a:defRPr>
-            </a:pPr>
-            <a:r>
-              <a:t>SECTION 7 — KẾT LUẬN &amp; THÔNG ĐIỆP HỌC THUẬT</a:t>
-            </a:r>
-          </a:p>
-        </p:txBody>
-      </p:sp>
-      <p:sp>
-        <p:nvSpPr>
-          <p:cNvPr id="4" name="TextBox 3"/>
-          <p:cNvSpPr txBox="1"/>
-          <p:nvPr/>
-        </p:nvSpPr>
-        <p:spPr>
-          <a:xfrm>
-            <a:off x="731520" y="749808"/>
-            <a:ext cx="10698480" cy="502920"/>
-          </a:xfrm>
-          <a:prstGeom prst="rect">
-            <a:avLst/>
-          </a:prstGeom>
-          <a:noFill/>
-        </p:spPr>
-        <p:txBody>
-          <a:bodyPr wrap="square" lIns="0" rIns="0" tIns="0" bIns="0">
-            <a:spAutoFit/>
-          </a:bodyPr>
-          <a:lstStyle/>
-          <a:p>
-            <a:pPr>
-              <a:defRPr sz="2100" b="1">
-                <a:solidFill>
-                  <a:srgbClr val="0F172A"/>
-                </a:solidFill>
-              </a:defRPr>
-            </a:pPr>
-            <a:r>
-              <a:t>TỔNG KẾT BÁO CÁO GIỮA KỲ &amp; ĐỊNH HƯỚNG NGHIÊN CỨU</a:t>
-            </a:r>
-          </a:p>
-        </p:txBody>
-      </p:sp>
-      <p:sp>
-        <p:nvSpPr>
-          <p:cNvPr id="5" name="TextBox 4"/>
-          <p:cNvSpPr txBox="1"/>
-          <p:nvPr/>
-        </p:nvSpPr>
-        <p:spPr>
-          <a:xfrm>
-            <a:off x="731520" y="1261872"/>
-            <a:ext cx="10698480" cy="320040"/>
-          </a:xfrm>
-          <a:prstGeom prst="rect">
-            <a:avLst/>
-          </a:prstGeom>
-          <a:noFill/>
-        </p:spPr>
-        <p:txBody>
-          <a:bodyPr wrap="square" lIns="0" rIns="0" tIns="0" bIns="0">
-            <a:spAutoFit/>
-          </a:bodyPr>
-          <a:lstStyle/>
-          <a:p>
-            <a:pPr>
-              <a:defRPr sz="1200">
-                <a:solidFill>
-                  <a:srgbClr val="475569"/>
-                </a:solidFill>
-              </a:defRPr>
-            </a:pPr>
-            <a:r>
-              <a:t>Tổng kết các đóng góp lý thuyết của Halpin và định hướng nghiên cứu tiếp theo</a:t>
-            </a:r>
-          </a:p>
-        </p:txBody>
-      </p:sp>
-      <p:sp>
-        <p:nvSpPr>
-          <p:cNvPr id="6" name="Rounded Rectangle 5"/>
-          <p:cNvSpPr/>
-          <p:nvPr/>
-        </p:nvSpPr>
-        <p:spPr>
-          <a:xfrm>
-            <a:off x="731520" y="1691640"/>
-            <a:ext cx="5212080" cy="4206240"/>
-          </a:xfrm>
-          <a:prstGeom prst="roundRect">
-            <a:avLst/>
-          </a:prstGeom>
-          <a:solidFill>
-            <a:srgbClr val="F8FAFC"/>
-          </a:solidFill>
-          <a:ln>
-            <a:solidFill>
-              <a:srgbClr val="BFDBFE"/>
-            </a:solidFill>
-          </a:ln>
-        </p:spPr>
-        <p:style>
-          <a:lnRef idx="1">
-            <a:schemeClr val="accent1"/>
-          </a:lnRef>
-          <a:fillRef idx="3">
-            <a:schemeClr val="accent1"/>
-          </a:fillRef>
-          <a:effectRef idx="2">
-            <a:schemeClr val="accent1"/>
-          </a:effectRef>
-          <a:fontRef idx="minor">
-            <a:schemeClr val="lt1"/>
-          </a:fontRef>
-        </p:style>
-        <p:txBody>
-          <a:bodyPr rtlCol="0" anchor="ctr"/>
-          <a:lstStyle/>
-          <a:p>
-            <a:pPr algn="ctr"/>
-          </a:p>
-        </p:txBody>
-      </p:sp>
-      <p:sp>
-        <p:nvSpPr>
-          <p:cNvPr id="7" name="TextBox 6"/>
-          <p:cNvSpPr txBox="1"/>
-          <p:nvPr/>
-        </p:nvSpPr>
-        <p:spPr>
-          <a:xfrm>
-            <a:off x="914400" y="1828800"/>
-            <a:ext cx="4846320" cy="3931920"/>
-          </a:xfrm>
-          <a:prstGeom prst="rect">
-            <a:avLst/>
-          </a:prstGeom>
-          <a:noFill/>
-        </p:spPr>
-        <p:txBody>
-          <a:bodyPr wrap="square">
-            <a:spAutoFit/>
-          </a:bodyPr>
-          <a:lstStyle/>
-          <a:p>
-            <a:pPr>
-              <a:defRPr sz="1300" b="1">
-                <a:solidFill>
-                  <a:srgbClr val="1E40AF"/>
-                </a:solidFill>
-              </a:defRPr>
-            </a:pPr>
-            <a:r>
-              <a:t>1. Thông Điệp Học Thuật Cốt Lõi (Harry Halpin 2025)</a:t>
-            </a:r>
-          </a:p>
-          <a:p>
-            <a:pPr>
-              <a:spcBef>
-                <a:spcPts val="800"/>
-              </a:spcBef>
-            </a:pPr>
-            <a:r>
-              <a:rPr b="1" sz="1100">
-                <a:solidFill>
-                  <a:srgbClr val="1E293B"/>
-                </a:solidFill>
-              </a:rPr>
-              <a:t>• Vượt qua sự trừu tượng hóa: </a:t>
-            </a:r>
-            <a:r>
-              <a:rPr sz="1050">
-                <a:solidFill>
-                  <a:srgbClr val="475569"/>
-                </a:solidFill>
-              </a:rPr>
-              <a:t>Mật mã học không chỉ là toán học thuần túy trên giấy tờ. Các hệ thống an toàn trong thế giới thực phải nhận thức rõ khoảng cách giữa mô hình lý tưởng và thực tế vật lý (kênh kề, siêu dữ liệu, chuỗi cung ứng, áp lực thể chế).</a:t>
-            </a:r>
-          </a:p>
-          <a:p>
-            <a:pPr>
-              <a:spcBef>
-                <a:spcPts val="800"/>
-              </a:spcBef>
-            </a:pPr>
-            <a:r>
-              <a:rPr b="1" sz="1100">
-                <a:solidFill>
-                  <a:srgbClr val="1E293B"/>
-                </a:solidFill>
-              </a:rPr>
-              <a:t>• Bản chất của đối thủ: </a:t>
-            </a:r>
-            <a:r>
-              <a:rPr sz="1050">
-                <a:solidFill>
-                  <a:srgbClr val="475569"/>
-                </a:solidFill>
-              </a:rPr>
-              <a:t>Đối thủ không phải là 'nhiễu ngẫu nhiên' mà là tác nhân có chủ đích, liên tục tìm kiếm các kênh rò rỉ bị mô hình toán học bỏ qua.</a:t>
-            </a:r>
-          </a:p>
-          <a:p>
-            <a:pPr>
-              <a:spcBef>
-                <a:spcPts val="800"/>
-              </a:spcBef>
-            </a:pPr>
-            <a:r>
-              <a:rPr b="1" sz="1100">
-                <a:solidFill>
-                  <a:srgbClr val="1E293B"/>
-                </a:solidFill>
-              </a:rPr>
-              <a:t>• Chương trình nghiên cứu mở: </a:t>
-            </a:r>
-            <a:r>
-              <a:rPr sz="1050">
-                <a:solidFill>
-                  <a:srgbClr val="475569"/>
-                </a:solidFill>
-              </a:rPr>
-              <a:t>Halpin đặt nền móng triết học và vạch ra 4 câu hỏi nghiên cứu liên ngành nhằm mở rộng mật mã học thành một khoa học an ninh hoàn chỉnh.</a:t>
-            </a:r>
-          </a:p>
-        </p:txBody>
-      </p:sp>
-      <p:sp>
-        <p:nvSpPr>
-          <p:cNvPr id="8" name="Rounded Rectangle 7"/>
-          <p:cNvSpPr/>
-          <p:nvPr/>
-        </p:nvSpPr>
-        <p:spPr>
-          <a:xfrm>
-            <a:off x="6217920" y="1691640"/>
-            <a:ext cx="5212080" cy="4206240"/>
-          </a:xfrm>
-          <a:prstGeom prst="roundRect">
-            <a:avLst/>
-          </a:prstGeom>
-          <a:solidFill>
-            <a:srgbClr val="ECFDF5"/>
-          </a:solidFill>
-          <a:ln>
-            <a:solidFill>
-              <a:srgbClr val="A7F3D0"/>
-            </a:solidFill>
-          </a:ln>
-        </p:spPr>
-        <p:style>
-          <a:lnRef idx="1">
-            <a:schemeClr val="accent1"/>
-          </a:lnRef>
-          <a:fillRef idx="3">
-            <a:schemeClr val="accent1"/>
-          </a:fillRef>
-          <a:effectRef idx="2">
-            <a:schemeClr val="accent1"/>
-          </a:effectRef>
-          <a:fontRef idx="minor">
-            <a:schemeClr val="lt1"/>
-          </a:fontRef>
-        </p:style>
-        <p:txBody>
-          <a:bodyPr rtlCol="0" anchor="ctr"/>
-          <a:lstStyle/>
-          <a:p>
-            <a:pPr algn="ctr"/>
-          </a:p>
-        </p:txBody>
-      </p:sp>
-      <p:sp>
-        <p:nvSpPr>
-          <p:cNvPr id="9" name="TextBox 8"/>
-          <p:cNvSpPr txBox="1"/>
-          <p:nvPr/>
-        </p:nvSpPr>
-        <p:spPr>
-          <a:xfrm>
-            <a:off x="6400800" y="1828800"/>
-            <a:ext cx="4846320" cy="3931920"/>
-          </a:xfrm>
-          <a:prstGeom prst="rect">
-            <a:avLst/>
-          </a:prstGeom>
-          <a:noFill/>
-        </p:spPr>
-        <p:txBody>
-          <a:bodyPr wrap="square">
-            <a:spAutoFit/>
-          </a:bodyPr>
-          <a:lstStyle/>
-          <a:p>
-            <a:pPr>
-              <a:defRPr sz="1300" b="1">
-                <a:solidFill>
-                  <a:srgbClr val="059669"/>
-                </a:solidFill>
-              </a:defRPr>
-            </a:pPr>
-            <a:r>
-              <a:t>2. Hoàn Thành Giữa Kỳ &amp; Lộ Trình Cuối Kỳ (Nhóm DT005)</a:t>
-            </a:r>
-          </a:p>
-          <a:p>
-            <a:pPr>
-              <a:spcBef>
-                <a:spcPts val="800"/>
-              </a:spcBef>
-            </a:pPr>
-            <a:r>
-              <a:rPr b="1" sz="1100">
-                <a:solidFill>
-                  <a:srgbClr val="1E293B"/>
-                </a:solidFill>
-              </a:rPr>
-              <a:t>• Nghiệm thu tiến độ giữa kỳ: </a:t>
-            </a:r>
-            <a:r>
-              <a:rPr sz="1050">
-                <a:solidFill>
-                  <a:srgbClr val="475569"/>
-                </a:solidFill>
-              </a:rPr>
-              <a:t>Hoàn thành thẩm định học thuật sâu sắc toàn văn bài báo gốc (17 trang PDF), phân tích đầy đủ 7 mục nội dung và làm rõ khoảng cách giữa lý thuyết trừu tượng với an ninh thực tế.</a:t>
-            </a:r>
-          </a:p>
-          <a:p>
-            <a:pPr>
-              <a:spcBef>
-                <a:spcPts val="800"/>
-              </a:spcBef>
-            </a:pPr>
-            <a:r>
-              <a:rPr b="1" sz="1100">
-                <a:solidFill>
-                  <a:srgbClr val="1E293B"/>
-                </a:solidFill>
-              </a:rPr>
-              <a:t>• Minh bạch phương pháp luận: </a:t>
-            </a:r>
-            <a:r>
-              <a:rPr sz="1050">
-                <a:solidFill>
-                  <a:srgbClr val="475569"/>
-                </a:solidFill>
-              </a:rPr>
-              <a:t>Không ngụy tạo số liệu tác giả; phân định rõ ràng giữa công trình khảo cứu triết học của Halpin và các kịch bản thực nghiệm minh họa độc lập do sinh viên tự xây dựng.</a:t>
-            </a:r>
-          </a:p>
-          <a:p>
-            <a:pPr>
-              <a:spcBef>
-                <a:spcPts val="800"/>
-              </a:spcBef>
-            </a:pPr>
-            <a:r>
-              <a:rPr b="1" sz="1100">
-                <a:solidFill>
-                  <a:srgbClr val="1E293B"/>
-                </a:solidFill>
-              </a:rPr>
-              <a:t>• Định hướng nghiên cứu cuối kỳ: </a:t>
-            </a:r>
-            <a:r>
-              <a:rPr sz="1050">
-                <a:solidFill>
-                  <a:srgbClr val="475569"/>
-                </a:solidFill>
-              </a:rPr>
-              <a:t>Tiếp tục nghiên cứu và hoàn thiện mô hình cấu trúc cây phân cấp tối ưu cho bài toán kiểm tra toàn vẹn dữ liệu, tiến hành đo đạc và đánh giá thực nghiệm toàn diện.</a:t>
-            </a:r>
-          </a:p>
-        </p:txBody>
-      </p:sp>
-      <p:sp>
-        <p:nvSpPr>
-          <p:cNvPr id="10" name="TextBox 9"/>
-          <p:cNvSpPr txBox="1"/>
-          <p:nvPr/>
-        </p:nvSpPr>
-        <p:spPr>
-          <a:xfrm>
-            <a:off x="731520" y="6035040"/>
-            <a:ext cx="10698480" cy="502920"/>
-          </a:xfrm>
-          <a:prstGeom prst="rect">
-            <a:avLst/>
-          </a:prstGeom>
-          <a:noFill/>
-        </p:spPr>
-        <p:txBody>
-          <a:bodyPr wrap="none">
-            <a:spAutoFit/>
-          </a:bodyPr>
-          <a:lstStyle/>
-          <a:p>
-            <a:pPr>
-              <a:defRPr sz="950" i="1">
-                <a:solidFill>
-                  <a:srgbClr val="64748B"/>
-                </a:solidFill>
-              </a:defRPr>
-            </a:pPr>
-            <a:r>
-              <a:t>Tài liệu tham khảo chính: Halpin (2025), Shannon (1949), Goldwasser-Micali (1984), Dolev-Yao (1983), Kocher (1996), RFC 6962.</a:t>
-            </a:r>
-          </a:p>
-        </p:txBody>
-      </p:sp>
-    </p:spTree>
-  </p:cSld>
-  <p:clrMapOvr>
-    <a:masterClrMapping/>
-  </p:clrMapOvr>
-</p:sld>
-</file>
-
-<file path=ppt/slides/slide15.xml><?xml version="1.0" encoding="utf-8"?>
 <p:sld xmlns:a="http://schemas.openxmlformats.org/drawingml/2006/main" xmlns:p="http://schemas.openxmlformats.org/presentationml/2006/main" xmlns:r="http://schemas.openxmlformats.org/officeDocument/2006/relationships">
   <p:cSld>
     <p:spTree>

</xml_diff>

<commit_message>
Streamline slide 12 table text, attach speaking expansions directly to slide bullets, and make slide 10 script read directly into the architecture diagram
</commit_message>
<xml_diff>
--- a/Bao_Cao_Giua_Ky_DT05_Final.pptx
+++ b/Bao_Cao_Giua_Ky_DT05_Final.pptx
@@ -4184,7 +4184,7 @@
                         </a:defRPr>
                       </a:pPr>
                       <a:r>
-                        <a:t>Coi thông tin là xác suất thống kê; kênh truyền chỉ chịu nhiễu ngẫu nhiên; an toàn tuyệt đối là One-Time Pad.</a:t>
+                        <a:t>Thông tin là xác suất thống kê; giả định kênh chỉ có nhiễu ngẫu nhiên.</a:t>
                       </a:r>
                     </a:p>
                   </a:txBody>
@@ -4207,7 +4207,7 @@
                         </a:defRPr>
                       </a:pPr>
                       <a:r>
-                        <a:t>Thông tin mang ngữ nghĩa khách quan (Dretske); đối thủ là tác nhân có chủ đích, liên tục tìm cách khai thác.</a:t>
+                        <a:t>Thông tin có ngữ nghĩa khách quan (Dretske); đối thủ là tác nhân có chủ đích.</a:t>
                       </a:r>
                     </a:p>
                   </a:txBody>
@@ -4230,7 +4230,7 @@
                         </a:defRPr>
                       </a:pPr>
                       <a:r>
-                        <a:t>Phân định rạch ròi giữa bắt lỗi ngẫu nhiên và an ninh đối kháng; mã tuyến tính (CRC32) không thể thay thế hàm băm phi tuyến (SHA-256).</a:t>
+                        <a:t>Mã tuyến tính (CRC32) chỉ bắt nhiễu; an ninh đối kháng cần hàm băm phi tuyến (SHA-256).</a:t>
                       </a:r>
                     </a:p>
                   </a:txBody>
@@ -4282,7 +4282,7 @@
                         </a:defRPr>
                       </a:pPr>
                       <a:r>
-                        <a:t>Coi thuật toán mật mã là hộp đen toán học lý tưởng; thời gian và phần cứng thực thi là vô hình.</a:t>
+                        <a:t>Coi mật mã là hộp đen toán học lý tưởng; coi thời gian thực thi là vô hình.</a:t>
                       </a:r>
                     </a:p>
                   </a:txBody>
@@ -4305,7 +4305,7 @@
                         </a:defRPr>
                       </a:pPr>
                       <a:r>
-                        <a:t>Sự trừu tượng hóa làm mật mã học mù quáng trước thế giới vật lý: bỏ qua thời gian CPU, năng lượng, lỗi cài đặt.</a:t>
+                        <a:t>Điểm mù vật lý: bỏ qua thời gian CPU, năng lượng, kiến trúc bộ nhớ cache.</a:t>
                       </a:r>
                     </a:p>
                   </a:txBody>
@@ -4328,7 +4328,7 @@
                         </a:defRPr>
                       </a:pPr>
                       <a:r>
-                        <a:t>Xây dựng hệ thống an toàn đa tầng; áp dụng hàm so sánh thời gian hằng số (hmac.compare_digest) triệt tiêu rò rỉ kênh kề.</a:t>
+                        <a:t>Phòng thủ đa tầng; dùng hàm thời gian hằng số (hmac.compare_digest) triệt tiêu kênh kề.</a:t>
                       </a:r>
                     </a:p>
                   </a:txBody>
@@ -4380,7 +4380,7 @@
                         </a:defRPr>
                       </a:pPr>
                       <a:r>
-                        <a:t>Đối thủ bị giới hạn trong năng lực tính toán đa thức (PPT) hoặc tấn công vào đường truyền (Dolev-Yao).</a:t>
+                        <a:t>Đối thủ bị giới hạn toán học (PPT) hoặc tấn công kênh truyền sạch (Dolev-Yao).</a:t>
                       </a:r>
                     </a:p>
                   </a:txBody>
@@ -4403,7 +4403,7 @@
                         </a:defRPr>
                       </a:pPr>
                       <a:r>
-                        <a:t>Snowden tiết lộ đối thủ thể chế (NSA) có nguồn lực khổng lồ: khai thác siêu dữ liệu, cài cửa sau chuẩn NIST.</a:t>
+                        <a:t>Đối thủ thể chế (NSA): khai thác siêu dữ liệu, cài cửa sau chuẩn NIST (Dual_EC).</a:t>
                       </a:r>
                     </a:p>
                   </a:txBody>
@@ -4426,7 +4426,7 @@
                         </a:defRPr>
                       </a:pPr>
                       <a:r>
-                        <a:t>Mở rộng nghiên cứu mật mã chống cửa sau (Cliptography); bảo vệ siêu dữ liệu và cấu trúc dữ liệu minh bạch (RFC 6962).</a:t>
+                        <a:t>Nghiên cứu mật mã chống cửa sau (Cliptography) và phân tách miền (RFC 6962).</a:t>
                       </a:r>
                     </a:p>
                   </a:txBody>
@@ -4478,7 +4478,7 @@
                         </a:defRPr>
                       </a:pPr>
                       <a:r>
-                        <a:t>Mật mã học là phân nhánh độc lập thuần túy của toán học rời rạc và khoa học máy tính lý thuyết.</a:t>
+                        <a:t>Mật mã học chỉ là phân nhánh của toán học rời rạc và lý thuyết tính toán.</a:t>
                       </a:r>
                     </a:p>
                   </a:txBody>
@@ -4501,7 +4501,7 @@
                         </a:defRPr>
                       </a:pPr>
                       <a:r>
-                        <a:t>Đặt ra 4 câu hỏi mở: tích hợp phương pháp liên ngành, dùng thống kê lượng hóa đối thủ, mô hình hóa hệ thống phức hợp.</a:t>
+                        <a:t>4 câu hỏi mở: dùng thống kê lượng hóa đối thủ, mô hình hóa mạng xã hội động.</a:t>
                       </a:r>
                     </a:p>
                   </a:txBody>
@@ -4524,7 +4524,7 @@
                         </a:defRPr>
                       </a:pPr>
                       <a:r>
-                        <a:t>Kết hợp toán học với triết học nhận thức và dữ liệu thực nghiệm để xây dựng một khoa học an ninh hoàn chỉnh.</a:t>
+                        <a:t>Kết hợp toán học, triết học nhận thức và dữ liệu thực nghiệm thành khoa học an ninh.</a:t>
                       </a:r>
                     </a:p>
                   </a:txBody>

</xml_diff>